<commit_message>
fix: update STAMPED story and project links
Link the poster PR, supplied Zenodo study record, and next research repo.
Describe the iterative four-condition research workshop and distinguish
its intended improvements from established findings. Refresh the speaker
notes, browser presentation, PowerPoint, and PDF downloads.

Co-Authored-By: Codex Desktop 26.1007.71326 (runtime codex-cli 0.162.0-alpha.17.2) / gpt-6-astra <codex@openai.com>
Codex-Reasoning-Effort: medium
</commit_message>
<xml_diff>
--- a/downloads/ai-and-ales.pptx
+++ b/downloads/ai-and-ales.pptx
@@ -2,19 +2,19 @@
 <file path=ppt/presentation.xml><?xml version="1.0" encoding="utf-8"?>
 <p:presentation xmlns:p="http://schemas.openxmlformats.org/presentationml/2006/main">
   <p:sldMasterIdLst>
-    <p:sldMasterId xmlns:r="http://schemas.openxmlformats.org/officeDocument/2006/relationships" id="2147483648" r:id="R7dba8d3be46c4767"/>
+    <p:sldMasterId xmlns:r="http://schemas.openxmlformats.org/officeDocument/2006/relationships" id="2147483648" r:id="Rc35e5cf0190b4952"/>
   </p:sldMasterIdLst>
   <p:notesMasterIdLst>
-    <p:notesMasterId xmlns:r="http://schemas.openxmlformats.org/officeDocument/2006/relationships" r:id="R7bbe29f2c1524408"/>
+    <p:notesMasterId xmlns:r="http://schemas.openxmlformats.org/officeDocument/2006/relationships" r:id="Re717b334248c4fc3"/>
   </p:notesMasterIdLst>
   <p:sldIdLst>
-    <p:sldId xmlns:r="http://schemas.openxmlformats.org/officeDocument/2006/relationships" id="256" r:id="R1032e381b1cc453b"/>
-    <p:sldId xmlns:r="http://schemas.openxmlformats.org/officeDocument/2006/relationships" id="257" r:id="R7ca3a0b1d1b24cc5"/>
-    <p:sldId xmlns:r="http://schemas.openxmlformats.org/officeDocument/2006/relationships" id="258" r:id="R19a848207e3545ac"/>
-    <p:sldId xmlns:r="http://schemas.openxmlformats.org/officeDocument/2006/relationships" id="259" r:id="R9b5ade4305c14bdb"/>
-    <p:sldId xmlns:r="http://schemas.openxmlformats.org/officeDocument/2006/relationships" id="260" r:id="R4b3516318dfa4ba6"/>
-    <p:sldId xmlns:r="http://schemas.openxmlformats.org/officeDocument/2006/relationships" id="261" r:id="R91ad1458e0b74ed0"/>
-    <p:sldId xmlns:r="http://schemas.openxmlformats.org/officeDocument/2006/relationships" id="262" r:id="Raa98052480644d96"/>
+    <p:sldId xmlns:r="http://schemas.openxmlformats.org/officeDocument/2006/relationships" id="256" r:id="R749d523e7458473a"/>
+    <p:sldId xmlns:r="http://schemas.openxmlformats.org/officeDocument/2006/relationships" id="257" r:id="R2dfbae2ffeed45ac"/>
+    <p:sldId xmlns:r="http://schemas.openxmlformats.org/officeDocument/2006/relationships" id="258" r:id="R3a8f793a2f3048be"/>
+    <p:sldId xmlns:r="http://schemas.openxmlformats.org/officeDocument/2006/relationships" id="259" r:id="R873e9ae212904b29"/>
+    <p:sldId xmlns:r="http://schemas.openxmlformats.org/officeDocument/2006/relationships" id="260" r:id="R07fb07e4c79c4bca"/>
+    <p:sldId xmlns:r="http://schemas.openxmlformats.org/officeDocument/2006/relationships" id="261" r:id="R4fa7c3cb80444cb9"/>
+    <p:sldId xmlns:r="http://schemas.openxmlformats.org/officeDocument/2006/relationships" id="262" r:id="R47d14dedea39418d"/>
   </p:sldIdLst>
   <p:sldSz cx="12192000" cy="6858000"/>
   <p:notesSz cx="6858000" cy="9144000"/>
@@ -973,7 +973,7 @@
           </a:p>
           <a:p xmlns:a="http://schemas.openxmlformats.org/drawingml/2006/main">
             <a:r>
-              <a:t>The STAMPED in Practice poster asks whether reusable skills help an agent leave better research evidence. We compared three paired tasks using public mixed-gambles task data. One attempt in each pair had additional STAMPED skills. All six attempts matched the checks on the actual data and passed fresh scientific command replay. The skills-assisted attempts took longer and added explicit research records. But one of them failed two required missing-value screening cases. Those tokens weren't present in the actual dataset, so a successful replay didn't expose the defect. We retained that failure. These are three small, unblinded comparisons with shared infrastructure and agent assessments, not proof that skills work generally. And this is the public-data replacement for an earlier ABCD proposal, not an ABCD reproduction. For me the useful part is having evidence that lets us ask a more precise question than 'Did the agent finish?'</a:t>
+              <a:t>The Zenodo record describes the original STAMPED in Practice proposal. The current poster PR captures the later public-data pilot, with working analyses and concrete failures to learn from. The next repository develops a repeated improvement process. Independent agents tackle the same scientific question under four kinds of assistance: baseline, general skill discovery, reproducibility-focused discovery, and explicit STAMPED skills. Independent judges assess scientific quality separately from how well the research object supports inspection and reuse. We then improve the skills and try again, keeping assessment fixed within a formal comparison. NARPS preparation pilots are already exposing useful problems. The hypothesis is that detailed STAMPED guidance improves performance and reduces inconsistent outcomes. The goal is transfer: a researcher brings their own data and hypothesis, and an independent agent can use these skills to do rigorous, convenient research. That improvement remains to be tested.</a:t>
             </a:r>
           </a:p>
           <a:p xmlns:a="http://schemas.openxmlformats.org/drawingml/2006/main">
@@ -988,12 +988,22 @@
           </a:p>
           <a:p xmlns:a="http://schemas.openxmlformats.org/drawingml/2006/main">
             <a:r>
-              <a:t>https://github.com/leej3/stamped-ai-research/blob/codex/stamped-poster-study/research/REPORT.md</a:t>
-            </a:r>
-          </a:p>
-          <a:p xmlns:a="http://schemas.openxmlformats.org/drawingml/2006/main">
-            <a:r>
-              <a:t>https://github.com/con/talks/tree/codex/stamped-usrse-poster/2026-usrse/stamped-ai-study</a:t>
+              <a:t>https://github.com/con/talks/pull/35</a:t>
+            </a:r>
+          </a:p>
+          <a:p xmlns:a="http://schemas.openxmlformats.org/drawingml/2006/main">
+            <a:r>
+              <a:t>https://zenodo.org/records/22833916</a:t>
+            </a:r>
+          </a:p>
+          <a:p xmlns:a="http://schemas.openxmlformats.org/drawingml/2006/main">
+            <a:r>
+              <a:t>https://github.com/leej3/stamped-ai-research-next</a:t>
+            </a:r>
+          </a:p>
+          <a:p xmlns:a="http://schemas.openxmlformats.org/drawingml/2006/main">
+            <a:r>
+              <a:t>https://github.com/leej3/stamped-ai-research-next/pull/3</a:t>
             </a:r>
           </a:p>
         </p:txBody>
@@ -1135,7 +1145,7 @@
           <p:cNvPr id="3" name="Title">
             <a:extLst xmlns:a="http://schemas.openxmlformats.org/drawingml/2006/main">
               <a:ext uri="{FF2B5EF4-FFF2-40B4-BE49-F238E27FC236}">
-                <a16:creationId xmlns:a16="http://schemas.microsoft.com/office/drawing/2014/main" id="{7BB49B1B-5D09-4865-86FA-625B077D7214}"/>
+                <a16:creationId xmlns:a16="http://schemas.microsoft.com/office/drawing/2014/main" id="{5ECE8D01-FB4C-4D9C-B704-A3837453582F}"/>
               </a:ext>
             </a:extLst>
           </p:cNvPr>
@@ -1292,7 +1302,7 @@
           <p:cNvPr id="2" name="Subtitle">
             <a:extLst xmlns:a="http://schemas.openxmlformats.org/drawingml/2006/main">
               <a:ext uri="{FF2B5EF4-FFF2-40B4-BE49-F238E27FC236}">
-                <a16:creationId xmlns:a16="http://schemas.microsoft.com/office/drawing/2014/main" id="{EE5BCFE7-2447-427C-A796-DBD7282BA6E3}"/>
+                <a16:creationId xmlns:a16="http://schemas.microsoft.com/office/drawing/2014/main" id="{4806A889-460C-46BB-8177-4426DF3F9C4B}"/>
               </a:ext>
             </a:extLst>
           </p:cNvPr>
@@ -1466,7 +1476,7 @@
           <p:cNvPr id="2" name="Section title">
             <a:extLst xmlns:a="http://schemas.openxmlformats.org/drawingml/2006/main">
               <a:ext uri="{FF2B5EF4-FFF2-40B4-BE49-F238E27FC236}">
-                <a16:creationId xmlns:a16="http://schemas.microsoft.com/office/drawing/2014/main" id="{2D97A4DD-1E2E-4179-A92C-90D34D69C95E}"/>
+                <a16:creationId xmlns:a16="http://schemas.microsoft.com/office/drawing/2014/main" id="{A16E0ED1-41E4-47CB-82A9-0AC96ED452F7}"/>
               </a:ext>
             </a:extLst>
           </p:cNvPr>
@@ -1640,7 +1650,7 @@
           <p:cNvPr id="3" name="Title">
             <a:extLst xmlns:a="http://schemas.openxmlformats.org/drawingml/2006/main">
               <a:ext uri="{FF2B5EF4-FFF2-40B4-BE49-F238E27FC236}">
-                <a16:creationId xmlns:a16="http://schemas.microsoft.com/office/drawing/2014/main" id="{02A67DA0-B5EB-42EB-9175-D25CF1D46A06}"/>
+                <a16:creationId xmlns:a16="http://schemas.microsoft.com/office/drawing/2014/main" id="{C4DE3FC7-49F9-406B-91D8-3F77D8F755E9}"/>
               </a:ext>
             </a:extLst>
           </p:cNvPr>
@@ -1797,7 +1807,7 @@
           <p:cNvPr id="2" name="Body">
             <a:extLst xmlns:a="http://schemas.openxmlformats.org/drawingml/2006/main">
               <a:ext uri="{FF2B5EF4-FFF2-40B4-BE49-F238E27FC236}">
-                <a16:creationId xmlns:a16="http://schemas.microsoft.com/office/drawing/2014/main" id="{C196C2EC-94DF-4C67-BDEF-CC924048A10A}"/>
+                <a16:creationId xmlns:a16="http://schemas.microsoft.com/office/drawing/2014/main" id="{9BCEBBCF-5B52-4E79-A2D7-D73A1EEAC9F5}"/>
               </a:ext>
             </a:extLst>
           </p:cNvPr>
@@ -1971,7 +1981,7 @@
           <p:cNvPr id="4" name="Title">
             <a:extLst xmlns:a="http://schemas.openxmlformats.org/drawingml/2006/main">
               <a:ext uri="{FF2B5EF4-FFF2-40B4-BE49-F238E27FC236}">
-                <a16:creationId xmlns:a16="http://schemas.microsoft.com/office/drawing/2014/main" id="{FDBCE098-66D5-41BA-943F-FA510397E851}"/>
+                <a16:creationId xmlns:a16="http://schemas.microsoft.com/office/drawing/2014/main" id="{F649052D-577D-4D42-BD86-59F9E93A56CE}"/>
               </a:ext>
             </a:extLst>
           </p:cNvPr>
@@ -2128,7 +2138,7 @@
           <p:cNvPr id="2" name="Left column">
             <a:extLst xmlns:a="http://schemas.openxmlformats.org/drawingml/2006/main">
               <a:ext uri="{FF2B5EF4-FFF2-40B4-BE49-F238E27FC236}">
-                <a16:creationId xmlns:a16="http://schemas.microsoft.com/office/drawing/2014/main" id="{3B8627F7-59E8-423A-BF84-D32D2A9AF2BE}"/>
+                <a16:creationId xmlns:a16="http://schemas.microsoft.com/office/drawing/2014/main" id="{00BA8127-20FD-4BD1-A777-EA0A0474EB78}"/>
               </a:ext>
             </a:extLst>
           </p:cNvPr>
@@ -2285,7 +2295,7 @@
           <p:cNvPr id="3" name="Right column">
             <a:extLst xmlns:a="http://schemas.openxmlformats.org/drawingml/2006/main">
               <a:ext uri="{FF2B5EF4-FFF2-40B4-BE49-F238E27FC236}">
-                <a16:creationId xmlns:a16="http://schemas.microsoft.com/office/drawing/2014/main" id="{7E5C1F17-8808-470B-8AE0-C623696582BA}"/>
+                <a16:creationId xmlns:a16="http://schemas.microsoft.com/office/drawing/2014/main" id="{3EFFBCCD-F472-4D35-A089-6A2C38365833}"/>
               </a:ext>
             </a:extLst>
           </p:cNvPr>
@@ -2459,7 +2469,7 @@
           <p:cNvPr id="3" name="Title">
             <a:extLst xmlns:a="http://schemas.openxmlformats.org/drawingml/2006/main">
               <a:ext uri="{FF2B5EF4-FFF2-40B4-BE49-F238E27FC236}">
-                <a16:creationId xmlns:a16="http://schemas.microsoft.com/office/drawing/2014/main" id="{0522764E-992E-4250-AC88-C44AD094C623}"/>
+                <a16:creationId xmlns:a16="http://schemas.microsoft.com/office/drawing/2014/main" id="{AFEBE894-459E-47D3-ADC6-4B7C7DB1E6E2}"/>
               </a:ext>
             </a:extLst>
           </p:cNvPr>
@@ -2616,7 +2626,7 @@
           <p:cNvPr id="2" name="Left column">
             <a:extLst xmlns:a="http://schemas.openxmlformats.org/drawingml/2006/main">
               <a:ext uri="{FF2B5EF4-FFF2-40B4-BE49-F238E27FC236}">
-                <a16:creationId xmlns:a16="http://schemas.microsoft.com/office/drawing/2014/main" id="{5DB27DB9-D85C-44E0-A265-1B40BA4AAC7D}"/>
+                <a16:creationId xmlns:a16="http://schemas.microsoft.com/office/drawing/2014/main" id="{1C76E4EE-96E6-4B9D-AF74-1C696BCF46ED}"/>
               </a:ext>
             </a:extLst>
           </p:cNvPr>
@@ -2811,12 +2821,12 @@
   </p:cSld>
   <p:clrMap bg1="lt1" tx1="dk1" bg2="lt2" tx2="dk2" accent1="accent1" accent2="accent2" accent3="accent3" accent4="accent4" accent5="accent5" accent6="accent6" hlink="hlink" folHlink="folHlink"/>
   <p:sldLayoutIdLst>
-    <p:sldLayoutId xmlns:r="http://schemas.openxmlformats.org/officeDocument/2006/relationships" id="2147483649" r:id="R293146fe7b3b49be"/>
-    <p:sldLayoutId xmlns:r="http://schemas.openxmlformats.org/officeDocument/2006/relationships" id="2147483650" r:id="R867ee3353b6b46c1"/>
-    <p:sldLayoutId xmlns:r="http://schemas.openxmlformats.org/officeDocument/2006/relationships" id="2147483651" r:id="R44d94a3b301441aa"/>
-    <p:sldLayoutId xmlns:r="http://schemas.openxmlformats.org/officeDocument/2006/relationships" id="2147483652" r:id="R7c3882db62fa4bde"/>
-    <p:sldLayoutId xmlns:r="http://schemas.openxmlformats.org/officeDocument/2006/relationships" id="2147483653" r:id="Rda42b18d8f9b4db7"/>
-    <p:sldLayoutId xmlns:r="http://schemas.openxmlformats.org/officeDocument/2006/relationships" id="2147483654" r:id="R8572031ac58b40c6"/>
+    <p:sldLayoutId xmlns:r="http://schemas.openxmlformats.org/officeDocument/2006/relationships" id="2147483649" r:id="Rf403ba8ca94347fd"/>
+    <p:sldLayoutId xmlns:r="http://schemas.openxmlformats.org/officeDocument/2006/relationships" id="2147483650" r:id="Re022c7244d79476a"/>
+    <p:sldLayoutId xmlns:r="http://schemas.openxmlformats.org/officeDocument/2006/relationships" id="2147483651" r:id="R54c9351805a94bdc"/>
+    <p:sldLayoutId xmlns:r="http://schemas.openxmlformats.org/officeDocument/2006/relationships" id="2147483652" r:id="Rfc5c57888a714361"/>
+    <p:sldLayoutId xmlns:r="http://schemas.openxmlformats.org/officeDocument/2006/relationships" id="2147483653" r:id="R2f56d0f86ca04b16"/>
+    <p:sldLayoutId xmlns:r="http://schemas.openxmlformats.org/officeDocument/2006/relationships" id="2147483654" r:id="R29e3a51d257c4342"/>
   </p:sldLayoutIdLst>
   <p:txStyles>
     <p:titleStyle>
@@ -3367,7 +3377,7 @@
           <p:cNvPr id="6" name="">
             <a:extLst xmlns:a="http://schemas.openxmlformats.org/drawingml/2006/main">
               <a:ext uri="{FF2B5EF4-FFF2-40B4-BE49-F238E27FC236}">
-                <a16:creationId xmlns:a16="http://schemas.microsoft.com/office/drawing/2014/main" id="{8860C90D-582F-47CA-9633-D9ABF0C4177A}"/>
+                <a16:creationId xmlns:a16="http://schemas.microsoft.com/office/drawing/2014/main" id="{B9B93178-11BE-421C-BDF7-5E746B75AEB7}"/>
               </a:ext>
             </a:extLst>
           </p:cNvPr>
@@ -3456,7 +3466,7 @@
           <p:cNvPr id="2" name="">
             <a:extLst xmlns:a="http://schemas.openxmlformats.org/drawingml/2006/main">
               <a:ext uri="{FF2B5EF4-FFF2-40B4-BE49-F238E27FC236}">
-                <a16:creationId xmlns:a16="http://schemas.microsoft.com/office/drawing/2014/main" id="{1E8892CA-0381-4E88-B150-D5D614E7015A}"/>
+                <a16:creationId xmlns:a16="http://schemas.microsoft.com/office/drawing/2014/main" id="{504FEA83-5323-4ED2-9921-75B9C9F08FB7}"/>
               </a:ext>
             </a:extLst>
           </p:cNvPr>
@@ -3545,7 +3555,7 @@
           <p:cNvPr id="3" name="">
             <a:extLst xmlns:a="http://schemas.openxmlformats.org/drawingml/2006/main">
               <a:ext uri="{FF2B5EF4-FFF2-40B4-BE49-F238E27FC236}">
-                <a16:creationId xmlns:a16="http://schemas.microsoft.com/office/drawing/2014/main" id="{274676BB-5EA2-4259-8EF2-017C04826464}"/>
+                <a16:creationId xmlns:a16="http://schemas.microsoft.com/office/drawing/2014/main" id="{50686B55-436A-4470-B2B2-98B829178561}"/>
               </a:ext>
             </a:extLst>
           </p:cNvPr>
@@ -3611,7 +3621,7 @@
           <p:cNvPr id="4" name="">
             <a:extLst xmlns:a="http://schemas.openxmlformats.org/drawingml/2006/main">
               <a:ext uri="{FF2B5EF4-FFF2-40B4-BE49-F238E27FC236}">
-                <a16:creationId xmlns:a16="http://schemas.microsoft.com/office/drawing/2014/main" id="{ECA5173E-BEEF-4394-B8DC-0AF923FADEEE}"/>
+                <a16:creationId xmlns:a16="http://schemas.microsoft.com/office/drawing/2014/main" id="{A6451C44-E404-4414-A73C-207503B50DA0}"/>
               </a:ext>
             </a:extLst>
           </p:cNvPr>
@@ -3700,7 +3710,7 @@
           <p:cNvPr id="5" name="">
             <a:extLst xmlns:a="http://schemas.openxmlformats.org/drawingml/2006/main">
               <a:ext uri="{FF2B5EF4-FFF2-40B4-BE49-F238E27FC236}">
-                <a16:creationId xmlns:a16="http://schemas.microsoft.com/office/drawing/2014/main" id="{74369023-725D-4E53-A491-04C547774D07}"/>
+                <a16:creationId xmlns:a16="http://schemas.microsoft.com/office/drawing/2014/main" id="{5D331664-C019-4CED-887A-CB51C89BEECF}"/>
               </a:ext>
             </a:extLst>
           </p:cNvPr>
@@ -3710,7 +3720,7 @@
           <p:nvPr/>
         </p:nvPicPr>
         <p:blipFill>
-          <a:blip xmlns:r="http://schemas.openxmlformats.org/officeDocument/2006/relationships" xmlns:a="http://schemas.openxmlformats.org/drawingml/2006/main" r:embed="R0092fa24df824b23"/>
+          <a:blip xmlns:r="http://schemas.openxmlformats.org/officeDocument/2006/relationships" xmlns:a="http://schemas.openxmlformats.org/drawingml/2006/main" r:embed="Ra0351631c91e443e"/>
           <a:stretch xmlns:a="http://schemas.openxmlformats.org/drawingml/2006/main"/>
         </p:blipFill>
         <p:spPr>
@@ -3726,7 +3736,7 @@
     </p:spTree>
     <p:extLst>
       <p:ext uri="{BB962C8B-B14F-4D97-AF65-F5344CB8AC3E}">
-        <p14:creationId xmlns:p14="http://schemas.microsoft.com/office/powerpoint/2010/main" val="1167892555"/>
+        <p14:creationId xmlns:p14="http://schemas.microsoft.com/office/powerpoint/2010/main" val="1428541225"/>
       </p:ext>
     </p:extLst>
   </p:cSld>
@@ -3757,7 +3767,7 @@
           <p:cNvPr id="13" name="">
             <a:extLst xmlns:a="http://schemas.openxmlformats.org/drawingml/2006/main">
               <a:ext uri="{FF2B5EF4-FFF2-40B4-BE49-F238E27FC236}">
-                <a16:creationId xmlns:a16="http://schemas.microsoft.com/office/drawing/2014/main" id="{FDFED16D-7337-428B-B3EF-AF46794AA3A3}"/>
+                <a16:creationId xmlns:a16="http://schemas.microsoft.com/office/drawing/2014/main" id="{C9B10118-3D44-4394-954C-0442B24D539B}"/>
               </a:ext>
             </a:extLst>
           </p:cNvPr>
@@ -3823,7 +3833,7 @@
           <p:cNvPr id="2" name="">
             <a:extLst xmlns:a="http://schemas.openxmlformats.org/drawingml/2006/main">
               <a:ext uri="{FF2B5EF4-FFF2-40B4-BE49-F238E27FC236}">
-                <a16:creationId xmlns:a16="http://schemas.microsoft.com/office/drawing/2014/main" id="{C13F3201-0B83-4EB1-A37D-5C31E0A0EE77}"/>
+                <a16:creationId xmlns:a16="http://schemas.microsoft.com/office/drawing/2014/main" id="{4FA4E031-A99A-4AD1-85E4-4C94524DC299}"/>
               </a:ext>
             </a:extLst>
           </p:cNvPr>
@@ -3889,7 +3899,7 @@
           <p:cNvPr id="3" name="">
             <a:extLst xmlns:a="http://schemas.openxmlformats.org/drawingml/2006/main">
               <a:ext uri="{FF2B5EF4-FFF2-40B4-BE49-F238E27FC236}">
-                <a16:creationId xmlns:a16="http://schemas.microsoft.com/office/drawing/2014/main" id="{29EF254F-9D31-4EEA-BEAB-1AAF8ED12092}"/>
+                <a16:creationId xmlns:a16="http://schemas.microsoft.com/office/drawing/2014/main" id="{E2456E1E-2B78-485E-A4FA-449B4B6CE55B}"/>
               </a:ext>
             </a:extLst>
           </p:cNvPr>
@@ -3955,7 +3965,7 @@
           <p:cNvPr id="4" name="">
             <a:extLst xmlns:a="http://schemas.openxmlformats.org/drawingml/2006/main">
               <a:ext uri="{FF2B5EF4-FFF2-40B4-BE49-F238E27FC236}">
-                <a16:creationId xmlns:a16="http://schemas.microsoft.com/office/drawing/2014/main" id="{A092FB1A-9B71-48CB-9DEF-8243A39BD6AD}"/>
+                <a16:creationId xmlns:a16="http://schemas.microsoft.com/office/drawing/2014/main" id="{532FA51B-C550-4923-93BB-656A63EE06DD}"/>
               </a:ext>
             </a:extLst>
           </p:cNvPr>
@@ -4021,7 +4031,7 @@
           <p:cNvPr id="5" name="">
             <a:extLst xmlns:a="http://schemas.openxmlformats.org/drawingml/2006/main">
               <a:ext uri="{FF2B5EF4-FFF2-40B4-BE49-F238E27FC236}">
-                <a16:creationId xmlns:a16="http://schemas.microsoft.com/office/drawing/2014/main" id="{084FDE1F-BE00-461B-99BF-2777343AC0AB}"/>
+                <a16:creationId xmlns:a16="http://schemas.microsoft.com/office/drawing/2014/main" id="{84709F00-937E-42BB-A7F5-D8A3DF4E3FC7}"/>
               </a:ext>
             </a:extLst>
           </p:cNvPr>
@@ -4087,7 +4097,7 @@
           <p:cNvPr id="6" name="">
             <a:extLst xmlns:a="http://schemas.openxmlformats.org/drawingml/2006/main">
               <a:ext uri="{FF2B5EF4-FFF2-40B4-BE49-F238E27FC236}">
-                <a16:creationId xmlns:a16="http://schemas.microsoft.com/office/drawing/2014/main" id="{081C2BC8-0146-48C2-A3B6-8451231E8EAB}"/>
+                <a16:creationId xmlns:a16="http://schemas.microsoft.com/office/drawing/2014/main" id="{F9171061-2637-4701-B020-4BCF2547EEE9}"/>
               </a:ext>
             </a:extLst>
           </p:cNvPr>
@@ -4153,7 +4163,7 @@
           <p:cNvPr id="7" name="">
             <a:extLst xmlns:a="http://schemas.openxmlformats.org/drawingml/2006/main">
               <a:ext uri="{FF2B5EF4-FFF2-40B4-BE49-F238E27FC236}">
-                <a16:creationId xmlns:a16="http://schemas.microsoft.com/office/drawing/2014/main" id="{CC474AF9-C321-4435-B584-73AA02B7C701}"/>
+                <a16:creationId xmlns:a16="http://schemas.microsoft.com/office/drawing/2014/main" id="{32E69005-D082-4613-8ACF-635FE50DB998}"/>
               </a:ext>
             </a:extLst>
           </p:cNvPr>
@@ -4219,7 +4229,7 @@
           <p:cNvPr id="8" name="">
             <a:extLst xmlns:a="http://schemas.openxmlformats.org/drawingml/2006/main">
               <a:ext uri="{FF2B5EF4-FFF2-40B4-BE49-F238E27FC236}">
-                <a16:creationId xmlns:a16="http://schemas.microsoft.com/office/drawing/2014/main" id="{27EEB7B8-BC9D-45E9-B151-81D6E50DA309}"/>
+                <a16:creationId xmlns:a16="http://schemas.microsoft.com/office/drawing/2014/main" id="{157BB6BE-2CC7-4E5C-9F49-26B548D0C3A1}"/>
               </a:ext>
             </a:extLst>
           </p:cNvPr>
@@ -4285,7 +4295,7 @@
           <p:cNvPr id="9" name="">
             <a:extLst xmlns:a="http://schemas.openxmlformats.org/drawingml/2006/main">
               <a:ext uri="{FF2B5EF4-FFF2-40B4-BE49-F238E27FC236}">
-                <a16:creationId xmlns:a16="http://schemas.microsoft.com/office/drawing/2014/main" id="{712E86E7-5F6B-4D8B-A831-D67379B36429}"/>
+                <a16:creationId xmlns:a16="http://schemas.microsoft.com/office/drawing/2014/main" id="{E5A5A45B-AD09-4565-8075-CB194E495234}"/>
               </a:ext>
             </a:extLst>
           </p:cNvPr>
@@ -4351,7 +4361,7 @@
           <p:cNvPr id="10" name="">
             <a:extLst xmlns:a="http://schemas.openxmlformats.org/drawingml/2006/main">
               <a:ext uri="{FF2B5EF4-FFF2-40B4-BE49-F238E27FC236}">
-                <a16:creationId xmlns:a16="http://schemas.microsoft.com/office/drawing/2014/main" id="{2CE5B1D1-A9F4-481A-85B8-928B0C3AB780}"/>
+                <a16:creationId xmlns:a16="http://schemas.microsoft.com/office/drawing/2014/main" id="{578C7BF0-69CF-4747-B882-81A076D81421}"/>
               </a:ext>
             </a:extLst>
           </p:cNvPr>
@@ -4406,7 +4416,7 @@
                 <a:latin typeface="Arial"/>
                 <a:ea typeface="Arial"/>
                 <a:cs typeface="Arial"/>
-                <a:hlinkClick xmlns:r="http://schemas.openxmlformats.org/officeDocument/2006/relationships" r:id="Rf6cc3af3a0514ed1"/>
+                <a:hlinkClick xmlns:r="http://schemas.openxmlformats.org/officeDocument/2006/relationships" r:id="R151c88c289d542f6"/>
               </a:rPr>
               <a:t>My skill workshop</a:t>
             </a:r>
@@ -4418,7 +4428,7 @@
           <p:cNvPr id="11" name="">
             <a:extLst xmlns:a="http://schemas.openxmlformats.org/drawingml/2006/main">
               <a:ext uri="{FF2B5EF4-FFF2-40B4-BE49-F238E27FC236}">
-                <a16:creationId xmlns:a16="http://schemas.microsoft.com/office/drawing/2014/main" id="{01CA0B98-897B-48F7-AE10-01CE786A64D5}"/>
+                <a16:creationId xmlns:a16="http://schemas.microsoft.com/office/drawing/2014/main" id="{29D21805-32B3-4761-A7D5-A698106002DC}"/>
               </a:ext>
             </a:extLst>
           </p:cNvPr>
@@ -4473,7 +4483,7 @@
                 <a:latin typeface="Arial"/>
                 <a:ea typeface="Arial"/>
                 <a:cs typeface="Arial"/>
-                <a:hlinkClick xmlns:r="http://schemas.openxmlformats.org/officeDocument/2006/relationships" r:id="Rb3aa11b45112443c"/>
+                <a:hlinkClick xmlns:r="http://schemas.openxmlformats.org/officeDocument/2006/relationships" r:id="R2893647c9ca0473f"/>
               </a:rPr>
               <a:t>Worktree tools</a:t>
             </a:r>
@@ -4485,7 +4495,7 @@
           <p:cNvPr id="12" name="">
             <a:extLst xmlns:a="http://schemas.openxmlformats.org/drawingml/2006/main">
               <a:ext uri="{FF2B5EF4-FFF2-40B4-BE49-F238E27FC236}">
-                <a16:creationId xmlns:a16="http://schemas.microsoft.com/office/drawing/2014/main" id="{5C6BB209-7549-467D-9C30-CD5D69846B0F}"/>
+                <a16:creationId xmlns:a16="http://schemas.microsoft.com/office/drawing/2014/main" id="{2FB1A14F-9883-4401-9ED3-CC7538E27C9A}"/>
               </a:ext>
             </a:extLst>
           </p:cNvPr>
@@ -4540,7 +4550,7 @@
                 <a:latin typeface="Arial"/>
                 <a:ea typeface="Arial"/>
                 <a:cs typeface="Arial"/>
-                <a:hlinkClick xmlns:r="http://schemas.openxmlformats.org/officeDocument/2006/relationships" r:id="R4f553f6516934ce3"/>
+                <a:hlinkClick xmlns:r="http://schemas.openxmlformats.org/officeDocument/2006/relationships" r:id="Rac718744c8544a7a"/>
               </a:rPr>
               <a:t>Execution records: duct</a:t>
             </a:r>
@@ -4550,7 +4560,7 @@
     </p:spTree>
     <p:extLst>
       <p:ext uri="{BB962C8B-B14F-4D97-AF65-F5344CB8AC3E}">
-        <p14:creationId xmlns:p14="http://schemas.microsoft.com/office/powerpoint/2010/main" val="339666126"/>
+        <p14:creationId xmlns:p14="http://schemas.microsoft.com/office/powerpoint/2010/main" val="1821715278"/>
       </p:ext>
     </p:extLst>
   </p:cSld>
@@ -4581,7 +4591,7 @@
           <p:cNvPr id="7" name="">
             <a:extLst xmlns:a="http://schemas.openxmlformats.org/drawingml/2006/main">
               <a:ext uri="{FF2B5EF4-FFF2-40B4-BE49-F238E27FC236}">
-                <a16:creationId xmlns:a16="http://schemas.microsoft.com/office/drawing/2014/main" id="{32ECE2C0-E808-46DE-976F-6D6FD0D41870}"/>
+                <a16:creationId xmlns:a16="http://schemas.microsoft.com/office/drawing/2014/main" id="{A54EC223-064A-49F7-879E-09008B059138}"/>
               </a:ext>
             </a:extLst>
           </p:cNvPr>
@@ -4647,7 +4657,7 @@
           <p:cNvPr id="2" name="">
             <a:extLst xmlns:a="http://schemas.openxmlformats.org/drawingml/2006/main">
               <a:ext uri="{FF2B5EF4-FFF2-40B4-BE49-F238E27FC236}">
-                <a16:creationId xmlns:a16="http://schemas.microsoft.com/office/drawing/2014/main" id="{B30A5726-C88B-4536-919A-2231798BC69A}"/>
+                <a16:creationId xmlns:a16="http://schemas.microsoft.com/office/drawing/2014/main" id="{456C0086-D942-45EB-86C8-FAD17293976F}"/>
               </a:ext>
             </a:extLst>
           </p:cNvPr>
@@ -4713,7 +4723,7 @@
           <p:cNvPr id="3" name="">
             <a:extLst xmlns:a="http://schemas.openxmlformats.org/drawingml/2006/main">
               <a:ext uri="{FF2B5EF4-FFF2-40B4-BE49-F238E27FC236}">
-                <a16:creationId xmlns:a16="http://schemas.microsoft.com/office/drawing/2014/main" id="{A111C543-4875-4CEE-A01B-7BE7B488F218}"/>
+                <a16:creationId xmlns:a16="http://schemas.microsoft.com/office/drawing/2014/main" id="{A5CAD189-CD07-43B7-829A-9CF010051189}"/>
               </a:ext>
             </a:extLst>
           </p:cNvPr>
@@ -4723,7 +4733,7 @@
           <p:nvPr/>
         </p:nvPicPr>
         <p:blipFill>
-          <a:blip xmlns:r="http://schemas.openxmlformats.org/officeDocument/2006/relationships" xmlns:a="http://schemas.openxmlformats.org/drawingml/2006/main" r:embed="R88af39c16a574953"/>
+          <a:blip xmlns:r="http://schemas.openxmlformats.org/officeDocument/2006/relationships" xmlns:a="http://schemas.openxmlformats.org/drawingml/2006/main" r:embed="R9ab0f64910ab40a1"/>
           <a:stretch xmlns:a="http://schemas.openxmlformats.org/drawingml/2006/main"/>
         </p:blipFill>
         <p:spPr>
@@ -4741,7 +4751,7 @@
           <p:cNvPr id="4" name="">
             <a:extLst xmlns:a="http://schemas.openxmlformats.org/drawingml/2006/main">
               <a:ext uri="{FF2B5EF4-FFF2-40B4-BE49-F238E27FC236}">
-                <a16:creationId xmlns:a16="http://schemas.microsoft.com/office/drawing/2014/main" id="{2F3A6F38-C16E-4D93-9742-AE227C3C2E74}"/>
+                <a16:creationId xmlns:a16="http://schemas.microsoft.com/office/drawing/2014/main" id="{B92CA66D-0F2B-42DE-A9BA-36FF365721C2}"/>
               </a:ext>
             </a:extLst>
           </p:cNvPr>
@@ -4751,7 +4761,7 @@
           <p:nvPr/>
         </p:nvPicPr>
         <p:blipFill>
-          <a:blip xmlns:r="http://schemas.openxmlformats.org/officeDocument/2006/relationships" xmlns:a="http://schemas.openxmlformats.org/drawingml/2006/main" r:embed="Rc5df6e90a2314b71"/>
+          <a:blip xmlns:r="http://schemas.openxmlformats.org/officeDocument/2006/relationships" xmlns:a="http://schemas.openxmlformats.org/drawingml/2006/main" r:embed="R1820c3005ee74efb"/>
           <a:stretch xmlns:a="http://schemas.openxmlformats.org/drawingml/2006/main"/>
         </p:blipFill>
         <p:spPr>
@@ -4769,7 +4779,7 @@
           <p:cNvPr id="5" name="">
             <a:extLst xmlns:a="http://schemas.openxmlformats.org/drawingml/2006/main">
               <a:ext uri="{FF2B5EF4-FFF2-40B4-BE49-F238E27FC236}">
-                <a16:creationId xmlns:a16="http://schemas.microsoft.com/office/drawing/2014/main" id="{C4498E09-4BBD-48CC-AF69-BF1A0C1EB5D4}"/>
+                <a16:creationId xmlns:a16="http://schemas.microsoft.com/office/drawing/2014/main" id="{D18ED21C-36E4-47DE-9E3D-47DF26B46940}"/>
               </a:ext>
             </a:extLst>
           </p:cNvPr>
@@ -4824,7 +4834,7 @@
                 <a:latin typeface="Arial"/>
                 <a:ea typeface="Arial"/>
                 <a:cs typeface="Arial"/>
-                <a:hlinkClick xmlns:r="http://schemas.openxmlformats.org/officeDocument/2006/relationships" r:id="Rb43bb39619294562"/>
+                <a:hlinkClick xmlns:r="http://schemas.openxmlformats.org/officeDocument/2006/relationships" r:id="R928139e28acc4124"/>
               </a:rPr>
               <a:t>Explore the preparation</a:t>
             </a:r>
@@ -4836,7 +4846,7 @@
           <p:cNvPr id="6" name="">
             <a:extLst xmlns:a="http://schemas.openxmlformats.org/drawingml/2006/main">
               <a:ext uri="{FF2B5EF4-FFF2-40B4-BE49-F238E27FC236}">
-                <a16:creationId xmlns:a16="http://schemas.microsoft.com/office/drawing/2014/main" id="{748955C9-6668-4172-B718-E772077AADF2}"/>
+                <a16:creationId xmlns:a16="http://schemas.microsoft.com/office/drawing/2014/main" id="{1CED3C7C-0599-4D99-8E77-548CFE63CF99}"/>
               </a:ext>
             </a:extLst>
           </p:cNvPr>
@@ -4891,7 +4901,7 @@
                 <a:latin typeface="Arial"/>
                 <a:ea typeface="Arial"/>
                 <a:cs typeface="Arial"/>
-                <a:hlinkClick xmlns:r="http://schemas.openxmlformats.org/officeDocument/2006/relationships" r:id="Rbb949fb45ae049c7"/>
+                <a:hlinkClick xmlns:r="http://schemas.openxmlformats.org/officeDocument/2006/relationships" r:id="R9751ee40ddf1401f"/>
               </a:rPr>
               <a:t>Open the presentation</a:t>
             </a:r>
@@ -4901,7 +4911,7 @@
     </p:spTree>
     <p:extLst>
       <p:ext uri="{BB962C8B-B14F-4D97-AF65-F5344CB8AC3E}">
-        <p14:creationId xmlns:p14="http://schemas.microsoft.com/office/powerpoint/2010/main" val="1981894478"/>
+        <p14:creationId xmlns:p14="http://schemas.microsoft.com/office/powerpoint/2010/main" val="998832131"/>
       </p:ext>
     </p:extLst>
   </p:cSld>
@@ -4932,7 +4942,7 @@
           <p:cNvPr id="7" name="">
             <a:extLst xmlns:a="http://schemas.openxmlformats.org/drawingml/2006/main">
               <a:ext uri="{FF2B5EF4-FFF2-40B4-BE49-F238E27FC236}">
-                <a16:creationId xmlns:a16="http://schemas.microsoft.com/office/drawing/2014/main" id="{1A380B79-E65F-43A3-9748-7ECBE8E2338C}"/>
+                <a16:creationId xmlns:a16="http://schemas.microsoft.com/office/drawing/2014/main" id="{A22CD10B-B836-4562-9ABD-3A48D9A332E8}"/>
               </a:ext>
             </a:extLst>
           </p:cNvPr>
@@ -4998,7 +5008,7 @@
           <p:cNvPr id="2" name="">
             <a:extLst xmlns:a="http://schemas.openxmlformats.org/drawingml/2006/main">
               <a:ext uri="{FF2B5EF4-FFF2-40B4-BE49-F238E27FC236}">
-                <a16:creationId xmlns:a16="http://schemas.microsoft.com/office/drawing/2014/main" id="{4BA1B8DC-3186-4A73-896C-E51B858D5618}"/>
+                <a16:creationId xmlns:a16="http://schemas.microsoft.com/office/drawing/2014/main" id="{C22A6579-25FE-425B-ADDB-5A589148141F}"/>
               </a:ext>
             </a:extLst>
           </p:cNvPr>
@@ -5008,7 +5018,7 @@
           <p:nvPr/>
         </p:nvPicPr>
         <p:blipFill>
-          <a:blip xmlns:r="http://schemas.openxmlformats.org/officeDocument/2006/relationships" xmlns:a="http://schemas.openxmlformats.org/drawingml/2006/main" r:embed="R54bde959b0f9410e"/>
+          <a:blip xmlns:r="http://schemas.openxmlformats.org/officeDocument/2006/relationships" xmlns:a="http://schemas.openxmlformats.org/drawingml/2006/main" r:embed="Re2566a1f966d46f7"/>
           <a:stretch xmlns:a="http://schemas.openxmlformats.org/drawingml/2006/main"/>
         </p:blipFill>
         <p:spPr>
@@ -5026,7 +5036,7 @@
           <p:cNvPr id="3" name="">
             <a:extLst xmlns:a="http://schemas.openxmlformats.org/drawingml/2006/main">
               <a:ext uri="{FF2B5EF4-FFF2-40B4-BE49-F238E27FC236}">
-                <a16:creationId xmlns:a16="http://schemas.microsoft.com/office/drawing/2014/main" id="{E1A1A587-189C-40A9-AD23-51BC77E15F56}"/>
+                <a16:creationId xmlns:a16="http://schemas.microsoft.com/office/drawing/2014/main" id="{B07233A0-C0F5-4872-998B-4FEC2EFD6C18}"/>
               </a:ext>
             </a:extLst>
           </p:cNvPr>
@@ -5138,7 +5148,7 @@
           <p:cNvPr id="4" name="">
             <a:extLst xmlns:a="http://schemas.openxmlformats.org/drawingml/2006/main">
               <a:ext uri="{FF2B5EF4-FFF2-40B4-BE49-F238E27FC236}">
-                <a16:creationId xmlns:a16="http://schemas.microsoft.com/office/drawing/2014/main" id="{3098313E-E8A3-4CA9-8A58-C75B6FF1F88E}"/>
+                <a16:creationId xmlns:a16="http://schemas.microsoft.com/office/drawing/2014/main" id="{6D8CCB30-D839-472A-B29B-AFCE7969E493}"/>
               </a:ext>
             </a:extLst>
           </p:cNvPr>
@@ -5250,7 +5260,7 @@
           <p:cNvPr id="5" name="">
             <a:extLst xmlns:a="http://schemas.openxmlformats.org/drawingml/2006/main">
               <a:ext uri="{FF2B5EF4-FFF2-40B4-BE49-F238E27FC236}">
-                <a16:creationId xmlns:a16="http://schemas.microsoft.com/office/drawing/2014/main" id="{466F5634-7E51-4236-91C0-A8ED301D9B98}"/>
+                <a16:creationId xmlns:a16="http://schemas.microsoft.com/office/drawing/2014/main" id="{44845F09-85C0-446C-9E17-1E9175F1366A}"/>
               </a:ext>
             </a:extLst>
           </p:cNvPr>
@@ -5305,7 +5315,7 @@
                 <a:latin typeface="Arial"/>
                 <a:ea typeface="Arial"/>
                 <a:cs typeface="Arial"/>
-                <a:hlinkClick xmlns:r="http://schemas.openxmlformats.org/officeDocument/2006/relationships" r:id="R0bf08c43d9314b97"/>
+                <a:hlinkClick xmlns:r="http://schemas.openxmlformats.org/officeDocument/2006/relationships" r:id="Re6867add8c5d446a"/>
               </a:rPr>
               <a:t>Research objects with AI: the talk</a:t>
             </a:r>
@@ -5317,7 +5327,7 @@
           <p:cNvPr id="6" name="">
             <a:extLst xmlns:a="http://schemas.openxmlformats.org/drawingml/2006/main">
               <a:ext uri="{FF2B5EF4-FFF2-40B4-BE49-F238E27FC236}">
-                <a16:creationId xmlns:a16="http://schemas.microsoft.com/office/drawing/2014/main" id="{E67A0410-38A2-40C0-81DB-E67E54362A3C}"/>
+                <a16:creationId xmlns:a16="http://schemas.microsoft.com/office/drawing/2014/main" id="{87A62A40-21EC-4250-98EA-642F2777BFCB}"/>
               </a:ext>
             </a:extLst>
           </p:cNvPr>
@@ -5372,7 +5382,7 @@
                 <a:latin typeface="Arial"/>
                 <a:ea typeface="Arial"/>
                 <a:cs typeface="Arial"/>
-                <a:hlinkClick xmlns:r="http://schemas.openxmlformats.org/officeDocument/2006/relationships" r:id="R837f9ccb92404944"/>
+                <a:hlinkClick xmlns:r="http://schemas.openxmlformats.org/officeDocument/2006/relationships" r:id="Rd541cc7dd5ae4e89"/>
               </a:rPr>
               <a:t>STAMPED principles</a:t>
             </a:r>
@@ -5382,7 +5392,7 @@
     </p:spTree>
     <p:extLst>
       <p:ext uri="{BB962C8B-B14F-4D97-AF65-F5344CB8AC3E}">
-        <p14:creationId xmlns:p14="http://schemas.microsoft.com/office/powerpoint/2010/main" val="1179289416"/>
+        <p14:creationId xmlns:p14="http://schemas.microsoft.com/office/powerpoint/2010/main" val="1600238096"/>
       </p:ext>
     </p:extLst>
   </p:cSld>
@@ -5413,7 +5423,7 @@
           <p:cNvPr id="9" name="">
             <a:extLst xmlns:a="http://schemas.openxmlformats.org/drawingml/2006/main">
               <a:ext uri="{FF2B5EF4-FFF2-40B4-BE49-F238E27FC236}">
-                <a16:creationId xmlns:a16="http://schemas.microsoft.com/office/drawing/2014/main" id="{D9D1FB75-D542-4498-9BFD-9D0E1542BFD8}"/>
+                <a16:creationId xmlns:a16="http://schemas.microsoft.com/office/drawing/2014/main" id="{954563A2-2981-47EB-996C-3B59AEA40F9A}"/>
               </a:ext>
             </a:extLst>
           </p:cNvPr>
@@ -5479,7 +5489,7 @@
           <p:cNvPr id="2" name="">
             <a:extLst xmlns:a="http://schemas.openxmlformats.org/drawingml/2006/main">
               <a:ext uri="{FF2B5EF4-FFF2-40B4-BE49-F238E27FC236}">
-                <a16:creationId xmlns:a16="http://schemas.microsoft.com/office/drawing/2014/main" id="{D8A168B3-24DB-45B2-8668-99F71B22E7D9}"/>
+                <a16:creationId xmlns:a16="http://schemas.microsoft.com/office/drawing/2014/main" id="{372CF419-69A5-4417-9BB1-1CFFDCD4CC87}"/>
               </a:ext>
             </a:extLst>
           </p:cNvPr>
@@ -5545,7 +5555,7 @@
           <p:cNvPr id="3" name="">
             <a:extLst xmlns:a="http://schemas.openxmlformats.org/drawingml/2006/main">
               <a:ext uri="{FF2B5EF4-FFF2-40B4-BE49-F238E27FC236}">
-                <a16:creationId xmlns:a16="http://schemas.microsoft.com/office/drawing/2014/main" id="{6ABFD5B7-75E3-47D4-B14A-78DF6714FD15}"/>
+                <a16:creationId xmlns:a16="http://schemas.microsoft.com/office/drawing/2014/main" id="{F146A648-4FE7-4E33-A4E0-F6CAA491FBF6}"/>
               </a:ext>
             </a:extLst>
           </p:cNvPr>
@@ -5634,7 +5644,7 @@
           <p:cNvPr id="4" name="">
             <a:extLst xmlns:a="http://schemas.openxmlformats.org/drawingml/2006/main">
               <a:ext uri="{FF2B5EF4-FFF2-40B4-BE49-F238E27FC236}">
-                <a16:creationId xmlns:a16="http://schemas.microsoft.com/office/drawing/2014/main" id="{4F35774C-DDAF-4B63-B0A3-7F41D5B23AB2}"/>
+                <a16:creationId xmlns:a16="http://schemas.microsoft.com/office/drawing/2014/main" id="{0DD24F89-1C08-40FB-9C7D-E39C00471D45}"/>
               </a:ext>
             </a:extLst>
           </p:cNvPr>
@@ -5746,7 +5756,7 @@
           <p:cNvPr id="5" name="">
             <a:extLst xmlns:a="http://schemas.openxmlformats.org/drawingml/2006/main">
               <a:ext uri="{FF2B5EF4-FFF2-40B4-BE49-F238E27FC236}">
-                <a16:creationId xmlns:a16="http://schemas.microsoft.com/office/drawing/2014/main" id="{D26FDAD6-F964-4CF7-838A-4D020122EAB0}"/>
+                <a16:creationId xmlns:a16="http://schemas.microsoft.com/office/drawing/2014/main" id="{E58CAB46-C422-482B-A696-CA88A6E7E025}"/>
               </a:ext>
             </a:extLst>
           </p:cNvPr>
@@ -5756,7 +5766,7 @@
           <p:nvPr/>
         </p:nvPicPr>
         <p:blipFill>
-          <a:blip xmlns:r="http://schemas.openxmlformats.org/officeDocument/2006/relationships" xmlns:a="http://schemas.openxmlformats.org/drawingml/2006/main" r:embed="R84c35f10b8b44763"/>
+          <a:blip xmlns:r="http://schemas.openxmlformats.org/officeDocument/2006/relationships" xmlns:a="http://schemas.openxmlformats.org/drawingml/2006/main" r:embed="Rfa97f16a7c434a0b"/>
           <a:stretch xmlns:a="http://schemas.openxmlformats.org/drawingml/2006/main"/>
         </p:blipFill>
         <p:spPr>
@@ -5774,7 +5784,7 @@
           <p:cNvPr id="6" name="">
             <a:extLst xmlns:a="http://schemas.openxmlformats.org/drawingml/2006/main">
               <a:ext uri="{FF2B5EF4-FFF2-40B4-BE49-F238E27FC236}">
-                <a16:creationId xmlns:a16="http://schemas.microsoft.com/office/drawing/2014/main" id="{076EE404-F294-4867-A6E7-93498794EEF5}"/>
+                <a16:creationId xmlns:a16="http://schemas.microsoft.com/office/drawing/2014/main" id="{2271D289-B5A5-47EE-905B-6EF97A631F44}"/>
               </a:ext>
             </a:extLst>
           </p:cNvPr>
@@ -5829,7 +5839,7 @@
                 <a:latin typeface="Arial"/>
                 <a:ea typeface="Arial"/>
                 <a:cs typeface="Arial"/>
-                <a:hlinkClick xmlns:r="http://schemas.openxmlformats.org/officeDocument/2006/relationships" r:id="Re4dbde56c1b14147"/>
+                <a:hlinkClick xmlns:r="http://schemas.openxmlformats.org/officeDocument/2006/relationships" r:id="R8c5a3dca3f3d45cd"/>
               </a:rPr>
               <a:t>Project + source</a:t>
             </a:r>
@@ -5841,7 +5851,7 @@
           <p:cNvPr id="7" name="">
             <a:extLst xmlns:a="http://schemas.openxmlformats.org/drawingml/2006/main">
               <a:ext uri="{FF2B5EF4-FFF2-40B4-BE49-F238E27FC236}">
-                <a16:creationId xmlns:a16="http://schemas.microsoft.com/office/drawing/2014/main" id="{5A323EAE-AA11-4572-9A77-CA26B47BFB6D}"/>
+                <a16:creationId xmlns:a16="http://schemas.microsoft.com/office/drawing/2014/main" id="{CFEB11F4-DB45-4733-85C9-14272698A0AA}"/>
               </a:ext>
             </a:extLst>
           </p:cNvPr>
@@ -5896,7 +5906,7 @@
                 <a:latin typeface="Arial"/>
                 <a:ea typeface="Arial"/>
                 <a:cs typeface="Arial"/>
-                <a:hlinkClick xmlns:r="http://schemas.openxmlformats.org/officeDocument/2006/relationships" r:id="R1dc30224934441b2"/>
+                <a:hlinkClick xmlns:r="http://schemas.openxmlformats.org/officeDocument/2006/relationships" r:id="R48a5c4b55b394fba"/>
               </a:rPr>
               <a:t>Explore the graph</a:t>
             </a:r>
@@ -5908,7 +5918,7 @@
           <p:cNvPr id="8" name="">
             <a:extLst xmlns:a="http://schemas.openxmlformats.org/drawingml/2006/main">
               <a:ext uri="{FF2B5EF4-FFF2-40B4-BE49-F238E27FC236}">
-                <a16:creationId xmlns:a16="http://schemas.microsoft.com/office/drawing/2014/main" id="{018E6454-F79E-4901-B470-E6B02FE4FA7A}"/>
+                <a16:creationId xmlns:a16="http://schemas.microsoft.com/office/drawing/2014/main" id="{2CC4E924-8A8D-41F5-934F-A4924CA72DB1}"/>
               </a:ext>
             </a:extLst>
           </p:cNvPr>
@@ -5963,7 +5973,7 @@
                 <a:latin typeface="Arial"/>
                 <a:ea typeface="Arial"/>
                 <a:cs typeface="Arial"/>
-                <a:hlinkClick xmlns:r="http://schemas.openxmlformats.org/officeDocument/2006/relationships" r:id="Rf7df31fc4d894205"/>
+                <a:hlinkClick xmlns:r="http://schemas.openxmlformats.org/officeDocument/2006/relationships" r:id="R79b782204b654974"/>
               </a:rPr>
               <a:t>Poster</a:t>
             </a:r>
@@ -5973,7 +5983,7 @@
     </p:spTree>
     <p:extLst>
       <p:ext uri="{BB962C8B-B14F-4D97-AF65-F5344CB8AC3E}">
-        <p14:creationId xmlns:p14="http://schemas.microsoft.com/office/powerpoint/2010/main" val="1320965885"/>
+        <p14:creationId xmlns:p14="http://schemas.microsoft.com/office/powerpoint/2010/main" val="1051359668"/>
       </p:ext>
     </p:extLst>
   </p:cSld>
@@ -6001,10 +6011,10 @@
       </p:grpSpPr>
       <p:sp>
         <p:nvSpPr>
-          <p:cNvPr id="10" name="">
+          <p:cNvPr id="11" name="">
             <a:extLst xmlns:a="http://schemas.openxmlformats.org/drawingml/2006/main">
               <a:ext uri="{FF2B5EF4-FFF2-40B4-BE49-F238E27FC236}">
-                <a16:creationId xmlns:a16="http://schemas.microsoft.com/office/drawing/2014/main" id="{D66BC826-BBD3-4E72-893F-50DADB6AB504}"/>
+                <a16:creationId xmlns:a16="http://schemas.microsoft.com/office/drawing/2014/main" id="{C1882910-780E-4127-84D8-D2360D9478D2}"/>
               </a:ext>
             </a:extLst>
           </p:cNvPr>
@@ -6070,7 +6080,7 @@
           <p:cNvPr id="2" name="">
             <a:extLst xmlns:a="http://schemas.openxmlformats.org/drawingml/2006/main">
               <a:ext uri="{FF2B5EF4-FFF2-40B4-BE49-F238E27FC236}">
-                <a16:creationId xmlns:a16="http://schemas.microsoft.com/office/drawing/2014/main" id="{AC96358B-CF02-4C91-B61B-5BC8792AA153}"/>
+                <a16:creationId xmlns:a16="http://schemas.microsoft.com/office/drawing/2014/main" id="{387D45B4-51CC-44E8-B821-CCCDF26B5F3B}"/>
               </a:ext>
             </a:extLst>
           </p:cNvPr>
@@ -6126,7 +6136,7 @@
                 <a:ea typeface="Arial"/>
                 <a:cs typeface="Arial"/>
               </a:rPr>
-              <a:t>Can reusable skills help an agent</a:t>
+              <a:t>Skills that improve through</a:t>
             </a:r>
           </a:p>
           <a:p xmlns:a="http://schemas.openxmlformats.org/drawingml/2006/main">
@@ -6149,7 +6159,7 @@
                 <a:ea typeface="Arial"/>
                 <a:cs typeface="Arial"/>
               </a:rPr>
-              <a:t>leave better research evidence?</a:t>
+              <a:t>scientific work</a:t>
             </a:r>
           </a:p>
         </p:txBody>
@@ -6159,7 +6169,7 @@
           <p:cNvPr id="3" name="">
             <a:extLst xmlns:a="http://schemas.openxmlformats.org/drawingml/2006/main">
               <a:ext uri="{FF2B5EF4-FFF2-40B4-BE49-F238E27FC236}">
-                <a16:creationId xmlns:a16="http://schemas.microsoft.com/office/drawing/2014/main" id="{931C5018-EB43-4A53-A58E-B907C5F9B50C}"/>
+                <a16:creationId xmlns:a16="http://schemas.microsoft.com/office/drawing/2014/main" id="{8DFD4201-8B9A-4221-B2AD-022F95D55F8E}"/>
               </a:ext>
             </a:extLst>
           </p:cNvPr>
@@ -6185,7 +6195,7 @@
           <a:bodyPr xmlns:a="http://schemas.openxmlformats.org/drawingml/2006/main" lIns="0" tIns="0" rIns="0" bIns="0"/>
           <a:lstStyle xmlns:a="http://schemas.openxmlformats.org/drawingml/2006/main">
             <a:defPPr>
-              <a:defRPr sz="2775" b="1">
+              <a:defRPr sz="2400" b="1">
                 <a:solidFill>
                   <a:srgbClr val="15716E"/>
                 </a:solidFill>
@@ -6197,7 +6207,7 @@
           </a:lstStyle>
           <a:p xmlns:a="http://schemas.openxmlformats.org/drawingml/2006/main">
             <a:pPr>
-              <a:defRPr sz="2775" b="1">
+              <a:defRPr sz="2400" b="1">
                 <a:solidFill>
                   <a:srgbClr val="15716E"/>
                 </a:solidFill>
@@ -6207,7 +6217,7 @@
               </a:defRPr>
             </a:pPr>
             <a:r>
-              <a:rPr sz="2775" b="1">
+              <a:rPr sz="2400" b="1">
                 <a:solidFill>
                   <a:srgbClr val="15716E"/>
                 </a:solidFill>
@@ -6215,7 +6225,7 @@
                 <a:ea typeface="Arial"/>
                 <a:cs typeface="Arial"/>
               </a:rPr>
-              <a:t>3 paired tasks. 6 attempts.</a:t>
+              <a:t>Study record on Zenodo</a:t>
             </a:r>
           </a:p>
         </p:txBody>
@@ -6225,7 +6235,7 @@
           <p:cNvPr id="4" name="">
             <a:extLst xmlns:a="http://schemas.openxmlformats.org/drawingml/2006/main">
               <a:ext uri="{FF2B5EF4-FFF2-40B4-BE49-F238E27FC236}">
-                <a16:creationId xmlns:a16="http://schemas.microsoft.com/office/drawing/2014/main" id="{01625513-2EF0-40B1-B90C-95D402E2484B}"/>
+                <a16:creationId xmlns:a16="http://schemas.microsoft.com/office/drawing/2014/main" id="{D5BBBD69-4238-4B15-9212-0D9FD0F88AA8}"/>
               </a:ext>
             </a:extLst>
           </p:cNvPr>
@@ -6236,7 +6246,73 @@
         </p:nvSpPr>
         <p:spPr>
           <a:xfrm xmlns:a="http://schemas.openxmlformats.org/drawingml/2006/main">
-            <a:off x="609600" y="3619500"/>
+            <a:off x="609600" y="3714750"/>
+            <a:ext cx="6286500" cy="619125"/>
+          </a:xfrm>
+          <a:prstGeom xmlns:a="http://schemas.openxmlformats.org/drawingml/2006/main" prst="rect">
+            <a:avLst/>
+          </a:prstGeom>
+          <a:noFill xmlns:a="http://schemas.openxmlformats.org/drawingml/2006/main"/>
+          <a:ln xmlns:a="http://schemas.openxmlformats.org/drawingml/2006/main" w="0">
+            <a:noFill/>
+          </a:ln>
+        </p:spPr>
+        <p:txBody>
+          <a:bodyPr xmlns:a="http://schemas.openxmlformats.org/drawingml/2006/main" lIns="0" tIns="0" rIns="0" bIns="0"/>
+          <a:lstStyle xmlns:a="http://schemas.openxmlformats.org/drawingml/2006/main">
+            <a:defPPr>
+              <a:defRPr sz="2250" b="0">
+                <a:solidFill>
+                  <a:srgbClr val="183A3C"/>
+                </a:solidFill>
+                <a:latin typeface="Arial"/>
+                <a:ea typeface="Arial"/>
+                <a:cs typeface="Arial"/>
+              </a:defRPr>
+            </a:defPPr>
+          </a:lstStyle>
+          <a:p xmlns:a="http://schemas.openxmlformats.org/drawingml/2006/main">
+            <a:pPr>
+              <a:defRPr sz="2250" b="0">
+                <a:solidFill>
+                  <a:srgbClr val="183A3C"/>
+                </a:solidFill>
+                <a:latin typeface="Arial"/>
+                <a:ea typeface="Arial"/>
+                <a:cs typeface="Arial"/>
+              </a:defRPr>
+            </a:pPr>
+            <a:r>
+              <a:rPr sz="2250" b="0">
+                <a:solidFill>
+                  <a:srgbClr val="183A3C"/>
+                </a:solidFill>
+                <a:latin typeface="Arial"/>
+                <a:ea typeface="Arial"/>
+                <a:cs typeface="Arial"/>
+              </a:rPr>
+              <a:t>Next: run, assess, improve, repeat</a:t>
+            </a:r>
+          </a:p>
+        </p:txBody>
+      </p:sp>
+      <p:sp>
+        <p:nvSpPr>
+          <p:cNvPr id="5" name="">
+            <a:extLst xmlns:a="http://schemas.openxmlformats.org/drawingml/2006/main">
+              <a:ext uri="{FF2B5EF4-FFF2-40B4-BE49-F238E27FC236}">
+                <a16:creationId xmlns:a16="http://schemas.microsoft.com/office/drawing/2014/main" id="{3BEE3616-0601-4378-B60B-4C4F88155024}"/>
+              </a:ext>
+            </a:extLst>
+          </p:cNvPr>
+          <p:cNvSpPr>
+            <a:spLocks xmlns:a="http://schemas.openxmlformats.org/drawingml/2006/main" noGrp="1"/>
+          </p:cNvSpPr>
+          <p:nvPr/>
+        </p:nvSpPr>
+        <p:spPr>
+          <a:xfrm xmlns:a="http://schemas.openxmlformats.org/drawingml/2006/main">
+            <a:off x="609600" y="4619625"/>
             <a:ext cx="6286500" cy="914400"/>
           </a:xfrm>
           <a:prstGeom xmlns:a="http://schemas.openxmlformats.org/drawingml/2006/main" prst="rect">
@@ -6251,7 +6327,7 @@
           <a:bodyPr xmlns:a="http://schemas.openxmlformats.org/drawingml/2006/main" lIns="0" tIns="0" rIns="0" bIns="0"/>
           <a:lstStyle xmlns:a="http://schemas.openxmlformats.org/drawingml/2006/main">
             <a:defPPr>
-              <a:defRPr sz="2250" b="0">
+              <a:defRPr sz="2100" b="0">
                 <a:solidFill>
                   <a:srgbClr val="183A3C"/>
                 </a:solidFill>
@@ -6263,7 +6339,7 @@
           </a:lstStyle>
           <a:p xmlns:a="http://schemas.openxmlformats.org/drawingml/2006/main">
             <a:pPr>
-              <a:defRPr sz="2250" b="0">
+              <a:defRPr sz="2100" b="0">
                 <a:solidFill>
                   <a:srgbClr val="183A3C"/>
                 </a:solidFill>
@@ -6273,7 +6349,7 @@
               </a:defRPr>
             </a:pPr>
             <a:r>
-              <a:rPr sz="2250" b="0">
+              <a:rPr sz="2100" b="0">
                 <a:solidFill>
                   <a:srgbClr val="183A3C"/>
                 </a:solidFill>
@@ -6281,12 +6357,12 @@
                 <a:ea typeface="Arial"/>
                 <a:cs typeface="Arial"/>
               </a:rPr>
-              <a:t>All matched the actual-data checks</a:t>
+              <a:t>Compare four assistance conditions.</a:t>
             </a:r>
           </a:p>
           <a:p xmlns:a="http://schemas.openxmlformats.org/drawingml/2006/main">
             <a:pPr>
-              <a:defRPr sz="2250" b="0">
+              <a:defRPr sz="2100" b="0">
                 <a:solidFill>
                   <a:srgbClr val="183A3C"/>
                 </a:solidFill>
@@ -6296,7 +6372,7 @@
               </a:defRPr>
             </a:pPr>
             <a:r>
-              <a:rPr sz="2250" b="0">
+              <a:rPr sz="2100" b="0">
                 <a:solidFill>
                   <a:srgbClr val="183A3C"/>
                 </a:solidFill>
@@ -6304,96 +6380,7 @@
                 <a:ea typeface="Arial"/>
                 <a:cs typeface="Arial"/>
               </a:rPr>
-              <a:t>and passed fresh scientific replay.</a:t>
-            </a:r>
-          </a:p>
-        </p:txBody>
-      </p:sp>
-      <p:sp>
-        <p:nvSpPr>
-          <p:cNvPr id="5" name="">
-            <a:extLst xmlns:a="http://schemas.openxmlformats.org/drawingml/2006/main">
-              <a:ext uri="{FF2B5EF4-FFF2-40B4-BE49-F238E27FC236}">
-                <a16:creationId xmlns:a16="http://schemas.microsoft.com/office/drawing/2014/main" id="{EB75D5A2-D31A-4AB8-8767-096BED221906}"/>
-              </a:ext>
-            </a:extLst>
-          </p:cNvPr>
-          <p:cNvSpPr>
-            <a:spLocks xmlns:a="http://schemas.openxmlformats.org/drawingml/2006/main" noGrp="1"/>
-          </p:cNvSpPr>
-          <p:nvPr/>
-        </p:nvSpPr>
-        <p:spPr>
-          <a:xfrm xmlns:a="http://schemas.openxmlformats.org/drawingml/2006/main">
-            <a:off x="609600" y="4762500"/>
-            <a:ext cx="6286500" cy="914400"/>
-          </a:xfrm>
-          <a:prstGeom xmlns:a="http://schemas.openxmlformats.org/drawingml/2006/main" prst="rect">
-            <a:avLst/>
-          </a:prstGeom>
-          <a:noFill xmlns:a="http://schemas.openxmlformats.org/drawingml/2006/main"/>
-          <a:ln xmlns:a="http://schemas.openxmlformats.org/drawingml/2006/main" w="0">
-            <a:noFill/>
-          </a:ln>
-        </p:spPr>
-        <p:txBody>
-          <a:bodyPr xmlns:a="http://schemas.openxmlformats.org/drawingml/2006/main" lIns="0" tIns="0" rIns="0" bIns="0"/>
-          <a:lstStyle xmlns:a="http://schemas.openxmlformats.org/drawingml/2006/main">
-            <a:defPPr>
-              <a:defRPr sz="2250" b="1">
-                <a:solidFill>
-                  <a:srgbClr val="AA492E"/>
-                </a:solidFill>
-                <a:latin typeface="Arial"/>
-                <a:ea typeface="Arial"/>
-                <a:cs typeface="Arial"/>
-              </a:defRPr>
-            </a:defPPr>
-          </a:lstStyle>
-          <a:p xmlns:a="http://schemas.openxmlformats.org/drawingml/2006/main">
-            <a:pPr>
-              <a:defRPr sz="2250" b="1">
-                <a:solidFill>
-                  <a:srgbClr val="AA492E"/>
-                </a:solidFill>
-                <a:latin typeface="Arial"/>
-                <a:ea typeface="Arial"/>
-                <a:cs typeface="Arial"/>
-              </a:defRPr>
-            </a:pPr>
-            <a:r>
-              <a:rPr sz="2250" b="1">
-                <a:solidFill>
-                  <a:srgbClr val="AA492E"/>
-                </a:solidFill>
-                <a:latin typeface="Arial"/>
-                <a:ea typeface="Arial"/>
-                <a:cs typeface="Arial"/>
-              </a:rPr>
-              <a:t>One skills-assisted attempt still failed</a:t>
-            </a:r>
-          </a:p>
-          <a:p xmlns:a="http://schemas.openxmlformats.org/drawingml/2006/main">
-            <a:pPr>
-              <a:defRPr sz="2250" b="1">
-                <a:solidFill>
-                  <a:srgbClr val="AA492E"/>
-                </a:solidFill>
-                <a:latin typeface="Arial"/>
-                <a:ea typeface="Arial"/>
-                <a:cs typeface="Arial"/>
-              </a:defRPr>
-            </a:pPr>
-            <a:r>
-              <a:rPr sz="2250" b="1">
-                <a:solidFill>
-                  <a:srgbClr val="AA492E"/>
-                </a:solidFill>
-                <a:latin typeface="Arial"/>
-                <a:ea typeface="Arial"/>
-                <a:cs typeface="Arial"/>
-              </a:rPr>
-              <a:t>2 missing-value screening cases.</a:t>
+              <a:t>Test quality, effort and consistency.</a:t>
             </a:r>
           </a:p>
         </p:txBody>
@@ -6403,7 +6390,7 @@
           <p:cNvPr id="6" name="">
             <a:extLst xmlns:a="http://schemas.openxmlformats.org/drawingml/2006/main">
               <a:ext uri="{FF2B5EF4-FFF2-40B4-BE49-F238E27FC236}">
-                <a16:creationId xmlns:a16="http://schemas.microsoft.com/office/drawing/2014/main" id="{EFEB509A-A7E4-4C4A-96C0-BB1C4E704DB1}"/>
+                <a16:creationId xmlns:a16="http://schemas.microsoft.com/office/drawing/2014/main" id="{E50DF319-A2A3-413C-B583-A170456781F3}"/>
               </a:ext>
             </a:extLst>
           </p:cNvPr>
@@ -6413,7 +6400,7 @@
           <p:nvPr/>
         </p:nvPicPr>
         <p:blipFill>
-          <a:blip xmlns:r="http://schemas.openxmlformats.org/officeDocument/2006/relationships" xmlns:a="http://schemas.openxmlformats.org/drawingml/2006/main" r:embed="R03bb5e456f2f4956"/>
+          <a:blip xmlns:r="http://schemas.openxmlformats.org/officeDocument/2006/relationships" xmlns:a="http://schemas.openxmlformats.org/drawingml/2006/main" r:embed="R353a67b311fd4f22"/>
           <a:stretch xmlns:a="http://schemas.openxmlformats.org/drawingml/2006/main"/>
         </p:blipFill>
         <p:spPr>
@@ -6431,7 +6418,7 @@
           <p:cNvPr id="7" name="">
             <a:extLst xmlns:a="http://schemas.openxmlformats.org/drawingml/2006/main">
               <a:ext uri="{FF2B5EF4-FFF2-40B4-BE49-F238E27FC236}">
-                <a16:creationId xmlns:a16="http://schemas.microsoft.com/office/drawing/2014/main" id="{3063DC6B-1EC0-4C78-BEEE-104A10A6E335}"/>
+                <a16:creationId xmlns:a16="http://schemas.microsoft.com/office/drawing/2014/main" id="{6503B8DC-5F78-45EA-9161-496D3AD6F3D1}"/>
               </a:ext>
             </a:extLst>
           </p:cNvPr>
@@ -6442,7 +6429,7 @@
         </p:nvSpPr>
         <p:spPr>
           <a:xfrm xmlns:a="http://schemas.openxmlformats.org/drawingml/2006/main">
-            <a:off x="7762875" y="5572125"/>
+            <a:off x="7762875" y="5524500"/>
             <a:ext cx="3810000" cy="647700"/>
           </a:xfrm>
           <a:prstGeom xmlns:a="http://schemas.openxmlformats.org/drawingml/2006/main" prst="rect">
@@ -6487,7 +6474,7 @@
                 <a:ea typeface="Arial"/>
                 <a:cs typeface="Arial"/>
               </a:rPr>
-              <a:t>Exploratory, unblinded study.</a:t>
+              <a:t>Research workshop in development.</a:t>
             </a:r>
           </a:p>
           <a:p xmlns:a="http://schemas.openxmlformats.org/drawingml/2006/main">
@@ -6510,7 +6497,7 @@
                 <a:ea typeface="Arial"/>
                 <a:cs typeface="Arial"/>
               </a:rPr>
-              <a:t>No general claim of skill effectiveness.</a:t>
+              <a:t>Transfer remains to be tested.</a:t>
             </a:r>
           </a:p>
         </p:txBody>
@@ -6520,7 +6507,7 @@
           <p:cNvPr id="8" name="">
             <a:extLst xmlns:a="http://schemas.openxmlformats.org/drawingml/2006/main">
               <a:ext uri="{FF2B5EF4-FFF2-40B4-BE49-F238E27FC236}">
-                <a16:creationId xmlns:a16="http://schemas.microsoft.com/office/drawing/2014/main" id="{EF2F5C64-7EFF-483C-B4ED-398DA0FD44EC}"/>
+                <a16:creationId xmlns:a16="http://schemas.microsoft.com/office/drawing/2014/main" id="{B6E74366-4108-4625-967E-9DC574E14512}"/>
               </a:ext>
             </a:extLst>
           </p:cNvPr>
@@ -6532,7 +6519,7 @@
         <p:spPr>
           <a:xfrm xmlns:a="http://schemas.openxmlformats.org/drawingml/2006/main">
             <a:off x="609600" y="6153150"/>
-            <a:ext cx="3714750" cy="361950"/>
+            <a:ext cx="3143250" cy="361950"/>
           </a:xfrm>
           <a:prstGeom xmlns:a="http://schemas.openxmlformats.org/drawingml/2006/main" prst="rect">
             <a:avLst/>
@@ -6575,9 +6562,9 @@
                 <a:latin typeface="Arial"/>
                 <a:ea typeface="Arial"/>
                 <a:cs typeface="Arial"/>
-                <a:hlinkClick xmlns:r="http://schemas.openxmlformats.org/officeDocument/2006/relationships" r:id="R524899ff711847ed"/>
+                <a:hlinkClick xmlns:r="http://schemas.openxmlformats.org/officeDocument/2006/relationships" r:id="R882b8cf50e3a494a"/>
               </a:rPr>
-              <a:t>Study + evidence</a:t>
+              <a:t>Poster PR #35</a:t>
             </a:r>
           </a:p>
         </p:txBody>
@@ -6587,7 +6574,7 @@
           <p:cNvPr id="9" name="">
             <a:extLst xmlns:a="http://schemas.openxmlformats.org/drawingml/2006/main">
               <a:ext uri="{FF2B5EF4-FFF2-40B4-BE49-F238E27FC236}">
-                <a16:creationId xmlns:a16="http://schemas.microsoft.com/office/drawing/2014/main" id="{21A00EDF-D5D5-4633-BD0A-A78E6774D023}"/>
+                <a16:creationId xmlns:a16="http://schemas.microsoft.com/office/drawing/2014/main" id="{CD5C5891-9406-4DBC-BFE1-D0959819CD09}"/>
               </a:ext>
             </a:extLst>
           </p:cNvPr>
@@ -6598,7 +6585,74 @@
         </p:nvSpPr>
         <p:spPr>
           <a:xfrm xmlns:a="http://schemas.openxmlformats.org/drawingml/2006/main">
-            <a:off x="4191000" y="6153150"/>
+            <a:off x="4333875" y="6153150"/>
+            <a:ext cx="3238500" cy="361950"/>
+          </a:xfrm>
+          <a:prstGeom xmlns:a="http://schemas.openxmlformats.org/drawingml/2006/main" prst="rect">
+            <a:avLst/>
+          </a:prstGeom>
+          <a:noFill xmlns:a="http://schemas.openxmlformats.org/drawingml/2006/main"/>
+          <a:ln xmlns:a="http://schemas.openxmlformats.org/drawingml/2006/main" w="0">
+            <a:noFill/>
+          </a:ln>
+        </p:spPr>
+        <p:txBody>
+          <a:bodyPr xmlns:a="http://schemas.openxmlformats.org/drawingml/2006/main" lIns="0" tIns="0" rIns="0" bIns="0"/>
+          <a:lstStyle xmlns:a="http://schemas.openxmlformats.org/drawingml/2006/main">
+            <a:defPPr>
+              <a:defRPr sz="1800" b="0">
+                <a:solidFill>
+                  <a:srgbClr val="15716E"/>
+                </a:solidFill>
+                <a:latin typeface="Arial"/>
+                <a:ea typeface="Arial"/>
+                <a:cs typeface="Arial"/>
+              </a:defRPr>
+            </a:defPPr>
+          </a:lstStyle>
+          <a:p xmlns:a="http://schemas.openxmlformats.org/drawingml/2006/main">
+            <a:pPr>
+              <a:defRPr sz="1800" b="0">
+                <a:solidFill>
+                  <a:srgbClr val="15716E"/>
+                </a:solidFill>
+                <a:latin typeface="Arial"/>
+                <a:ea typeface="Arial"/>
+                <a:cs typeface="Arial"/>
+              </a:defRPr>
+            </a:pPr>
+            <a:r>
+              <a:rPr sz="1800" b="0">
+                <a:solidFill>
+                  <a:srgbClr val="15716E"/>
+                </a:solidFill>
+                <a:latin typeface="Arial"/>
+                <a:ea typeface="Arial"/>
+                <a:cs typeface="Arial"/>
+                <a:hlinkClick xmlns:r="http://schemas.openxmlformats.org/officeDocument/2006/relationships" r:id="Rec16e4e201994115"/>
+              </a:rPr>
+              <a:t>Study on Zenodo</a:t>
+            </a:r>
+          </a:p>
+        </p:txBody>
+      </p:sp>
+      <p:sp>
+        <p:nvSpPr>
+          <p:cNvPr id="10" name="">
+            <a:extLst xmlns:a="http://schemas.openxmlformats.org/drawingml/2006/main">
+              <a:ext uri="{FF2B5EF4-FFF2-40B4-BE49-F238E27FC236}">
+                <a16:creationId xmlns:a16="http://schemas.microsoft.com/office/drawing/2014/main" id="{580B5769-1EE1-4048-AA14-FEDB446B9DDA}"/>
+              </a:ext>
+            </a:extLst>
+          </p:cNvPr>
+          <p:cNvSpPr>
+            <a:spLocks xmlns:a="http://schemas.openxmlformats.org/drawingml/2006/main" noGrp="1"/>
+          </p:cNvSpPr>
+          <p:nvPr/>
+        </p:nvSpPr>
+        <p:spPr>
+          <a:xfrm xmlns:a="http://schemas.openxmlformats.org/drawingml/2006/main">
+            <a:off x="8239125" y="6153150"/>
             <a:ext cx="3333750" cy="361950"/>
           </a:xfrm>
           <a:prstGeom xmlns:a="http://schemas.openxmlformats.org/drawingml/2006/main" prst="rect">
@@ -6642,9 +6696,9 @@
                 <a:latin typeface="Arial"/>
                 <a:ea typeface="Arial"/>
                 <a:cs typeface="Arial"/>
-                <a:hlinkClick xmlns:r="http://schemas.openxmlformats.org/officeDocument/2006/relationships" r:id="R6cc2fd4fb84b4186"/>
+                <a:hlinkClick xmlns:r="http://schemas.openxmlformats.org/officeDocument/2006/relationships" r:id="Re319bd24410245e6"/>
               </a:rPr>
-              <a:t>Poster + source</a:t>
+              <a:t>Next repository</a:t>
             </a:r>
           </a:p>
         </p:txBody>
@@ -6652,7 +6706,7 @@
     </p:spTree>
     <p:extLst>
       <p:ext uri="{BB962C8B-B14F-4D97-AF65-F5344CB8AC3E}">
-        <p14:creationId xmlns:p14="http://schemas.microsoft.com/office/powerpoint/2010/main" val="862794614"/>
+        <p14:creationId xmlns:p14="http://schemas.microsoft.com/office/powerpoint/2010/main" val="349039849"/>
       </p:ext>
     </p:extLst>
   </p:cSld>
@@ -6683,7 +6737,7 @@
           <p:cNvPr id="6" name="">
             <a:extLst xmlns:a="http://schemas.openxmlformats.org/drawingml/2006/main">
               <a:ext uri="{FF2B5EF4-FFF2-40B4-BE49-F238E27FC236}">
-                <a16:creationId xmlns:a16="http://schemas.microsoft.com/office/drawing/2014/main" id="{9F1F057F-FDDC-48D5-91C9-F01DF63C464A}"/>
+                <a16:creationId xmlns:a16="http://schemas.microsoft.com/office/drawing/2014/main" id="{8F7E996F-F3D6-497E-B045-EC1D22B0AE48}"/>
               </a:ext>
             </a:extLst>
           </p:cNvPr>
@@ -6772,7 +6826,7 @@
           <p:cNvPr id="2" name="">
             <a:extLst xmlns:a="http://schemas.openxmlformats.org/drawingml/2006/main">
               <a:ext uri="{FF2B5EF4-FFF2-40B4-BE49-F238E27FC236}">
-                <a16:creationId xmlns:a16="http://schemas.microsoft.com/office/drawing/2014/main" id="{72C1EC05-2A12-41E6-987E-07464923A210}"/>
+                <a16:creationId xmlns:a16="http://schemas.microsoft.com/office/drawing/2014/main" id="{94C8A294-5801-4C2E-9398-D3F368720787}"/>
               </a:ext>
             </a:extLst>
           </p:cNvPr>
@@ -6861,7 +6915,7 @@
           <p:cNvPr id="3" name="">
             <a:extLst xmlns:a="http://schemas.openxmlformats.org/drawingml/2006/main">
               <a:ext uri="{FF2B5EF4-FFF2-40B4-BE49-F238E27FC236}">
-                <a16:creationId xmlns:a16="http://schemas.microsoft.com/office/drawing/2014/main" id="{28AD7E58-7753-4797-A9DA-B1B588107340}"/>
+                <a16:creationId xmlns:a16="http://schemas.microsoft.com/office/drawing/2014/main" id="{5F10C5A6-72A2-4500-8C2D-A6635302CEEA}"/>
               </a:ext>
             </a:extLst>
           </p:cNvPr>
@@ -6927,7 +6981,7 @@
           <p:cNvPr id="4" name="">
             <a:extLst xmlns:a="http://schemas.openxmlformats.org/drawingml/2006/main">
               <a:ext uri="{FF2B5EF4-FFF2-40B4-BE49-F238E27FC236}">
-                <a16:creationId xmlns:a16="http://schemas.microsoft.com/office/drawing/2014/main" id="{5F680896-D81E-45F5-8661-6899C5DBF3EA}"/>
+                <a16:creationId xmlns:a16="http://schemas.microsoft.com/office/drawing/2014/main" id="{6D23265D-A199-4432-A4F7-0BDB9A11B688}"/>
               </a:ext>
             </a:extLst>
           </p:cNvPr>
@@ -6982,7 +7036,7 @@
                 <a:latin typeface="Arial"/>
                 <a:ea typeface="Arial"/>
                 <a:cs typeface="Arial"/>
-                <a:hlinkClick xmlns:r="http://schemas.openxmlformats.org/officeDocument/2006/relationships" r:id="Rba026827bb0a4a97"/>
+                <a:hlinkClick xmlns:r="http://schemas.openxmlformats.org/officeDocument/2006/relationships" r:id="R992e7ebfccf143e0"/>
               </a:rPr>
               <a:t>leej3.github.io/ai-and-ales-2026</a:t>
             </a:r>
@@ -6994,7 +7048,7 @@
           <p:cNvPr id="5" name="">
             <a:extLst xmlns:a="http://schemas.openxmlformats.org/drawingml/2006/main">
               <a:ext uri="{FF2B5EF4-FFF2-40B4-BE49-F238E27FC236}">
-                <a16:creationId xmlns:a16="http://schemas.microsoft.com/office/drawing/2014/main" id="{E75CD89D-BC14-42B4-AEA8-83099CAD1BF8}"/>
+                <a16:creationId xmlns:a16="http://schemas.microsoft.com/office/drawing/2014/main" id="{C59C02E6-9D54-4491-B81F-D4521E9D57A1}"/>
               </a:ext>
             </a:extLst>
           </p:cNvPr>
@@ -7049,7 +7103,7 @@
                 <a:latin typeface="Arial"/>
                 <a:ea typeface="Arial"/>
                 <a:cs typeface="Arial"/>
-                <a:hlinkClick xmlns:r="http://schemas.openxmlformats.org/officeDocument/2006/relationships" r:id="Ra64ad28dfc374224"/>
+                <a:hlinkClick xmlns:r="http://schemas.openxmlformats.org/officeDocument/2006/relationships" r:id="R7912f2f727df4fa9"/>
               </a:rPr>
               <a:t>All links, downloads and editable source</a:t>
             </a:r>
@@ -7059,7 +7113,7 @@
     </p:spTree>
     <p:extLst>
       <p:ext uri="{BB962C8B-B14F-4D97-AF65-F5344CB8AC3E}">
-        <p14:creationId xmlns:p14="http://schemas.microsoft.com/office/powerpoint/2010/main" val="441788110"/>
+        <p14:creationId xmlns:p14="http://schemas.microsoft.com/office/powerpoint/2010/main" val="1819292043"/>
       </p:ext>
     </p:extLst>
   </p:cSld>

</xml_diff>

<commit_message>
feat: add Keyhatch to the AI and Ales presentation
Explain selective credential approval and bounded retrieval, link the
public source and design limits, and retain experimental status.
Tighten the eight-slide script to keep the five-minute schedule.
Refresh the browser deck, PowerPoint, PDF, and source notes.

Co-Authored-By: Codex Desktop 26.1007.71326 (runtime codex-cli 0.162.0-alpha.17.2) / gpt-6-astra <codex@openai.com>
Codex-Reasoning-Effort: medium
</commit_message>
<xml_diff>
--- a/downloads/ai-and-ales.pptx
+++ b/downloads/ai-and-ales.pptx
@@ -2,19 +2,20 @@
 <file path=ppt/presentation.xml><?xml version="1.0" encoding="utf-8"?>
 <p:presentation xmlns:p="http://schemas.openxmlformats.org/presentationml/2006/main">
   <p:sldMasterIdLst>
-    <p:sldMasterId xmlns:r="http://schemas.openxmlformats.org/officeDocument/2006/relationships" id="2147483648" r:id="Rc35e5cf0190b4952"/>
+    <p:sldMasterId xmlns:r="http://schemas.openxmlformats.org/officeDocument/2006/relationships" id="2147483648" r:id="R3f4912f66ed640dc"/>
   </p:sldMasterIdLst>
   <p:notesMasterIdLst>
-    <p:notesMasterId xmlns:r="http://schemas.openxmlformats.org/officeDocument/2006/relationships" r:id="Re717b334248c4fc3"/>
+    <p:notesMasterId xmlns:r="http://schemas.openxmlformats.org/officeDocument/2006/relationships" r:id="R25ad05a288f34a27"/>
   </p:notesMasterIdLst>
   <p:sldIdLst>
-    <p:sldId xmlns:r="http://schemas.openxmlformats.org/officeDocument/2006/relationships" id="256" r:id="R749d523e7458473a"/>
-    <p:sldId xmlns:r="http://schemas.openxmlformats.org/officeDocument/2006/relationships" id="257" r:id="R2dfbae2ffeed45ac"/>
-    <p:sldId xmlns:r="http://schemas.openxmlformats.org/officeDocument/2006/relationships" id="258" r:id="R3a8f793a2f3048be"/>
-    <p:sldId xmlns:r="http://schemas.openxmlformats.org/officeDocument/2006/relationships" id="259" r:id="R873e9ae212904b29"/>
-    <p:sldId xmlns:r="http://schemas.openxmlformats.org/officeDocument/2006/relationships" id="260" r:id="R07fb07e4c79c4bca"/>
-    <p:sldId xmlns:r="http://schemas.openxmlformats.org/officeDocument/2006/relationships" id="261" r:id="R4fa7c3cb80444cb9"/>
-    <p:sldId xmlns:r="http://schemas.openxmlformats.org/officeDocument/2006/relationships" id="262" r:id="R47d14dedea39418d"/>
+    <p:sldId xmlns:r="http://schemas.openxmlformats.org/officeDocument/2006/relationships" id="256" r:id="Rfc5e3d3b6d464d9f"/>
+    <p:sldId xmlns:r="http://schemas.openxmlformats.org/officeDocument/2006/relationships" id="257" r:id="R66d78493e1db47ce"/>
+    <p:sldId xmlns:r="http://schemas.openxmlformats.org/officeDocument/2006/relationships" id="258" r:id="R99ac34531c1e4518"/>
+    <p:sldId xmlns:r="http://schemas.openxmlformats.org/officeDocument/2006/relationships" id="259" r:id="R8e81d6385f3f46b1"/>
+    <p:sldId xmlns:r="http://schemas.openxmlformats.org/officeDocument/2006/relationships" id="260" r:id="R1731c5b7cd744ed8"/>
+    <p:sldId xmlns:r="http://schemas.openxmlformats.org/officeDocument/2006/relationships" id="261" r:id="R222f2d9d7d644a34"/>
+    <p:sldId xmlns:r="http://schemas.openxmlformats.org/officeDocument/2006/relationships" id="262" r:id="Rc8cf0142103b42fc"/>
+    <p:sldId xmlns:r="http://schemas.openxmlformats.org/officeDocument/2006/relationships" id="263" r:id="R157b22d670e047b7"/>
   </p:sldIdLst>
   <p:sldSz cx="12192000" cy="6858000"/>
   <p:notesSz cx="6858000" cy="9144000"/>
@@ -448,7 +449,7 @@
           <a:lstStyle xmlns:a="http://schemas.openxmlformats.org/drawingml/2006/main"/>
           <a:p xmlns:a="http://schemas.openxmlformats.org/drawingml/2006/main">
             <a:r>
-              <a:t>25 seconds</a:t>
+              <a:t>20 seconds</a:t>
             </a:r>
           </a:p>
           <a:p xmlns:a="http://schemas.openxmlformats.org/drawingml/2006/main">
@@ -458,7 +459,7 @@
           </a:p>
           <a:p xmlns:a="http://schemas.openxmlformats.org/drawingml/2006/main">
             <a:r>
-              <a:t>I'm John. I work on research software at Dartmouth's Center for Open Neuroscience. I use coding agents to build software, explore ideas, and prepare talks like this one. Tonight I want to show a few things I've made and the question connecting them: when an agent produces something, what would let another person understand it and trust it?</a:t>
+              <a:t>I'm John. I work on research software at Dartmouth's Center for Open Neuroscience. I use coding agents to build software, explore ideas, and prepare talks. Here are a few things I've made, connected by one question: what would let another person understand an agent's work and trust it?</a:t>
             </a:r>
           </a:p>
           <a:p xmlns:a="http://schemas.openxmlformats.org/drawingml/2006/main">
@@ -543,7 +544,7 @@
           <a:lstStyle xmlns:a="http://schemas.openxmlformats.org/drawingml/2006/main"/>
           <a:p xmlns:a="http://schemas.openxmlformats.org/drawingml/2006/main">
             <a:r>
-              <a:t>45 seconds</a:t>
+              <a:t>35 seconds</a:t>
             </a:r>
           </a:p>
           <a:p xmlns:a="http://schemas.openxmlformats.org/drawingml/2006/main">
@@ -553,7 +554,7 @@
           </a:p>
           <a:p xmlns:a="http://schemas.openxmlformats.org/drawingml/2006/main">
             <a:r>
-              <a:t>The agent is only part of my setup. Codex works with the actual project files and terminal. Skills are reusable instructions for a particular kind of work, while Markdown keeps the goal and important decisions visible. Git records changes. Worktrees let me try things separately without mixing unfinished changes together. Pixi describes the software environment, and DataLad connects data and code with their history. When I need execution records, duct captures what a command did. These tools give the agent something concrete to act on, and give me something concrete to check. The skill workshop and worktree utilities are linked here if you want to explore them.</a:t>
+              <a:t>Codex works with my actual project files and terminal. Skills are reusable instructions, while Markdown keeps the goal and decisions visible. Git records changes, and worktrees keep separate experiments from mixing together. Pixi describes the software environment, and DataLad connects data and code with their history. When I need execution records, duct captures what a command did. These tools give the agent something concrete to act on, and give me something concrete to check. My skill workshop and worktree utilities are linked here.</a:t>
             </a:r>
           </a:p>
           <a:p xmlns:a="http://schemas.openxmlformats.org/drawingml/2006/main">
@@ -648,7 +649,7 @@
           <a:lstStyle xmlns:a="http://schemas.openxmlformats.org/drawingml/2006/main"/>
           <a:p xmlns:a="http://schemas.openxmlformats.org/drawingml/2006/main">
             <a:r>
-              <a:t>45 seconds</a:t>
+              <a:t>35 seconds</a:t>
             </a:r>
           </a:p>
           <a:p xmlns:a="http://schemas.openxmlformats.org/drawingml/2006/main">
@@ -658,7 +659,7 @@
           </a:p>
           <a:p xmlns:a="http://schemas.openxmlformats.org/drawingml/2006/main">
             <a:r>
-              <a:t>This is The Software Engineer Reborn, a talk I prepared for the Williamsburg software community. On the left is the preparation: a Talk Atlas where I can compare possible narratives and follow source notes. On the right is the presentation that came out of that process. Making a tool to think with became part of making the talk. The question I kept coming back to was about my own role. As the machine produces more implementation, I spend more attention on defining the problem, selecting evidence, and deciding which work I can actually stand behind. Both the preparation and the finished slides are public.</a:t>
+              <a:t>Keyhatch tackles a very practical interruption: an agent needs a credential to do useful work. I'm building a native Mac app where I approve selected credentials once, then allow repeated retrieval during a limited window. Apple Passwords remains the source of truth, with selective import into Keyhatch. A local command-line client connects the agent to the broker. The important tradeoff is that a recipient can keep a disclosed secret. Expiry stops future retrieval; it cannot take that secret back. It's an experimental project with public source. Production signing and release validation remain unfinished.</a:t>
             </a:r>
           </a:p>
           <a:p xmlns:a="http://schemas.openxmlformats.org/drawingml/2006/main">
@@ -673,17 +674,17 @@
           </a:p>
           <a:p xmlns:a="http://schemas.openxmlformats.org/drawingml/2006/main">
             <a:r>
-              <a:t>https://software-engineer-reborn-atlas.johnlee3728739.chatgpt.site/</a:t>
-            </a:r>
-          </a:p>
-          <a:p xmlns:a="http://schemas.openxmlformats.org/drawingml/2006/main">
-            <a:r>
-              <a:t>https://leej3.github.io/software-engineer-reborn/</a:t>
-            </a:r>
-          </a:p>
-          <a:p xmlns:a="http://schemas.openxmlformats.org/drawingml/2006/main">
-            <a:r>
-              <a:t>https://github.com/leej3/software-engineer-reborn/tree/main/talk-concepts</a:t>
+              <a:t>https://github.com/leej3/keyhatch</a:t>
+            </a:r>
+          </a:p>
+          <a:p xmlns:a="http://schemas.openxmlformats.org/drawingml/2006/main">
+            <a:r>
+              <a:t>https://github.com/leej3/keyhatch/blob/main/SECURITY.md</a:t>
+            </a:r>
+          </a:p>
+          <a:p xmlns:a="http://schemas.openxmlformats.org/drawingml/2006/main">
+            <a:r>
+              <a:t>https://github.com/leej3/keyhatch/blob/main/docs/DISTRIBUTION.md</a:t>
             </a:r>
           </a:p>
         </p:txBody>
@@ -753,7 +754,7 @@
           <a:lstStyle xmlns:a="http://schemas.openxmlformats.org/drawingml/2006/main"/>
           <a:p xmlns:a="http://schemas.openxmlformats.org/drawingml/2006/main">
             <a:r>
-              <a:t>45 seconds</a:t>
+              <a:t>40 seconds</a:t>
             </a:r>
           </a:p>
           <a:p xmlns:a="http://schemas.openxmlformats.org/drawingml/2006/main">
@@ -763,7 +764,7 @@
           </a:p>
           <a:p xmlns:a="http://schemas.openxmlformats.org/drawingml/2006/main">
             <a:r>
-              <a:t>The next talk asks, 'What did we just make?' A figure or a report is only the visible result. The useful object also includes the inputs, code, decisions, and environment needed to inspect it or run it again. Our team's STAMPED principles give us a vocabulary for that package: self-contained, tracked, actionable, modular, portable, ephemeral, and distributable. In plain terms: can I get the pieces, see their history, run the procedure, and recover a useful state somewhere else? This matters beyond science. An AI-generated website, spreadsheet, or presentation also needs enough context for the next person to understand what they have.</a:t>
+              <a:t>This is The Software Engineer Reborn, a talk for the Williamsburg software community. On the left is the preparation: a Talk Atlas for comparing narratives and following source notes. On the right is the presentation. Making a tool to think with became part of making the talk. The question was about my own role. As the machine produces more implementation, I spend more attention on defining the problem, selecting evidence, and deciding which work I can stand behind. Both the preparation and the finished slides are public.</a:t>
             </a:r>
           </a:p>
           <a:p xmlns:a="http://schemas.openxmlformats.org/drawingml/2006/main">
@@ -778,17 +779,17 @@
           </a:p>
           <a:p xmlns:a="http://schemas.openxmlformats.org/drawingml/2006/main">
             <a:r>
-              <a:t>https://research-object-with-ai.pages.dev/</a:t>
-            </a:r>
-          </a:p>
-          <a:p xmlns:a="http://schemas.openxmlformats.org/drawingml/2006/main">
-            <a:r>
-              <a:t>https://github.com/leej3/research-object-with-ai</a:t>
-            </a:r>
-          </a:p>
-          <a:p xmlns:a="http://schemas.openxmlformats.org/drawingml/2006/main">
-            <a:r>
-              <a:t>https://stamped-principles.org/</a:t>
+              <a:t>https://software-engineer-reborn-atlas.johnlee3728739.chatgpt.site/</a:t>
+            </a:r>
+          </a:p>
+          <a:p xmlns:a="http://schemas.openxmlformats.org/drawingml/2006/main">
+            <a:r>
+              <a:t>https://leej3.github.io/software-engineer-reborn/</a:t>
+            </a:r>
+          </a:p>
+          <a:p xmlns:a="http://schemas.openxmlformats.org/drawingml/2006/main">
+            <a:r>
+              <a:t>https://github.com/leej3/software-engineer-reborn/tree/main/talk-concepts</a:t>
             </a:r>
           </a:p>
         </p:txBody>
@@ -858,7 +859,7 @@
           <a:lstStyle xmlns:a="http://schemas.openxmlformats.org/drawingml/2006/main"/>
           <a:p xmlns:a="http://schemas.openxmlformats.org/drawingml/2006/main">
             <a:r>
-              <a:t>55 seconds</a:t>
+              <a:t>40 seconds</a:t>
             </a:r>
           </a:p>
           <a:p xmlns:a="http://schemas.openxmlformats.org/drawingml/2006/main">
@@ -868,7 +869,7 @@
           </a:p>
           <a:p xmlns:a="http://schemas.openxmlformats.org/drawingml/2006/main">
             <a:r>
-              <a:t>Orinoco Lite is one example of software I've been working on with agents. Research groups have information about people, projects, publications, and software scattered across many places. Here those things become structured records with explicit relationships. The website and this graph are different views of those records. An editor can propose a change through GitHub so the proposal and its review have a visible history. It builds on the upstream ORINOCO work, with a lighter Git-backed deployment. What interests me is the shared context: people can browse it, software can validate it, and agents can work with a clearer description of what the group knows. The screenshot is saved here, so this example doesn't depend on tonight's Wi-Fi.</a:t>
+              <a:t>The next talk asks, 'What did we just make?' A figure or report is only the visible result. The useful object also includes the inputs, code, decisions, and environment needed to inspect or rerun it. Our team's STAMPED principles give us a vocabulary: self-contained, tracked, actionable, modular, portable, ephemeral, and distributable. In plain terms: can I get the pieces, see their history, run the procedure, and recover a useful state elsewhere? This matters beyond science. An AI-generated website or spreadsheet also needs enough context for the next person.</a:t>
             </a:r>
           </a:p>
           <a:p xmlns:a="http://schemas.openxmlformats.org/drawingml/2006/main">
@@ -883,17 +884,17 @@
           </a:p>
           <a:p xmlns:a="http://schemas.openxmlformats.org/drawingml/2006/main">
             <a:r>
-              <a:t>https://github.com/ORINOCO-Lite/orinoco-lite-dev</a:t>
-            </a:r>
-          </a:p>
-          <a:p xmlns:a="http://schemas.openxmlformats.org/drawingml/2006/main">
-            <a:r>
-              <a:t>https://dev.centerforopenneuroscience.org/explore/</a:t>
-            </a:r>
-          </a:p>
-          <a:p xmlns:a="http://schemas.openxmlformats.org/drawingml/2006/main">
-            <a:r>
-              <a:t>https://doi.org/10.5281/zenodo.22834595</a:t>
+              <a:t>https://research-object-with-ai.pages.dev/</a:t>
+            </a:r>
+          </a:p>
+          <a:p xmlns:a="http://schemas.openxmlformats.org/drawingml/2006/main">
+            <a:r>
+              <a:t>https://github.com/leej3/research-object-with-ai</a:t>
+            </a:r>
+          </a:p>
+          <a:p xmlns:a="http://schemas.openxmlformats.org/drawingml/2006/main">
+            <a:r>
+              <a:t>https://stamped-principles.org/</a:t>
             </a:r>
           </a:p>
         </p:txBody>
@@ -963,7 +964,7 @@
           <a:lstStyle xmlns:a="http://schemas.openxmlformats.org/drawingml/2006/main"/>
           <a:p xmlns:a="http://schemas.openxmlformats.org/drawingml/2006/main">
             <a:r>
-              <a:t>60 seconds</a:t>
+              <a:t>50 seconds</a:t>
             </a:r>
           </a:p>
           <a:p xmlns:a="http://schemas.openxmlformats.org/drawingml/2006/main">
@@ -973,7 +974,7 @@
           </a:p>
           <a:p xmlns:a="http://schemas.openxmlformats.org/drawingml/2006/main">
             <a:r>
-              <a:t>The Zenodo record describes the original STAMPED in Practice proposal. The current poster PR captures the later public-data pilot, with working analyses and concrete failures to learn from. The next repository develops a repeated improvement process. Independent agents tackle the same scientific question under four kinds of assistance: baseline, general skill discovery, reproducibility-focused discovery, and explicit STAMPED skills. Independent judges assess scientific quality separately from how well the research object supports inspection and reuse. We then improve the skills and try again, keeping assessment fixed within a formal comparison. NARPS preparation pilots are already exposing useful problems. The hypothesis is that detailed STAMPED guidance improves performance and reduces inconsistent outcomes. The goal is transfer: a researcher brings their own data and hypothesis, and an independent agent can use these skills to do rigorous, convenient research. That improvement remains to be tested.</a:t>
+              <a:t>Orinoco Lite is software I've been working on with agents. Research groups have information about people, projects, publications, and software scattered across many places. Here those become structured records with explicit relationships. The website and this graph are different views of those records. An editor proposes changes through GitHub, preserving a visible review history. It builds on upstream ORINOCO with a lighter Git-backed deployment. What interests me is shared context: people can browse it, software can validate it, and agents can work with a clearer description of what the group knows. This screenshot is saved, so the example works without Wi-Fi.</a:t>
             </a:r>
           </a:p>
           <a:p xmlns:a="http://schemas.openxmlformats.org/drawingml/2006/main">
@@ -988,22 +989,17 @@
           </a:p>
           <a:p xmlns:a="http://schemas.openxmlformats.org/drawingml/2006/main">
             <a:r>
-              <a:t>https://github.com/con/talks/pull/35</a:t>
-            </a:r>
-          </a:p>
-          <a:p xmlns:a="http://schemas.openxmlformats.org/drawingml/2006/main">
-            <a:r>
-              <a:t>https://zenodo.org/records/22833916</a:t>
-            </a:r>
-          </a:p>
-          <a:p xmlns:a="http://schemas.openxmlformats.org/drawingml/2006/main">
-            <a:r>
-              <a:t>https://github.com/leej3/stamped-ai-research-next</a:t>
-            </a:r>
-          </a:p>
-          <a:p xmlns:a="http://schemas.openxmlformats.org/drawingml/2006/main">
-            <a:r>
-              <a:t>https://github.com/leej3/stamped-ai-research-next/pull/3</a:t>
+              <a:t>https://github.com/ORINOCO-Lite/orinoco-lite-dev</a:t>
+            </a:r>
+          </a:p>
+          <a:p xmlns:a="http://schemas.openxmlformats.org/drawingml/2006/main">
+            <a:r>
+              <a:t>https://dev.centerforopenneuroscience.org/explore/</a:t>
+            </a:r>
+          </a:p>
+          <a:p xmlns:a="http://schemas.openxmlformats.org/drawingml/2006/main">
+            <a:r>
+              <a:t>https://doi.org/10.5281/zenodo.22834595</a:t>
             </a:r>
           </a:p>
         </p:txBody>
@@ -1073,6 +1069,116 @@
           <a:lstStyle xmlns:a="http://schemas.openxmlformats.org/drawingml/2006/main"/>
           <a:p xmlns:a="http://schemas.openxmlformats.org/drawingml/2006/main">
             <a:r>
+              <a:t>55 seconds</a:t>
+            </a:r>
+          </a:p>
+          <a:p xmlns:a="http://schemas.openxmlformats.org/drawingml/2006/main">
+            <a:r>
+              <a:t/>
+            </a:r>
+          </a:p>
+          <a:p xmlns:a="http://schemas.openxmlformats.org/drawingml/2006/main">
+            <a:r>
+              <a:t>The Zenodo record describes the original STAMPED in Practice proposal. The current poster PR captures the later public-data pilot, with working analyses and concrete failures to learn from. The next repository develops a repeated improvement process. Independent agents tackle the same scientific question under four kinds of assistance: baseline, general skill discovery, reproducibility-focused discovery, and explicit STAMPED skills. Independent judges assess scientific quality separately from how well the research object supports inspection and reuse. We then improve the skills and try again, keeping assessment fixed within a formal comparison. NARPS preparation pilots are already exposing useful problems. The hypothesis is that detailed STAMPED guidance improves performance and reduces inconsistent outcomes. The goal is transfer: a researcher brings their own data and hypothesis, and an independent agent can use these skills to do rigorous, convenient research. That improvement remains to be tested.</a:t>
+            </a:r>
+          </a:p>
+          <a:p xmlns:a="http://schemas.openxmlformats.org/drawingml/2006/main">
+            <a:r>
+              <a:t/>
+            </a:r>
+          </a:p>
+          <a:p xmlns:a="http://schemas.openxmlformats.org/drawingml/2006/main">
+            <a:r>
+              <a:t>Sources:</a:t>
+            </a:r>
+          </a:p>
+          <a:p xmlns:a="http://schemas.openxmlformats.org/drawingml/2006/main">
+            <a:r>
+              <a:t>https://github.com/con/talks/pull/35</a:t>
+            </a:r>
+          </a:p>
+          <a:p xmlns:a="http://schemas.openxmlformats.org/drawingml/2006/main">
+            <a:r>
+              <a:t>https://zenodo.org/records/22833916</a:t>
+            </a:r>
+          </a:p>
+          <a:p xmlns:a="http://schemas.openxmlformats.org/drawingml/2006/main">
+            <a:r>
+              <a:t>https://github.com/leej3/stamped-ai-research-next</a:t>
+            </a:r>
+          </a:p>
+          <a:p xmlns:a="http://schemas.openxmlformats.org/drawingml/2006/main">
+            <a:r>
+              <a:t>https://github.com/leej3/stamped-ai-research-next/pull/3</a:t>
+            </a:r>
+          </a:p>
+        </p:txBody>
+      </p:sp>
+      <p:sp>
+        <p:nvSpPr>
+          <p:cNvPr id="4" name="Slide Number Placeholder 3"/>
+          <p:cNvSpPr>
+            <a:spLocks xmlns:a="http://schemas.openxmlformats.org/drawingml/2006/main" noGrp="1"/>
+          </p:cNvSpPr>
+          <p:nvPr>
+            <p:ph type="sldNum" idx="5"/>
+          </p:nvPr>
+        </p:nvSpPr>
+        <p:spPr/>
+        <p:txBody>
+          <a:bodyPr xmlns:a="http://schemas.openxmlformats.org/drawingml/2006/main"/>
+          <a:lstStyle xmlns:a="http://schemas.openxmlformats.org/drawingml/2006/main"/>
+          <a:p xmlns:a="http://schemas.openxmlformats.org/drawingml/2006/main"/>
+        </p:txBody>
+      </p:sp>
+    </p:spTree>
+  </p:cSld>
+  <p:clrMapOvr>
+    <a:masterClrMapping xmlns:a="http://schemas.openxmlformats.org/drawingml/2006/main"/>
+  </p:clrMapOvr>
+</p:notes>
+</file>
+
+<file path=ppt/notesSlides/notesSlide8.xml><?xml version="1.0" encoding="utf-8"?>
+<p:notes xmlns:p="http://schemas.openxmlformats.org/presentationml/2006/main">
+  <p:cSld>
+    <p:spTree>
+      <p:nvGrpSpPr>
+        <p:cNvPr id="1" name=""/>
+        <p:cNvGrpSpPr/>
+        <p:nvPr/>
+      </p:nvGrpSpPr>
+      <p:grpSpPr>
+        <a:xfrm xmlns:a="http://schemas.openxmlformats.org/drawingml/2006/main"/>
+      </p:grpSpPr>
+      <p:sp>
+        <p:nvSpPr>
+          <p:cNvPr id="2" name="Slide Image Placeholder 1"/>
+          <p:cNvSpPr>
+            <a:spLocks xmlns:a="http://schemas.openxmlformats.org/drawingml/2006/main" noGrp="1"/>
+          </p:cNvSpPr>
+          <p:nvPr>
+            <p:ph type="sldImg" idx="0"/>
+          </p:nvPr>
+        </p:nvSpPr>
+        <p:spPr/>
+      </p:sp>
+      <p:sp>
+        <p:nvSpPr>
+          <p:cNvPr id="3" name="Notes Placeholder 2"/>
+          <p:cNvSpPr>
+            <a:spLocks xmlns:a="http://schemas.openxmlformats.org/drawingml/2006/main" noGrp="1"/>
+          </p:cNvSpPr>
+          <p:nvPr>
+            <p:ph type="body" idx="1"/>
+          </p:nvPr>
+        </p:nvSpPr>
+        <p:spPr/>
+        <p:txBody>
+          <a:bodyPr xmlns:a="http://schemas.openxmlformats.org/drawingml/2006/main"/>
+          <a:lstStyle xmlns:a="http://schemas.openxmlformats.org/drawingml/2006/main"/>
+          <a:p xmlns:a="http://schemas.openxmlformats.org/drawingml/2006/main">
+            <a:r>
               <a:t>25 seconds</a:t>
             </a:r>
           </a:p>
@@ -1145,7 +1251,7 @@
           <p:cNvPr id="3" name="Title">
             <a:extLst xmlns:a="http://schemas.openxmlformats.org/drawingml/2006/main">
               <a:ext uri="{FF2B5EF4-FFF2-40B4-BE49-F238E27FC236}">
-                <a16:creationId xmlns:a16="http://schemas.microsoft.com/office/drawing/2014/main" id="{5ECE8D01-FB4C-4D9C-B704-A3837453582F}"/>
+                <a16:creationId xmlns:a16="http://schemas.microsoft.com/office/drawing/2014/main" id="{4E4518CF-BC3F-4B78-B237-C3894CA6AB74}"/>
               </a:ext>
             </a:extLst>
           </p:cNvPr>
@@ -1302,7 +1408,7 @@
           <p:cNvPr id="2" name="Subtitle">
             <a:extLst xmlns:a="http://schemas.openxmlformats.org/drawingml/2006/main">
               <a:ext uri="{FF2B5EF4-FFF2-40B4-BE49-F238E27FC236}">
-                <a16:creationId xmlns:a16="http://schemas.microsoft.com/office/drawing/2014/main" id="{4806A889-460C-46BB-8177-4426DF3F9C4B}"/>
+                <a16:creationId xmlns:a16="http://schemas.microsoft.com/office/drawing/2014/main" id="{3A4FFE00-26A2-4312-8565-445CFACD4754}"/>
               </a:ext>
             </a:extLst>
           </p:cNvPr>
@@ -1476,7 +1582,7 @@
           <p:cNvPr id="2" name="Section title">
             <a:extLst xmlns:a="http://schemas.openxmlformats.org/drawingml/2006/main">
               <a:ext uri="{FF2B5EF4-FFF2-40B4-BE49-F238E27FC236}">
-                <a16:creationId xmlns:a16="http://schemas.microsoft.com/office/drawing/2014/main" id="{A16E0ED1-41E4-47CB-82A9-0AC96ED452F7}"/>
+                <a16:creationId xmlns:a16="http://schemas.microsoft.com/office/drawing/2014/main" id="{C7A3BD07-A82A-4692-9B36-EFAD767C262C}"/>
               </a:ext>
             </a:extLst>
           </p:cNvPr>
@@ -1650,7 +1756,7 @@
           <p:cNvPr id="3" name="Title">
             <a:extLst xmlns:a="http://schemas.openxmlformats.org/drawingml/2006/main">
               <a:ext uri="{FF2B5EF4-FFF2-40B4-BE49-F238E27FC236}">
-                <a16:creationId xmlns:a16="http://schemas.microsoft.com/office/drawing/2014/main" id="{C4DE3FC7-49F9-406B-91D8-3F77D8F755E9}"/>
+                <a16:creationId xmlns:a16="http://schemas.microsoft.com/office/drawing/2014/main" id="{88493432-C963-40B7-BF64-2CBAD824E798}"/>
               </a:ext>
             </a:extLst>
           </p:cNvPr>
@@ -1807,7 +1913,7 @@
           <p:cNvPr id="2" name="Body">
             <a:extLst xmlns:a="http://schemas.openxmlformats.org/drawingml/2006/main">
               <a:ext uri="{FF2B5EF4-FFF2-40B4-BE49-F238E27FC236}">
-                <a16:creationId xmlns:a16="http://schemas.microsoft.com/office/drawing/2014/main" id="{9BCEBBCF-5B52-4E79-A2D7-D73A1EEAC9F5}"/>
+                <a16:creationId xmlns:a16="http://schemas.microsoft.com/office/drawing/2014/main" id="{74592EEB-5B82-4D45-876F-DA34C1A4FCDC}"/>
               </a:ext>
             </a:extLst>
           </p:cNvPr>
@@ -1981,7 +2087,7 @@
           <p:cNvPr id="4" name="Title">
             <a:extLst xmlns:a="http://schemas.openxmlformats.org/drawingml/2006/main">
               <a:ext uri="{FF2B5EF4-FFF2-40B4-BE49-F238E27FC236}">
-                <a16:creationId xmlns:a16="http://schemas.microsoft.com/office/drawing/2014/main" id="{F649052D-577D-4D42-BD86-59F9E93A56CE}"/>
+                <a16:creationId xmlns:a16="http://schemas.microsoft.com/office/drawing/2014/main" id="{45298BBF-5C26-40AD-BC32-1EE80D8EDC1A}"/>
               </a:ext>
             </a:extLst>
           </p:cNvPr>
@@ -2138,7 +2244,7 @@
           <p:cNvPr id="2" name="Left column">
             <a:extLst xmlns:a="http://schemas.openxmlformats.org/drawingml/2006/main">
               <a:ext uri="{FF2B5EF4-FFF2-40B4-BE49-F238E27FC236}">
-                <a16:creationId xmlns:a16="http://schemas.microsoft.com/office/drawing/2014/main" id="{00BA8127-20FD-4BD1-A777-EA0A0474EB78}"/>
+                <a16:creationId xmlns:a16="http://schemas.microsoft.com/office/drawing/2014/main" id="{EFAFC491-C6D4-4B55-98DA-C6B4E2799DCA}"/>
               </a:ext>
             </a:extLst>
           </p:cNvPr>
@@ -2295,7 +2401,7 @@
           <p:cNvPr id="3" name="Right column">
             <a:extLst xmlns:a="http://schemas.openxmlformats.org/drawingml/2006/main">
               <a:ext uri="{FF2B5EF4-FFF2-40B4-BE49-F238E27FC236}">
-                <a16:creationId xmlns:a16="http://schemas.microsoft.com/office/drawing/2014/main" id="{3EFFBCCD-F472-4D35-A089-6A2C38365833}"/>
+                <a16:creationId xmlns:a16="http://schemas.microsoft.com/office/drawing/2014/main" id="{2EC7EF62-CA19-463B-A506-FE07BF181777}"/>
               </a:ext>
             </a:extLst>
           </p:cNvPr>
@@ -2469,7 +2575,7 @@
           <p:cNvPr id="3" name="Title">
             <a:extLst xmlns:a="http://schemas.openxmlformats.org/drawingml/2006/main">
               <a:ext uri="{FF2B5EF4-FFF2-40B4-BE49-F238E27FC236}">
-                <a16:creationId xmlns:a16="http://schemas.microsoft.com/office/drawing/2014/main" id="{AFEBE894-459E-47D3-ADC6-4B7C7DB1E6E2}"/>
+                <a16:creationId xmlns:a16="http://schemas.microsoft.com/office/drawing/2014/main" id="{9580E713-A8CB-41D9-B5D9-87A86A71BF65}"/>
               </a:ext>
             </a:extLst>
           </p:cNvPr>
@@ -2626,7 +2732,7 @@
           <p:cNvPr id="2" name="Left column">
             <a:extLst xmlns:a="http://schemas.openxmlformats.org/drawingml/2006/main">
               <a:ext uri="{FF2B5EF4-FFF2-40B4-BE49-F238E27FC236}">
-                <a16:creationId xmlns:a16="http://schemas.microsoft.com/office/drawing/2014/main" id="{1C76E4EE-96E6-4B9D-AF74-1C696BCF46ED}"/>
+                <a16:creationId xmlns:a16="http://schemas.microsoft.com/office/drawing/2014/main" id="{6F0E5CC1-4811-4B27-8358-A5D5F518AD0E}"/>
               </a:ext>
             </a:extLst>
           </p:cNvPr>
@@ -2821,12 +2927,12 @@
   </p:cSld>
   <p:clrMap bg1="lt1" tx1="dk1" bg2="lt2" tx2="dk2" accent1="accent1" accent2="accent2" accent3="accent3" accent4="accent4" accent5="accent5" accent6="accent6" hlink="hlink" folHlink="folHlink"/>
   <p:sldLayoutIdLst>
-    <p:sldLayoutId xmlns:r="http://schemas.openxmlformats.org/officeDocument/2006/relationships" id="2147483649" r:id="Rf403ba8ca94347fd"/>
-    <p:sldLayoutId xmlns:r="http://schemas.openxmlformats.org/officeDocument/2006/relationships" id="2147483650" r:id="Re022c7244d79476a"/>
-    <p:sldLayoutId xmlns:r="http://schemas.openxmlformats.org/officeDocument/2006/relationships" id="2147483651" r:id="R54c9351805a94bdc"/>
-    <p:sldLayoutId xmlns:r="http://schemas.openxmlformats.org/officeDocument/2006/relationships" id="2147483652" r:id="Rfc5c57888a714361"/>
-    <p:sldLayoutId xmlns:r="http://schemas.openxmlformats.org/officeDocument/2006/relationships" id="2147483653" r:id="R2f56d0f86ca04b16"/>
-    <p:sldLayoutId xmlns:r="http://schemas.openxmlformats.org/officeDocument/2006/relationships" id="2147483654" r:id="R29e3a51d257c4342"/>
+    <p:sldLayoutId xmlns:r="http://schemas.openxmlformats.org/officeDocument/2006/relationships" id="2147483649" r:id="Ra04a6f6efe8c4b1c"/>
+    <p:sldLayoutId xmlns:r="http://schemas.openxmlformats.org/officeDocument/2006/relationships" id="2147483650" r:id="Re6b9c4cb988343a1"/>
+    <p:sldLayoutId xmlns:r="http://schemas.openxmlformats.org/officeDocument/2006/relationships" id="2147483651" r:id="Rbc2c4864150047f8"/>
+    <p:sldLayoutId xmlns:r="http://schemas.openxmlformats.org/officeDocument/2006/relationships" id="2147483652" r:id="Ra8d76696bc224fa5"/>
+    <p:sldLayoutId xmlns:r="http://schemas.openxmlformats.org/officeDocument/2006/relationships" id="2147483653" r:id="R517eac0797804bc3"/>
+    <p:sldLayoutId xmlns:r="http://schemas.openxmlformats.org/officeDocument/2006/relationships" id="2147483654" r:id="Ra28a71cb58f341b6"/>
   </p:sldLayoutIdLst>
   <p:txStyles>
     <p:titleStyle>
@@ -3377,7 +3483,7 @@
           <p:cNvPr id="6" name="">
             <a:extLst xmlns:a="http://schemas.openxmlformats.org/drawingml/2006/main">
               <a:ext uri="{FF2B5EF4-FFF2-40B4-BE49-F238E27FC236}">
-                <a16:creationId xmlns:a16="http://schemas.microsoft.com/office/drawing/2014/main" id="{B9B93178-11BE-421C-BDF7-5E746B75AEB7}"/>
+                <a16:creationId xmlns:a16="http://schemas.microsoft.com/office/drawing/2014/main" id="{EF190C9F-6E11-42E2-B8A7-F59D633ADA81}"/>
               </a:ext>
             </a:extLst>
           </p:cNvPr>
@@ -3466,7 +3572,7 @@
           <p:cNvPr id="2" name="">
             <a:extLst xmlns:a="http://schemas.openxmlformats.org/drawingml/2006/main">
               <a:ext uri="{FF2B5EF4-FFF2-40B4-BE49-F238E27FC236}">
-                <a16:creationId xmlns:a16="http://schemas.microsoft.com/office/drawing/2014/main" id="{504FEA83-5323-4ED2-9921-75B9C9F08FB7}"/>
+                <a16:creationId xmlns:a16="http://schemas.microsoft.com/office/drawing/2014/main" id="{406AA874-36E2-4058-886E-086C5F4C61D1}"/>
               </a:ext>
             </a:extLst>
           </p:cNvPr>
@@ -3555,7 +3661,7 @@
           <p:cNvPr id="3" name="">
             <a:extLst xmlns:a="http://schemas.openxmlformats.org/drawingml/2006/main">
               <a:ext uri="{FF2B5EF4-FFF2-40B4-BE49-F238E27FC236}">
-                <a16:creationId xmlns:a16="http://schemas.microsoft.com/office/drawing/2014/main" id="{50686B55-436A-4470-B2B2-98B829178561}"/>
+                <a16:creationId xmlns:a16="http://schemas.microsoft.com/office/drawing/2014/main" id="{7A9F030E-1C9F-4BB3-9760-F372D37D8BC4}"/>
               </a:ext>
             </a:extLst>
           </p:cNvPr>
@@ -3621,7 +3727,7 @@
           <p:cNvPr id="4" name="">
             <a:extLst xmlns:a="http://schemas.openxmlformats.org/drawingml/2006/main">
               <a:ext uri="{FF2B5EF4-FFF2-40B4-BE49-F238E27FC236}">
-                <a16:creationId xmlns:a16="http://schemas.microsoft.com/office/drawing/2014/main" id="{A6451C44-E404-4414-A73C-207503B50DA0}"/>
+                <a16:creationId xmlns:a16="http://schemas.microsoft.com/office/drawing/2014/main" id="{ACF4AEBB-4099-4324-AC06-EEE53DA6CE70}"/>
               </a:ext>
             </a:extLst>
           </p:cNvPr>
@@ -3710,7 +3816,7 @@
           <p:cNvPr id="5" name="">
             <a:extLst xmlns:a="http://schemas.openxmlformats.org/drawingml/2006/main">
               <a:ext uri="{FF2B5EF4-FFF2-40B4-BE49-F238E27FC236}">
-                <a16:creationId xmlns:a16="http://schemas.microsoft.com/office/drawing/2014/main" id="{5D331664-C019-4CED-887A-CB51C89BEECF}"/>
+                <a16:creationId xmlns:a16="http://schemas.microsoft.com/office/drawing/2014/main" id="{96CBFE16-70B9-44B3-88E4-E841BF0A32A2}"/>
               </a:ext>
             </a:extLst>
           </p:cNvPr>
@@ -3720,7 +3826,7 @@
           <p:nvPr/>
         </p:nvPicPr>
         <p:blipFill>
-          <a:blip xmlns:r="http://schemas.openxmlformats.org/officeDocument/2006/relationships" xmlns:a="http://schemas.openxmlformats.org/drawingml/2006/main" r:embed="Ra0351631c91e443e"/>
+          <a:blip xmlns:r="http://schemas.openxmlformats.org/officeDocument/2006/relationships" xmlns:a="http://schemas.openxmlformats.org/drawingml/2006/main" r:embed="R9ab39f1b2f744979"/>
           <a:stretch xmlns:a="http://schemas.openxmlformats.org/drawingml/2006/main"/>
         </p:blipFill>
         <p:spPr>
@@ -3736,7 +3842,7 @@
     </p:spTree>
     <p:extLst>
       <p:ext uri="{BB962C8B-B14F-4D97-AF65-F5344CB8AC3E}">
-        <p14:creationId xmlns:p14="http://schemas.microsoft.com/office/powerpoint/2010/main" val="1428541225"/>
+        <p14:creationId xmlns:p14="http://schemas.microsoft.com/office/powerpoint/2010/main" val="1036525785"/>
       </p:ext>
     </p:extLst>
   </p:cSld>
@@ -3767,7 +3873,7 @@
           <p:cNvPr id="13" name="">
             <a:extLst xmlns:a="http://schemas.openxmlformats.org/drawingml/2006/main">
               <a:ext uri="{FF2B5EF4-FFF2-40B4-BE49-F238E27FC236}">
-                <a16:creationId xmlns:a16="http://schemas.microsoft.com/office/drawing/2014/main" id="{C9B10118-3D44-4394-954C-0442B24D539B}"/>
+                <a16:creationId xmlns:a16="http://schemas.microsoft.com/office/drawing/2014/main" id="{EF76398E-4902-45B3-B513-2548BC942CE6}"/>
               </a:ext>
             </a:extLst>
           </p:cNvPr>
@@ -3833,7 +3939,7 @@
           <p:cNvPr id="2" name="">
             <a:extLst xmlns:a="http://schemas.openxmlformats.org/drawingml/2006/main">
               <a:ext uri="{FF2B5EF4-FFF2-40B4-BE49-F238E27FC236}">
-                <a16:creationId xmlns:a16="http://schemas.microsoft.com/office/drawing/2014/main" id="{4FA4E031-A99A-4AD1-85E4-4C94524DC299}"/>
+                <a16:creationId xmlns:a16="http://schemas.microsoft.com/office/drawing/2014/main" id="{C4BEC4A7-482E-49FC-918A-A3C2B54554F1}"/>
               </a:ext>
             </a:extLst>
           </p:cNvPr>
@@ -3899,7 +4005,7 @@
           <p:cNvPr id="3" name="">
             <a:extLst xmlns:a="http://schemas.openxmlformats.org/drawingml/2006/main">
               <a:ext uri="{FF2B5EF4-FFF2-40B4-BE49-F238E27FC236}">
-                <a16:creationId xmlns:a16="http://schemas.microsoft.com/office/drawing/2014/main" id="{E2456E1E-2B78-485E-A4FA-449B4B6CE55B}"/>
+                <a16:creationId xmlns:a16="http://schemas.microsoft.com/office/drawing/2014/main" id="{DA8978B5-77AD-4BAE-9FA8-8CCAC2B2848D}"/>
               </a:ext>
             </a:extLst>
           </p:cNvPr>
@@ -3965,7 +4071,7 @@
           <p:cNvPr id="4" name="">
             <a:extLst xmlns:a="http://schemas.openxmlformats.org/drawingml/2006/main">
               <a:ext uri="{FF2B5EF4-FFF2-40B4-BE49-F238E27FC236}">
-                <a16:creationId xmlns:a16="http://schemas.microsoft.com/office/drawing/2014/main" id="{532FA51B-C550-4923-93BB-656A63EE06DD}"/>
+                <a16:creationId xmlns:a16="http://schemas.microsoft.com/office/drawing/2014/main" id="{67384A87-8A2F-4CE0-93C1-99B10F7092DE}"/>
               </a:ext>
             </a:extLst>
           </p:cNvPr>
@@ -4031,7 +4137,7 @@
           <p:cNvPr id="5" name="">
             <a:extLst xmlns:a="http://schemas.openxmlformats.org/drawingml/2006/main">
               <a:ext uri="{FF2B5EF4-FFF2-40B4-BE49-F238E27FC236}">
-                <a16:creationId xmlns:a16="http://schemas.microsoft.com/office/drawing/2014/main" id="{84709F00-937E-42BB-A7F5-D8A3DF4E3FC7}"/>
+                <a16:creationId xmlns:a16="http://schemas.microsoft.com/office/drawing/2014/main" id="{3FC93EF2-2EDD-4AFB-868A-1143DB60D543}"/>
               </a:ext>
             </a:extLst>
           </p:cNvPr>
@@ -4097,7 +4203,7 @@
           <p:cNvPr id="6" name="">
             <a:extLst xmlns:a="http://schemas.openxmlformats.org/drawingml/2006/main">
               <a:ext uri="{FF2B5EF4-FFF2-40B4-BE49-F238E27FC236}">
-                <a16:creationId xmlns:a16="http://schemas.microsoft.com/office/drawing/2014/main" id="{F9171061-2637-4701-B020-4BCF2547EEE9}"/>
+                <a16:creationId xmlns:a16="http://schemas.microsoft.com/office/drawing/2014/main" id="{90549095-91BD-4FB6-98D5-E7EE21362612}"/>
               </a:ext>
             </a:extLst>
           </p:cNvPr>
@@ -4163,7 +4269,7 @@
           <p:cNvPr id="7" name="">
             <a:extLst xmlns:a="http://schemas.openxmlformats.org/drawingml/2006/main">
               <a:ext uri="{FF2B5EF4-FFF2-40B4-BE49-F238E27FC236}">
-                <a16:creationId xmlns:a16="http://schemas.microsoft.com/office/drawing/2014/main" id="{32E69005-D082-4613-8ACF-635FE50DB998}"/>
+                <a16:creationId xmlns:a16="http://schemas.microsoft.com/office/drawing/2014/main" id="{40237FB8-3C5D-46AB-80AD-9649A8E87294}"/>
               </a:ext>
             </a:extLst>
           </p:cNvPr>
@@ -4229,7 +4335,7 @@
           <p:cNvPr id="8" name="">
             <a:extLst xmlns:a="http://schemas.openxmlformats.org/drawingml/2006/main">
               <a:ext uri="{FF2B5EF4-FFF2-40B4-BE49-F238E27FC236}">
-                <a16:creationId xmlns:a16="http://schemas.microsoft.com/office/drawing/2014/main" id="{157BB6BE-2CC7-4E5C-9F49-26B548D0C3A1}"/>
+                <a16:creationId xmlns:a16="http://schemas.microsoft.com/office/drawing/2014/main" id="{2F11A4F5-16C8-4751-9102-1623740AA6DD}"/>
               </a:ext>
             </a:extLst>
           </p:cNvPr>
@@ -4295,7 +4401,7 @@
           <p:cNvPr id="9" name="">
             <a:extLst xmlns:a="http://schemas.openxmlformats.org/drawingml/2006/main">
               <a:ext uri="{FF2B5EF4-FFF2-40B4-BE49-F238E27FC236}">
-                <a16:creationId xmlns:a16="http://schemas.microsoft.com/office/drawing/2014/main" id="{E5A5A45B-AD09-4565-8075-CB194E495234}"/>
+                <a16:creationId xmlns:a16="http://schemas.microsoft.com/office/drawing/2014/main" id="{425ABBEC-E6AD-4E5D-8198-69F5AD1E993D}"/>
               </a:ext>
             </a:extLst>
           </p:cNvPr>
@@ -4361,7 +4467,7 @@
           <p:cNvPr id="10" name="">
             <a:extLst xmlns:a="http://schemas.openxmlformats.org/drawingml/2006/main">
               <a:ext uri="{FF2B5EF4-FFF2-40B4-BE49-F238E27FC236}">
-                <a16:creationId xmlns:a16="http://schemas.microsoft.com/office/drawing/2014/main" id="{578C7BF0-69CF-4747-B882-81A076D81421}"/>
+                <a16:creationId xmlns:a16="http://schemas.microsoft.com/office/drawing/2014/main" id="{525797B7-CCB6-49EC-8F83-BD1A4FF8EB80}"/>
               </a:ext>
             </a:extLst>
           </p:cNvPr>
@@ -4416,7 +4522,7 @@
                 <a:latin typeface="Arial"/>
                 <a:ea typeface="Arial"/>
                 <a:cs typeface="Arial"/>
-                <a:hlinkClick xmlns:r="http://schemas.openxmlformats.org/officeDocument/2006/relationships" r:id="R151c88c289d542f6"/>
+                <a:hlinkClick xmlns:r="http://schemas.openxmlformats.org/officeDocument/2006/relationships" r:id="R9a80e352920542af"/>
               </a:rPr>
               <a:t>My skill workshop</a:t>
             </a:r>
@@ -4428,7 +4534,7 @@
           <p:cNvPr id="11" name="">
             <a:extLst xmlns:a="http://schemas.openxmlformats.org/drawingml/2006/main">
               <a:ext uri="{FF2B5EF4-FFF2-40B4-BE49-F238E27FC236}">
-                <a16:creationId xmlns:a16="http://schemas.microsoft.com/office/drawing/2014/main" id="{29D21805-32B3-4761-A7D5-A698106002DC}"/>
+                <a16:creationId xmlns:a16="http://schemas.microsoft.com/office/drawing/2014/main" id="{E1E0061F-A7D1-440C-A3F1-960DA4230DE8}"/>
               </a:ext>
             </a:extLst>
           </p:cNvPr>
@@ -4483,7 +4589,7 @@
                 <a:latin typeface="Arial"/>
                 <a:ea typeface="Arial"/>
                 <a:cs typeface="Arial"/>
-                <a:hlinkClick xmlns:r="http://schemas.openxmlformats.org/officeDocument/2006/relationships" r:id="R2893647c9ca0473f"/>
+                <a:hlinkClick xmlns:r="http://schemas.openxmlformats.org/officeDocument/2006/relationships" r:id="R04c02bd235f14bfb"/>
               </a:rPr>
               <a:t>Worktree tools</a:t>
             </a:r>
@@ -4495,7 +4601,7 @@
           <p:cNvPr id="12" name="">
             <a:extLst xmlns:a="http://schemas.openxmlformats.org/drawingml/2006/main">
               <a:ext uri="{FF2B5EF4-FFF2-40B4-BE49-F238E27FC236}">
-                <a16:creationId xmlns:a16="http://schemas.microsoft.com/office/drawing/2014/main" id="{2FB1A14F-9883-4401-9ED3-CC7538E27C9A}"/>
+                <a16:creationId xmlns:a16="http://schemas.microsoft.com/office/drawing/2014/main" id="{27F0C586-2356-40FF-AA6A-869463CF4B6E}"/>
               </a:ext>
             </a:extLst>
           </p:cNvPr>
@@ -4550,7 +4656,7 @@
                 <a:latin typeface="Arial"/>
                 <a:ea typeface="Arial"/>
                 <a:cs typeface="Arial"/>
-                <a:hlinkClick xmlns:r="http://schemas.openxmlformats.org/officeDocument/2006/relationships" r:id="Rac718744c8544a7a"/>
+                <a:hlinkClick xmlns:r="http://schemas.openxmlformats.org/officeDocument/2006/relationships" r:id="R641fc2044c3d4a1e"/>
               </a:rPr>
               <a:t>Execution records: duct</a:t>
             </a:r>
@@ -4560,7 +4666,7 @@
     </p:spTree>
     <p:extLst>
       <p:ext uri="{BB962C8B-B14F-4D97-AF65-F5344CB8AC3E}">
-        <p14:creationId xmlns:p14="http://schemas.microsoft.com/office/powerpoint/2010/main" val="1821715278"/>
+        <p14:creationId xmlns:p14="http://schemas.microsoft.com/office/powerpoint/2010/main" val="1794823925"/>
       </p:ext>
     </p:extLst>
   </p:cSld>
@@ -4588,10 +4694,10 @@
       </p:grpSpPr>
       <p:sp>
         <p:nvSpPr>
-          <p:cNvPr id="7" name="">
+          <p:cNvPr id="9" name="">
             <a:extLst xmlns:a="http://schemas.openxmlformats.org/drawingml/2006/main">
               <a:ext uri="{FF2B5EF4-FFF2-40B4-BE49-F238E27FC236}">
-                <a16:creationId xmlns:a16="http://schemas.microsoft.com/office/drawing/2014/main" id="{A54EC223-064A-49F7-879E-09008B059138}"/>
+                <a16:creationId xmlns:a16="http://schemas.microsoft.com/office/drawing/2014/main" id="{8ADC2F20-FBDC-4F06-8C5D-1016452422A7}"/>
               </a:ext>
             </a:extLst>
           </p:cNvPr>
@@ -4647,7 +4753,7 @@
                 <a:ea typeface="Arial"/>
                 <a:cs typeface="Arial"/>
               </a:rPr>
-              <a:t>The Software Engineer Reborn</a:t>
+              <a:t>Keyhatch</a:t>
             </a:r>
           </a:p>
         </p:txBody>
@@ -4657,7 +4763,7 @@
           <p:cNvPr id="2" name="">
             <a:extLst xmlns:a="http://schemas.openxmlformats.org/drawingml/2006/main">
               <a:ext uri="{FF2B5EF4-FFF2-40B4-BE49-F238E27FC236}">
-                <a16:creationId xmlns:a16="http://schemas.microsoft.com/office/drawing/2014/main" id="{456C0086-D942-45EB-86C8-FAD17293976F}"/>
+                <a16:creationId xmlns:a16="http://schemas.microsoft.com/office/drawing/2014/main" id="{39DF2997-1B7A-4E79-AF48-DD62B049E948}"/>
               </a:ext>
             </a:extLst>
           </p:cNvPr>
@@ -4668,8 +4774,8 @@
         </p:nvSpPr>
         <p:spPr>
           <a:xfrm xmlns:a="http://schemas.openxmlformats.org/drawingml/2006/main">
-            <a:off x="609600" y="1428750"/>
-            <a:ext cx="10972800" cy="619125"/>
+            <a:off x="609600" y="1666875"/>
+            <a:ext cx="10972800" cy="666750"/>
           </a:xfrm>
           <a:prstGeom xmlns:a="http://schemas.openxmlformats.org/drawingml/2006/main" prst="rect">
             <a:avLst/>
@@ -4683,7 +4789,7 @@
           <a:bodyPr xmlns:a="http://schemas.openxmlformats.org/drawingml/2006/main" lIns="0" tIns="0" rIns="0" bIns="0"/>
           <a:lstStyle xmlns:a="http://schemas.openxmlformats.org/drawingml/2006/main">
             <a:defPPr>
-              <a:defRPr sz="2250" b="0">
+              <a:defRPr sz="3300" b="1">
                 <a:solidFill>
                   <a:srgbClr val="183A3C"/>
                 </a:solidFill>
@@ -4695,7 +4801,7 @@
           </a:lstStyle>
           <a:p xmlns:a="http://schemas.openxmlformats.org/drawingml/2006/main">
             <a:pPr>
-              <a:defRPr sz="2250" b="0">
+              <a:defRPr sz="3300" b="1">
                 <a:solidFill>
                   <a:srgbClr val="183A3C"/>
                 </a:solidFill>
@@ -4705,7 +4811,7 @@
               </a:defRPr>
             </a:pPr>
             <a:r>
-              <a:rPr sz="2250" b="0">
+              <a:rPr sz="3300" b="1">
                 <a:solidFill>
                   <a:srgbClr val="183A3C"/>
                 </a:solidFill>
@@ -4713,85 +4819,29 @@
                 <a:ea typeface="Arial"/>
                 <a:cs typeface="Arial"/>
               </a:rPr>
-              <a:t>I used an interactive preparation space to work through the ideas.</a:t>
-            </a:r>
-          </a:p>
-        </p:txBody>
-      </p:sp>
-      <p:pic>
-        <p:nvPicPr>
+              <a:t>Selective credential access for agents</a:t>
+            </a:r>
+          </a:p>
+        </p:txBody>
+      </p:sp>
+      <p:sp>
+        <p:nvSpPr>
           <p:cNvPr id="3" name="">
             <a:extLst xmlns:a="http://schemas.openxmlformats.org/drawingml/2006/main">
               <a:ext uri="{FF2B5EF4-FFF2-40B4-BE49-F238E27FC236}">
-                <a16:creationId xmlns:a16="http://schemas.microsoft.com/office/drawing/2014/main" id="{A5CAD189-CD07-43B7-829A-9CF010051189}"/>
+                <a16:creationId xmlns:a16="http://schemas.microsoft.com/office/drawing/2014/main" id="{84E461A7-B25D-4B6B-8000-910CFE77E4B3}"/>
               </a:ext>
             </a:extLst>
           </p:cNvPr>
-          <p:cNvPicPr>
-            <a:picLocks xmlns:a="http://schemas.openxmlformats.org/drawingml/2006/main" noChangeAspect="1"/>
-          </p:cNvPicPr>
+          <p:cNvSpPr>
+            <a:spLocks xmlns:a="http://schemas.openxmlformats.org/drawingml/2006/main" noGrp="1"/>
+          </p:cNvSpPr>
           <p:nvPr/>
-        </p:nvPicPr>
-        <p:blipFill>
-          <a:blip xmlns:r="http://schemas.openxmlformats.org/officeDocument/2006/relationships" xmlns:a="http://schemas.openxmlformats.org/drawingml/2006/main" r:embed="R9ab0f64910ab40a1"/>
-          <a:stretch xmlns:a="http://schemas.openxmlformats.org/drawingml/2006/main"/>
-        </p:blipFill>
+        </p:nvSpPr>
         <p:spPr>
           <a:xfrm xmlns:a="http://schemas.openxmlformats.org/drawingml/2006/main">
-            <a:off x="609600" y="2333625"/>
-            <a:ext cx="5257800" cy="3286125"/>
-          </a:xfrm>
-          <a:prstGeom xmlns:a="http://schemas.openxmlformats.org/drawingml/2006/main" prst="rect">
-            <a:avLst/>
-          </a:prstGeom>
-        </p:spPr>
-      </p:pic>
-      <p:pic>
-        <p:nvPicPr>
-          <p:cNvPr id="4" name="">
-            <a:extLst xmlns:a="http://schemas.openxmlformats.org/drawingml/2006/main">
-              <a:ext uri="{FF2B5EF4-FFF2-40B4-BE49-F238E27FC236}">
-                <a16:creationId xmlns:a16="http://schemas.microsoft.com/office/drawing/2014/main" id="{B92CA66D-0F2B-42DE-A9BA-36FF365721C2}"/>
-              </a:ext>
-            </a:extLst>
-          </p:cNvPr>
-          <p:cNvPicPr>
-            <a:picLocks xmlns:a="http://schemas.openxmlformats.org/drawingml/2006/main" noChangeAspect="1"/>
-          </p:cNvPicPr>
-          <p:nvPr/>
-        </p:nvPicPr>
-        <p:blipFill>
-          <a:blip xmlns:r="http://schemas.openxmlformats.org/officeDocument/2006/relationships" xmlns:a="http://schemas.openxmlformats.org/drawingml/2006/main" r:embed="R1820c3005ee74efb"/>
-          <a:stretch xmlns:a="http://schemas.openxmlformats.org/drawingml/2006/main"/>
-        </p:blipFill>
-        <p:spPr>
-          <a:xfrm xmlns:a="http://schemas.openxmlformats.org/drawingml/2006/main">
-            <a:off x="6324600" y="2333625"/>
-            <a:ext cx="5257800" cy="3286125"/>
-          </a:xfrm>
-          <a:prstGeom xmlns:a="http://schemas.openxmlformats.org/drawingml/2006/main" prst="rect">
-            <a:avLst/>
-          </a:prstGeom>
-        </p:spPr>
-      </p:pic>
-      <p:sp>
-        <p:nvSpPr>
-          <p:cNvPr id="5" name="">
-            <a:extLst xmlns:a="http://schemas.openxmlformats.org/drawingml/2006/main">
-              <a:ext uri="{FF2B5EF4-FFF2-40B4-BE49-F238E27FC236}">
-                <a16:creationId xmlns:a16="http://schemas.microsoft.com/office/drawing/2014/main" id="{D18ED21C-36E4-47DE-9E3D-47DF26B46940}"/>
-              </a:ext>
-            </a:extLst>
-          </p:cNvPr>
-          <p:cNvSpPr>
-            <a:spLocks xmlns:a="http://schemas.openxmlformats.org/drawingml/2006/main" noGrp="1"/>
-          </p:cNvSpPr>
-          <p:nvPr/>
-        </p:nvSpPr>
-        <p:spPr>
-          <a:xfrm xmlns:a="http://schemas.openxmlformats.org/drawingml/2006/main">
-            <a:off x="609600" y="5857875"/>
-            <a:ext cx="5238750" cy="361950"/>
+            <a:off x="609600" y="2857500"/>
+            <a:ext cx="10763250" cy="1095375"/>
           </a:xfrm>
           <a:prstGeom xmlns:a="http://schemas.openxmlformats.org/drawingml/2006/main" prst="rect">
             <a:avLst/>
@@ -4805,7 +4855,7 @@
           <a:bodyPr xmlns:a="http://schemas.openxmlformats.org/drawingml/2006/main" lIns="0" tIns="0" rIns="0" bIns="0"/>
           <a:lstStyle xmlns:a="http://schemas.openxmlformats.org/drawingml/2006/main">
             <a:defPPr>
-              <a:defRPr sz="1800" b="0">
+              <a:defRPr sz="2775" b="0">
                 <a:solidFill>
                   <a:srgbClr val="15716E"/>
                 </a:solidFill>
@@ -4817,7 +4867,7 @@
           </a:lstStyle>
           <a:p xmlns:a="http://schemas.openxmlformats.org/drawingml/2006/main">
             <a:pPr>
-              <a:defRPr sz="1800" b="0">
+              <a:defRPr sz="2775" b="0">
                 <a:solidFill>
                   <a:srgbClr val="15716E"/>
                 </a:solidFill>
@@ -4827,26 +4877,48 @@
               </a:defRPr>
             </a:pPr>
             <a:r>
-              <a:rPr sz="1800" b="0">
+              <a:rPr sz="2775" b="0">
                 <a:solidFill>
                   <a:srgbClr val="15716E"/>
                 </a:solidFill>
                 <a:latin typeface="Arial"/>
                 <a:ea typeface="Arial"/>
                 <a:cs typeface="Arial"/>
-                <a:hlinkClick xmlns:r="http://schemas.openxmlformats.org/officeDocument/2006/relationships" r:id="R928139e28acc4124"/>
               </a:rPr>
-              <a:t>Explore the preparation</a:t>
-            </a:r>
-          </a:p>
-        </p:txBody>
-      </p:sp>
-      <p:sp>
-        <p:nvSpPr>
-          <p:cNvPr id="6" name="">
+              <a:t>Approve selected credentials once.</a:t>
+            </a:r>
+          </a:p>
+          <a:p xmlns:a="http://schemas.openxmlformats.org/drawingml/2006/main">
+            <a:pPr>
+              <a:defRPr sz="2775" b="0">
+                <a:solidFill>
+                  <a:srgbClr val="15716E"/>
+                </a:solidFill>
+                <a:latin typeface="Arial"/>
+                <a:ea typeface="Arial"/>
+                <a:cs typeface="Arial"/>
+              </a:defRPr>
+            </a:pPr>
+            <a:r>
+              <a:rPr sz="2775" b="0">
+                <a:solidFill>
+                  <a:srgbClr val="15716E"/>
+                </a:solidFill>
+                <a:latin typeface="Arial"/>
+                <a:ea typeface="Arial"/>
+                <a:cs typeface="Arial"/>
+              </a:rPr>
+              <a:t>Allow repeated retrieval within a limited window.</a:t>
+            </a:r>
+          </a:p>
+        </p:txBody>
+      </p:sp>
+      <p:sp>
+        <p:nvSpPr>
+          <p:cNvPr id="4" name="">
             <a:extLst xmlns:a="http://schemas.openxmlformats.org/drawingml/2006/main">
               <a:ext uri="{FF2B5EF4-FFF2-40B4-BE49-F238E27FC236}">
-                <a16:creationId xmlns:a16="http://schemas.microsoft.com/office/drawing/2014/main" id="{1CED3C7C-0599-4D99-8E77-548CFE63CF99}"/>
+                <a16:creationId xmlns:a16="http://schemas.microsoft.com/office/drawing/2014/main" id="{2E01E6DF-F722-4285-AA19-09F8AF88456B}"/>
               </a:ext>
             </a:extLst>
           </p:cNvPr>
@@ -4857,8 +4929,8 @@
         </p:nvSpPr>
         <p:spPr>
           <a:xfrm xmlns:a="http://schemas.openxmlformats.org/drawingml/2006/main">
-            <a:off x="6324600" y="5857875"/>
-            <a:ext cx="5238750" cy="361950"/>
+            <a:off x="609600" y="4333875"/>
+            <a:ext cx="10763250" cy="571500"/>
           </a:xfrm>
           <a:prstGeom xmlns:a="http://schemas.openxmlformats.org/drawingml/2006/main" prst="rect">
             <a:avLst/>
@@ -4872,9 +4944,9 @@
           <a:bodyPr xmlns:a="http://schemas.openxmlformats.org/drawingml/2006/main" lIns="0" tIns="0" rIns="0" bIns="0"/>
           <a:lstStyle xmlns:a="http://schemas.openxmlformats.org/drawingml/2006/main">
             <a:defPPr>
-              <a:defRPr sz="1800" b="0">
-                <a:solidFill>
-                  <a:srgbClr val="15716E"/>
+              <a:defRPr sz="2250" b="0">
+                <a:solidFill>
+                  <a:srgbClr val="183A3C"/>
                 </a:solidFill>
                 <a:latin typeface="Arial"/>
                 <a:ea typeface="Arial"/>
@@ -4884,6 +4956,126 @@
           </a:lstStyle>
           <a:p xmlns:a="http://schemas.openxmlformats.org/drawingml/2006/main">
             <a:pPr>
+              <a:defRPr sz="2250" b="0">
+                <a:solidFill>
+                  <a:srgbClr val="183A3C"/>
+                </a:solidFill>
+                <a:latin typeface="Arial"/>
+                <a:ea typeface="Arial"/>
+                <a:cs typeface="Arial"/>
+              </a:defRPr>
+            </a:pPr>
+            <a:r>
+              <a:rPr sz="2250" b="0">
+                <a:solidFill>
+                  <a:srgbClr val="183A3C"/>
+                </a:solidFill>
+                <a:latin typeface="Arial"/>
+                <a:ea typeface="Arial"/>
+                <a:cs typeface="Arial"/>
+              </a:rPr>
+              <a:t>Native macOS app + local command-line client</a:t>
+            </a:r>
+          </a:p>
+        </p:txBody>
+      </p:sp>
+      <p:sp>
+        <p:nvSpPr>
+          <p:cNvPr id="5" name="">
+            <a:extLst xmlns:a="http://schemas.openxmlformats.org/drawingml/2006/main">
+              <a:ext uri="{FF2B5EF4-FFF2-40B4-BE49-F238E27FC236}">
+                <a16:creationId xmlns:a16="http://schemas.microsoft.com/office/drawing/2014/main" id="{84783422-11BD-4FAE-B636-DA6819A0774C}"/>
+              </a:ext>
+            </a:extLst>
+          </p:cNvPr>
+          <p:cNvSpPr>
+            <a:spLocks xmlns:a="http://schemas.openxmlformats.org/drawingml/2006/main" noGrp="1"/>
+          </p:cNvSpPr>
+          <p:nvPr/>
+        </p:nvSpPr>
+        <p:spPr>
+          <a:xfrm xmlns:a="http://schemas.openxmlformats.org/drawingml/2006/main">
+            <a:off x="609600" y="5095875"/>
+            <a:ext cx="10763250" cy="552450"/>
+          </a:xfrm>
+          <a:prstGeom xmlns:a="http://schemas.openxmlformats.org/drawingml/2006/main" prst="rect">
+            <a:avLst/>
+          </a:prstGeom>
+          <a:noFill xmlns:a="http://schemas.openxmlformats.org/drawingml/2006/main"/>
+          <a:ln xmlns:a="http://schemas.openxmlformats.org/drawingml/2006/main" w="0">
+            <a:noFill/>
+          </a:ln>
+        </p:spPr>
+        <p:txBody>
+          <a:bodyPr xmlns:a="http://schemas.openxmlformats.org/drawingml/2006/main" lIns="0" tIns="0" rIns="0" bIns="0"/>
+          <a:lstStyle xmlns:a="http://schemas.openxmlformats.org/drawingml/2006/main">
+            <a:defPPr>
+              <a:defRPr sz="2025" b="0">
+                <a:solidFill>
+                  <a:srgbClr val="183A3C"/>
+                </a:solidFill>
+                <a:latin typeface="Arial"/>
+                <a:ea typeface="Arial"/>
+                <a:cs typeface="Arial"/>
+              </a:defRPr>
+            </a:defPPr>
+          </a:lstStyle>
+          <a:p xmlns:a="http://schemas.openxmlformats.org/drawingml/2006/main">
+            <a:pPr>
+              <a:defRPr sz="2025" b="0">
+                <a:solidFill>
+                  <a:srgbClr val="183A3C"/>
+                </a:solidFill>
+                <a:latin typeface="Arial"/>
+                <a:ea typeface="Arial"/>
+                <a:cs typeface="Arial"/>
+              </a:defRPr>
+            </a:pPr>
+            <a:r>
+              <a:rPr sz="2025" b="0">
+                <a:solidFill>
+                  <a:srgbClr val="183A3C"/>
+                </a:solidFill>
+                <a:latin typeface="Arial"/>
+                <a:ea typeface="Arial"/>
+                <a:cs typeface="Arial"/>
+              </a:rPr>
+              <a:t>Expiry stops future retrieval. It cannot recall a disclosed secret.</a:t>
+            </a:r>
+          </a:p>
+        </p:txBody>
+      </p:sp>
+      <p:sp>
+        <p:nvSpPr>
+          <p:cNvPr id="6" name="">
+            <a:extLst xmlns:a="http://schemas.openxmlformats.org/drawingml/2006/main">
+              <a:ext uri="{FF2B5EF4-FFF2-40B4-BE49-F238E27FC236}">
+                <a16:creationId xmlns:a16="http://schemas.microsoft.com/office/drawing/2014/main" id="{4C205536-B730-430E-86C4-3E42EBAD70ED}"/>
+              </a:ext>
+            </a:extLst>
+          </p:cNvPr>
+          <p:cNvSpPr>
+            <a:spLocks xmlns:a="http://schemas.openxmlformats.org/drawingml/2006/main" noGrp="1"/>
+          </p:cNvSpPr>
+          <p:nvPr/>
+        </p:nvSpPr>
+        <p:spPr>
+          <a:xfrm xmlns:a="http://schemas.openxmlformats.org/drawingml/2006/main">
+            <a:off x="609600" y="6153150"/>
+            <a:ext cx="3810000" cy="361950"/>
+          </a:xfrm>
+          <a:prstGeom xmlns:a="http://schemas.openxmlformats.org/drawingml/2006/main" prst="rect">
+            <a:avLst/>
+          </a:prstGeom>
+          <a:noFill xmlns:a="http://schemas.openxmlformats.org/drawingml/2006/main"/>
+          <a:ln xmlns:a="http://schemas.openxmlformats.org/drawingml/2006/main" w="0">
+            <a:noFill/>
+          </a:ln>
+        </p:spPr>
+        <p:txBody>
+          <a:bodyPr xmlns:a="http://schemas.openxmlformats.org/drawingml/2006/main" lIns="0" tIns="0" rIns="0" bIns="0"/>
+          <a:lstStyle xmlns:a="http://schemas.openxmlformats.org/drawingml/2006/main">
+            <a:defPPr>
               <a:defRPr sz="1800" b="0">
                 <a:solidFill>
                   <a:srgbClr val="15716E"/>
@@ -4892,6 +5084,18 @@
                 <a:ea typeface="Arial"/>
                 <a:cs typeface="Arial"/>
               </a:defRPr>
+            </a:defPPr>
+          </a:lstStyle>
+          <a:p xmlns:a="http://schemas.openxmlformats.org/drawingml/2006/main">
+            <a:pPr>
+              <a:defRPr sz="1800" b="0">
+                <a:solidFill>
+                  <a:srgbClr val="15716E"/>
+                </a:solidFill>
+                <a:latin typeface="Arial"/>
+                <a:ea typeface="Arial"/>
+                <a:cs typeface="Arial"/>
+              </a:defRPr>
             </a:pPr>
             <a:r>
               <a:rPr sz="1800" b="0">
@@ -4901,9 +5105,142 @@
                 <a:latin typeface="Arial"/>
                 <a:ea typeface="Arial"/>
                 <a:cs typeface="Arial"/>
-                <a:hlinkClick xmlns:r="http://schemas.openxmlformats.org/officeDocument/2006/relationships" r:id="R9751ee40ddf1401f"/>
+                <a:hlinkClick xmlns:r="http://schemas.openxmlformats.org/officeDocument/2006/relationships" r:id="R5f520bf4e8bf4644"/>
               </a:rPr>
-              <a:t>Open the presentation</a:t>
+              <a:t>Project + source</a:t>
+            </a:r>
+          </a:p>
+        </p:txBody>
+      </p:sp>
+      <p:sp>
+        <p:nvSpPr>
+          <p:cNvPr id="7" name="">
+            <a:extLst xmlns:a="http://schemas.openxmlformats.org/drawingml/2006/main">
+              <a:ext uri="{FF2B5EF4-FFF2-40B4-BE49-F238E27FC236}">
+                <a16:creationId xmlns:a16="http://schemas.microsoft.com/office/drawing/2014/main" id="{EDA4CDBA-4FE9-4BBA-A5A8-1DD4E7CB80B1}"/>
+              </a:ext>
+            </a:extLst>
+          </p:cNvPr>
+          <p:cNvSpPr>
+            <a:spLocks xmlns:a="http://schemas.openxmlformats.org/drawingml/2006/main" noGrp="1"/>
+          </p:cNvSpPr>
+          <p:nvPr/>
+        </p:nvSpPr>
+        <p:spPr>
+          <a:xfrm xmlns:a="http://schemas.openxmlformats.org/drawingml/2006/main">
+            <a:off x="4619625" y="6153150"/>
+            <a:ext cx="3429000" cy="361950"/>
+          </a:xfrm>
+          <a:prstGeom xmlns:a="http://schemas.openxmlformats.org/drawingml/2006/main" prst="rect">
+            <a:avLst/>
+          </a:prstGeom>
+          <a:noFill xmlns:a="http://schemas.openxmlformats.org/drawingml/2006/main"/>
+          <a:ln xmlns:a="http://schemas.openxmlformats.org/drawingml/2006/main" w="0">
+            <a:noFill/>
+          </a:ln>
+        </p:spPr>
+        <p:txBody>
+          <a:bodyPr xmlns:a="http://schemas.openxmlformats.org/drawingml/2006/main" lIns="0" tIns="0" rIns="0" bIns="0"/>
+          <a:lstStyle xmlns:a="http://schemas.openxmlformats.org/drawingml/2006/main">
+            <a:defPPr>
+              <a:defRPr sz="1800" b="0">
+                <a:solidFill>
+                  <a:srgbClr val="15716E"/>
+                </a:solidFill>
+                <a:latin typeface="Arial"/>
+                <a:ea typeface="Arial"/>
+                <a:cs typeface="Arial"/>
+              </a:defRPr>
+            </a:defPPr>
+          </a:lstStyle>
+          <a:p xmlns:a="http://schemas.openxmlformats.org/drawingml/2006/main">
+            <a:pPr>
+              <a:defRPr sz="1800" b="0">
+                <a:solidFill>
+                  <a:srgbClr val="15716E"/>
+                </a:solidFill>
+                <a:latin typeface="Arial"/>
+                <a:ea typeface="Arial"/>
+                <a:cs typeface="Arial"/>
+              </a:defRPr>
+            </a:pPr>
+            <a:r>
+              <a:rPr sz="1800" b="0">
+                <a:solidFill>
+                  <a:srgbClr val="15716E"/>
+                </a:solidFill>
+                <a:latin typeface="Arial"/>
+                <a:ea typeface="Arial"/>
+                <a:cs typeface="Arial"/>
+                <a:hlinkClick xmlns:r="http://schemas.openxmlformats.org/officeDocument/2006/relationships" r:id="R5b9cbab0c11840d1"/>
+              </a:rPr>
+              <a:t>Design and limits</a:t>
+            </a:r>
+          </a:p>
+        </p:txBody>
+      </p:sp>
+      <p:sp>
+        <p:nvSpPr>
+          <p:cNvPr id="8" name="">
+            <a:extLst xmlns:a="http://schemas.openxmlformats.org/drawingml/2006/main">
+              <a:ext uri="{FF2B5EF4-FFF2-40B4-BE49-F238E27FC236}">
+                <a16:creationId xmlns:a16="http://schemas.microsoft.com/office/drawing/2014/main" id="{6DA27C01-0D4D-4A6F-A9D8-93169ABBEF76}"/>
+              </a:ext>
+            </a:extLst>
+          </p:cNvPr>
+          <p:cNvSpPr>
+            <a:spLocks xmlns:a="http://schemas.openxmlformats.org/drawingml/2006/main" noGrp="1"/>
+          </p:cNvSpPr>
+          <p:nvPr/>
+        </p:nvSpPr>
+        <p:spPr>
+          <a:xfrm xmlns:a="http://schemas.openxmlformats.org/drawingml/2006/main">
+            <a:off x="8763000" y="6153150"/>
+            <a:ext cx="2952750" cy="361950"/>
+          </a:xfrm>
+          <a:prstGeom xmlns:a="http://schemas.openxmlformats.org/drawingml/2006/main" prst="rect">
+            <a:avLst/>
+          </a:prstGeom>
+          <a:noFill xmlns:a="http://schemas.openxmlformats.org/drawingml/2006/main"/>
+          <a:ln xmlns:a="http://schemas.openxmlformats.org/drawingml/2006/main" w="0">
+            <a:noFill/>
+          </a:ln>
+        </p:spPr>
+        <p:txBody>
+          <a:bodyPr xmlns:a="http://schemas.openxmlformats.org/drawingml/2006/main" lIns="0" tIns="0" rIns="0" bIns="0"/>
+          <a:lstStyle xmlns:a="http://schemas.openxmlformats.org/drawingml/2006/main">
+            <a:defPPr>
+              <a:defRPr sz="1800" b="0">
+                <a:solidFill>
+                  <a:srgbClr val="AA492E"/>
+                </a:solidFill>
+                <a:latin typeface="Arial"/>
+                <a:ea typeface="Arial"/>
+                <a:cs typeface="Arial"/>
+              </a:defRPr>
+            </a:defPPr>
+          </a:lstStyle>
+          <a:p xmlns:a="http://schemas.openxmlformats.org/drawingml/2006/main">
+            <a:pPr>
+              <a:defRPr sz="1800" b="0">
+                <a:solidFill>
+                  <a:srgbClr val="AA492E"/>
+                </a:solidFill>
+                <a:latin typeface="Arial"/>
+                <a:ea typeface="Arial"/>
+                <a:cs typeface="Arial"/>
+              </a:defRPr>
+            </a:pPr>
+            <a:r>
+              <a:rPr sz="1800" b="0">
+                <a:solidFill>
+                  <a:srgbClr val="AA492E"/>
+                </a:solidFill>
+                <a:latin typeface="Arial"/>
+                <a:ea typeface="Arial"/>
+                <a:cs typeface="Arial"/>
+              </a:rPr>
+              <a:t>Experimental build</a:t>
             </a:r>
           </a:p>
         </p:txBody>
@@ -4911,7 +5248,7 @@
     </p:spTree>
     <p:extLst>
       <p:ext uri="{BB962C8B-B14F-4D97-AF65-F5344CB8AC3E}">
-        <p14:creationId xmlns:p14="http://schemas.microsoft.com/office/powerpoint/2010/main" val="998832131"/>
+        <p14:creationId xmlns:p14="http://schemas.microsoft.com/office/powerpoint/2010/main" val="284359823"/>
       </p:ext>
     </p:extLst>
   </p:cSld>
@@ -4942,7 +5279,7 @@
           <p:cNvPr id="7" name="">
             <a:extLst xmlns:a="http://schemas.openxmlformats.org/drawingml/2006/main">
               <a:ext uri="{FF2B5EF4-FFF2-40B4-BE49-F238E27FC236}">
-                <a16:creationId xmlns:a16="http://schemas.microsoft.com/office/drawing/2014/main" id="{A22CD10B-B836-4562-9ABD-3A48D9A332E8}"/>
+                <a16:creationId xmlns:a16="http://schemas.microsoft.com/office/drawing/2014/main" id="{289E1D99-39AE-45F2-A713-75984A8D9426}"/>
               </a:ext>
             </a:extLst>
           </p:cNvPr>
@@ -4998,17 +5335,83 @@
                 <a:ea typeface="Arial"/>
                 <a:cs typeface="Arial"/>
               </a:rPr>
-              <a:t>What did we just make?</a:t>
-            </a:r>
-          </a:p>
-        </p:txBody>
-      </p:sp>
-      <p:pic>
-        <p:nvPicPr>
+              <a:t>The Software Engineer Reborn</a:t>
+            </a:r>
+          </a:p>
+        </p:txBody>
+      </p:sp>
+      <p:sp>
+        <p:nvSpPr>
           <p:cNvPr id="2" name="">
             <a:extLst xmlns:a="http://schemas.openxmlformats.org/drawingml/2006/main">
               <a:ext uri="{FF2B5EF4-FFF2-40B4-BE49-F238E27FC236}">
-                <a16:creationId xmlns:a16="http://schemas.microsoft.com/office/drawing/2014/main" id="{C22A6579-25FE-425B-ADDB-5A589148141F}"/>
+                <a16:creationId xmlns:a16="http://schemas.microsoft.com/office/drawing/2014/main" id="{320644F6-7703-49FC-A329-1A86E92B60DE}"/>
+              </a:ext>
+            </a:extLst>
+          </p:cNvPr>
+          <p:cNvSpPr>
+            <a:spLocks xmlns:a="http://schemas.openxmlformats.org/drawingml/2006/main" noGrp="1"/>
+          </p:cNvSpPr>
+          <p:nvPr/>
+        </p:nvSpPr>
+        <p:spPr>
+          <a:xfrm xmlns:a="http://schemas.openxmlformats.org/drawingml/2006/main">
+            <a:off x="609600" y="1428750"/>
+            <a:ext cx="10972800" cy="619125"/>
+          </a:xfrm>
+          <a:prstGeom xmlns:a="http://schemas.openxmlformats.org/drawingml/2006/main" prst="rect">
+            <a:avLst/>
+          </a:prstGeom>
+          <a:noFill xmlns:a="http://schemas.openxmlformats.org/drawingml/2006/main"/>
+          <a:ln xmlns:a="http://schemas.openxmlformats.org/drawingml/2006/main" w="0">
+            <a:noFill/>
+          </a:ln>
+        </p:spPr>
+        <p:txBody>
+          <a:bodyPr xmlns:a="http://schemas.openxmlformats.org/drawingml/2006/main" lIns="0" tIns="0" rIns="0" bIns="0"/>
+          <a:lstStyle xmlns:a="http://schemas.openxmlformats.org/drawingml/2006/main">
+            <a:defPPr>
+              <a:defRPr sz="2250" b="0">
+                <a:solidFill>
+                  <a:srgbClr val="183A3C"/>
+                </a:solidFill>
+                <a:latin typeface="Arial"/>
+                <a:ea typeface="Arial"/>
+                <a:cs typeface="Arial"/>
+              </a:defRPr>
+            </a:defPPr>
+          </a:lstStyle>
+          <a:p xmlns:a="http://schemas.openxmlformats.org/drawingml/2006/main">
+            <a:pPr>
+              <a:defRPr sz="2250" b="0">
+                <a:solidFill>
+                  <a:srgbClr val="183A3C"/>
+                </a:solidFill>
+                <a:latin typeface="Arial"/>
+                <a:ea typeface="Arial"/>
+                <a:cs typeface="Arial"/>
+              </a:defRPr>
+            </a:pPr>
+            <a:r>
+              <a:rPr sz="2250" b="0">
+                <a:solidFill>
+                  <a:srgbClr val="183A3C"/>
+                </a:solidFill>
+                <a:latin typeface="Arial"/>
+                <a:ea typeface="Arial"/>
+                <a:cs typeface="Arial"/>
+              </a:rPr>
+              <a:t>I used an interactive preparation space to work through the ideas.</a:t>
+            </a:r>
+          </a:p>
+        </p:txBody>
+      </p:sp>
+      <p:pic>
+        <p:nvPicPr>
+          <p:cNvPr id="3" name="">
+            <a:extLst xmlns:a="http://schemas.openxmlformats.org/drawingml/2006/main">
+              <a:ext uri="{FF2B5EF4-FFF2-40B4-BE49-F238E27FC236}">
+                <a16:creationId xmlns:a16="http://schemas.microsoft.com/office/drawing/2014/main" id="{A2960D0F-CF9F-4D4A-A887-3B95086E5440}"/>
               </a:ext>
             </a:extLst>
           </p:cNvPr>
@@ -5018,37 +5421,65 @@
           <p:nvPr/>
         </p:nvPicPr>
         <p:blipFill>
-          <a:blip xmlns:r="http://schemas.openxmlformats.org/officeDocument/2006/relationships" xmlns:a="http://schemas.openxmlformats.org/drawingml/2006/main" r:embed="Re2566a1f966d46f7"/>
+          <a:blip xmlns:r="http://schemas.openxmlformats.org/officeDocument/2006/relationships" xmlns:a="http://schemas.openxmlformats.org/drawingml/2006/main" r:embed="R44b3dd2e63804868"/>
           <a:stretch xmlns:a="http://schemas.openxmlformats.org/drawingml/2006/main"/>
         </p:blipFill>
         <p:spPr>
           <a:xfrm xmlns:a="http://schemas.openxmlformats.org/drawingml/2006/main">
-            <a:off x="609600" y="1813322"/>
-            <a:ext cx="5810250" cy="3631406"/>
+            <a:off x="609600" y="2333625"/>
+            <a:ext cx="5257800" cy="3286125"/>
           </a:xfrm>
           <a:prstGeom xmlns:a="http://schemas.openxmlformats.org/drawingml/2006/main" prst="rect">
             <a:avLst/>
           </a:prstGeom>
         </p:spPr>
       </p:pic>
-      <p:sp>
-        <p:nvSpPr>
-          <p:cNvPr id="3" name="">
+      <p:pic>
+        <p:nvPicPr>
+          <p:cNvPr id="4" name="">
             <a:extLst xmlns:a="http://schemas.openxmlformats.org/drawingml/2006/main">
               <a:ext uri="{FF2B5EF4-FFF2-40B4-BE49-F238E27FC236}">
-                <a16:creationId xmlns:a16="http://schemas.microsoft.com/office/drawing/2014/main" id="{B07233A0-C0F5-4872-998B-4FEC2EFD6C18}"/>
+                <a16:creationId xmlns:a16="http://schemas.microsoft.com/office/drawing/2014/main" id="{045DE682-D6C9-4B0F-AD96-00BBC28DDF2C}"/>
               </a:ext>
             </a:extLst>
           </p:cNvPr>
-          <p:cNvSpPr>
-            <a:spLocks xmlns:a="http://schemas.openxmlformats.org/drawingml/2006/main" noGrp="1"/>
-          </p:cNvSpPr>
+          <p:cNvPicPr>
+            <a:picLocks xmlns:a="http://schemas.openxmlformats.org/drawingml/2006/main" noChangeAspect="1"/>
+          </p:cNvPicPr>
           <p:nvPr/>
-        </p:nvSpPr>
+        </p:nvPicPr>
+        <p:blipFill>
+          <a:blip xmlns:r="http://schemas.openxmlformats.org/officeDocument/2006/relationships" xmlns:a="http://schemas.openxmlformats.org/drawingml/2006/main" r:embed="R54df6184f3614d5e"/>
+          <a:stretch xmlns:a="http://schemas.openxmlformats.org/drawingml/2006/main"/>
+        </p:blipFill>
         <p:spPr>
           <a:xfrm xmlns:a="http://schemas.openxmlformats.org/drawingml/2006/main">
-            <a:off x="6953250" y="1924050"/>
-            <a:ext cx="4667250" cy="1476375"/>
+            <a:off x="6324600" y="2333625"/>
+            <a:ext cx="5257800" cy="3286125"/>
+          </a:xfrm>
+          <a:prstGeom xmlns:a="http://schemas.openxmlformats.org/drawingml/2006/main" prst="rect">
+            <a:avLst/>
+          </a:prstGeom>
+        </p:spPr>
+      </p:pic>
+      <p:sp>
+        <p:nvSpPr>
+          <p:cNvPr id="5" name="">
+            <a:extLst xmlns:a="http://schemas.openxmlformats.org/drawingml/2006/main">
+              <a:ext uri="{FF2B5EF4-FFF2-40B4-BE49-F238E27FC236}">
+                <a16:creationId xmlns:a16="http://schemas.microsoft.com/office/drawing/2014/main" id="{AF3D3518-FBA3-4261-BC6B-48BAF16C11EA}"/>
+              </a:ext>
+            </a:extLst>
+          </p:cNvPr>
+          <p:cNvSpPr>
+            <a:spLocks xmlns:a="http://schemas.openxmlformats.org/drawingml/2006/main" noGrp="1"/>
+          </p:cNvSpPr>
+          <p:nvPr/>
+        </p:nvSpPr>
+        <p:spPr>
+          <a:xfrm xmlns:a="http://schemas.openxmlformats.org/drawingml/2006/main">
+            <a:off x="609600" y="5857875"/>
+            <a:ext cx="5238750" cy="361950"/>
           </a:xfrm>
           <a:prstGeom xmlns:a="http://schemas.openxmlformats.org/drawingml/2006/main" prst="rect">
             <a:avLst/>
@@ -5062,9 +5493,9 @@
           <a:bodyPr xmlns:a="http://schemas.openxmlformats.org/drawingml/2006/main" lIns="0" tIns="0" rIns="0" bIns="0"/>
           <a:lstStyle xmlns:a="http://schemas.openxmlformats.org/drawingml/2006/main">
             <a:defPPr>
-              <a:defRPr sz="2625" b="1">
-                <a:solidFill>
-                  <a:srgbClr val="183A3C"/>
+              <a:defRPr sz="1800" b="0">
+                <a:solidFill>
+                  <a:srgbClr val="15716E"/>
                 </a:solidFill>
                 <a:latin typeface="Arial"/>
                 <a:ea typeface="Arial"/>
@@ -5074,9 +5505,9 @@
           </a:lstStyle>
           <a:p xmlns:a="http://schemas.openxmlformats.org/drawingml/2006/main">
             <a:pPr>
-              <a:defRPr sz="2625" b="1">
-                <a:solidFill>
-                  <a:srgbClr val="183A3C"/>
+              <a:defRPr sz="1800" b="0">
+                <a:solidFill>
+                  <a:srgbClr val="15716E"/>
                 </a:solidFill>
                 <a:latin typeface="Arial"/>
                 <a:ea typeface="Arial"/>
@@ -5084,71 +5515,26 @@
               </a:defRPr>
             </a:pPr>
             <a:r>
-              <a:rPr sz="2625" b="1">
-                <a:solidFill>
-                  <a:srgbClr val="183A3C"/>
-                </a:solidFill>
-                <a:latin typeface="Arial"/>
-                <a:ea typeface="Arial"/>
-                <a:cs typeface="Arial"/>
+              <a:rPr sz="1800" b="0">
+                <a:solidFill>
+                  <a:srgbClr val="15716E"/>
+                </a:solidFill>
+                <a:latin typeface="Arial"/>
+                <a:ea typeface="Arial"/>
+                <a:cs typeface="Arial"/>
+                <a:hlinkClick xmlns:r="http://schemas.openxmlformats.org/officeDocument/2006/relationships" r:id="R960de19399e34afb"/>
               </a:rPr>
-              <a:t>A research object includes</a:t>
-            </a:r>
-          </a:p>
-          <a:p xmlns:a="http://schemas.openxmlformats.org/drawingml/2006/main">
-            <a:pPr>
-              <a:defRPr sz="2625" b="1">
-                <a:solidFill>
-                  <a:srgbClr val="183A3C"/>
-                </a:solidFill>
-                <a:latin typeface="Arial"/>
-                <a:ea typeface="Arial"/>
-                <a:cs typeface="Arial"/>
-              </a:defRPr>
-            </a:pPr>
-            <a:r>
-              <a:rPr sz="2625" b="1">
-                <a:solidFill>
-                  <a:srgbClr val="183A3C"/>
-                </a:solidFill>
-                <a:latin typeface="Arial"/>
-                <a:ea typeface="Arial"/>
-                <a:cs typeface="Arial"/>
-              </a:rPr>
-              <a:t>the result and what it takes</a:t>
-            </a:r>
-          </a:p>
-          <a:p xmlns:a="http://schemas.openxmlformats.org/drawingml/2006/main">
-            <a:pPr>
-              <a:defRPr sz="2625" b="1">
-                <a:solidFill>
-                  <a:srgbClr val="183A3C"/>
-                </a:solidFill>
-                <a:latin typeface="Arial"/>
-                <a:ea typeface="Arial"/>
-                <a:cs typeface="Arial"/>
-              </a:defRPr>
-            </a:pPr>
-            <a:r>
-              <a:rPr sz="2625" b="1">
-                <a:solidFill>
-                  <a:srgbClr val="183A3C"/>
-                </a:solidFill>
-                <a:latin typeface="Arial"/>
-                <a:ea typeface="Arial"/>
-                <a:cs typeface="Arial"/>
-              </a:rPr>
-              <a:t>to inspect or rerun it.</a:t>
-            </a:r>
-          </a:p>
-        </p:txBody>
-      </p:sp>
-      <p:sp>
-        <p:nvSpPr>
-          <p:cNvPr id="4" name="">
+              <a:t>Explore the preparation</a:t>
+            </a:r>
+          </a:p>
+        </p:txBody>
+      </p:sp>
+      <p:sp>
+        <p:nvSpPr>
+          <p:cNvPr id="6" name="">
             <a:extLst xmlns:a="http://schemas.openxmlformats.org/drawingml/2006/main">
               <a:ext uri="{FF2B5EF4-FFF2-40B4-BE49-F238E27FC236}">
-                <a16:creationId xmlns:a16="http://schemas.microsoft.com/office/drawing/2014/main" id="{6D8CCB30-D839-472A-B29B-AFCE7969E493}"/>
+                <a16:creationId xmlns:a16="http://schemas.microsoft.com/office/drawing/2014/main" id="{07F268C8-833A-4773-AC55-0BF56C7195A5}"/>
               </a:ext>
             </a:extLst>
           </p:cNvPr>
@@ -5159,8 +5545,8 @@
         </p:nvSpPr>
         <p:spPr>
           <a:xfrm xmlns:a="http://schemas.openxmlformats.org/drawingml/2006/main">
-            <a:off x="6953250" y="3762375"/>
-            <a:ext cx="4667250" cy="1428750"/>
+            <a:off x="6324600" y="5857875"/>
+            <a:ext cx="5238750" cy="361950"/>
           </a:xfrm>
           <a:prstGeom xmlns:a="http://schemas.openxmlformats.org/drawingml/2006/main" prst="rect">
             <a:avLst/>
@@ -5174,9 +5560,9 @@
           <a:bodyPr xmlns:a="http://schemas.openxmlformats.org/drawingml/2006/main" lIns="0" tIns="0" rIns="0" bIns="0"/>
           <a:lstStyle xmlns:a="http://schemas.openxmlformats.org/drawingml/2006/main">
             <a:defPPr>
-              <a:defRPr sz="2100" b="0">
-                <a:solidFill>
-                  <a:srgbClr val="183A3C"/>
+              <a:defRPr sz="1800" b="0">
+                <a:solidFill>
+                  <a:srgbClr val="15716E"/>
                 </a:solidFill>
                 <a:latin typeface="Arial"/>
                 <a:ea typeface="Arial"/>
@@ -5186,9 +5572,9 @@
           </a:lstStyle>
           <a:p xmlns:a="http://schemas.openxmlformats.org/drawingml/2006/main">
             <a:pPr>
-              <a:defRPr sz="2100" b="0">
-                <a:solidFill>
-                  <a:srgbClr val="183A3C"/>
+              <a:defRPr sz="1800" b="0">
+                <a:solidFill>
+                  <a:srgbClr val="15716E"/>
                 </a:solidFill>
                 <a:latin typeface="Arial"/>
                 <a:ea typeface="Arial"/>
@@ -5196,195 +5582,16 @@
               </a:defRPr>
             </a:pPr>
             <a:r>
-              <a:rPr sz="2100" b="0">
-                <a:solidFill>
-                  <a:srgbClr val="183A3C"/>
-                </a:solidFill>
-                <a:latin typeface="Arial"/>
-                <a:ea typeface="Arial"/>
-                <a:cs typeface="Arial"/>
+              <a:rPr sz="1800" b="0">
+                <a:solidFill>
+                  <a:srgbClr val="15716E"/>
+                </a:solidFill>
+                <a:latin typeface="Arial"/>
+                <a:ea typeface="Arial"/>
+                <a:cs typeface="Arial"/>
+                <a:hlinkClick xmlns:r="http://schemas.openxmlformats.org/officeDocument/2006/relationships" r:id="R22ad2b7699ba4eff"/>
               </a:rPr>
-              <a:t>STAMPED asks about the package:</a:t>
-            </a:r>
-          </a:p>
-          <a:p xmlns:a="http://schemas.openxmlformats.org/drawingml/2006/main">
-            <a:pPr>
-              <a:defRPr sz="2100" b="0">
-                <a:solidFill>
-                  <a:srgbClr val="183A3C"/>
-                </a:solidFill>
-                <a:latin typeface="Arial"/>
-                <a:ea typeface="Arial"/>
-                <a:cs typeface="Arial"/>
-              </a:defRPr>
-            </a:pPr>
-            <a:r>
-              <a:rPr sz="2100" b="0">
-                <a:solidFill>
-                  <a:srgbClr val="183A3C"/>
-                </a:solidFill>
-                <a:latin typeface="Arial"/>
-                <a:ea typeface="Arial"/>
-                <a:cs typeface="Arial"/>
-              </a:rPr>
-              <a:t>its history, its parts, its environment,</a:t>
-            </a:r>
-          </a:p>
-          <a:p xmlns:a="http://schemas.openxmlformats.org/drawingml/2006/main">
-            <a:pPr>
-              <a:defRPr sz="2100" b="0">
-                <a:solidFill>
-                  <a:srgbClr val="183A3C"/>
-                </a:solidFill>
-                <a:latin typeface="Arial"/>
-                <a:ea typeface="Arial"/>
-                <a:cs typeface="Arial"/>
-              </a:defRPr>
-            </a:pPr>
-            <a:r>
-              <a:rPr sz="2100" b="0">
-                <a:solidFill>
-                  <a:srgbClr val="183A3C"/>
-                </a:solidFill>
-                <a:latin typeface="Arial"/>
-                <a:ea typeface="Arial"/>
-                <a:cs typeface="Arial"/>
-              </a:rPr>
-              <a:t>and how someone else can use it.</a:t>
-            </a:r>
-          </a:p>
-        </p:txBody>
-      </p:sp>
-      <p:sp>
-        <p:nvSpPr>
-          <p:cNvPr id="5" name="">
-            <a:extLst xmlns:a="http://schemas.openxmlformats.org/drawingml/2006/main">
-              <a:ext uri="{FF2B5EF4-FFF2-40B4-BE49-F238E27FC236}">
-                <a16:creationId xmlns:a16="http://schemas.microsoft.com/office/drawing/2014/main" id="{44845F09-85C0-446C-9E17-1E9175F1366A}"/>
-              </a:ext>
-            </a:extLst>
-          </p:cNvPr>
-          <p:cNvSpPr>
-            <a:spLocks xmlns:a="http://schemas.openxmlformats.org/drawingml/2006/main" noGrp="1"/>
-          </p:cNvSpPr>
-          <p:nvPr/>
-        </p:nvSpPr>
-        <p:spPr>
-          <a:xfrm xmlns:a="http://schemas.openxmlformats.org/drawingml/2006/main">
-            <a:off x="609600" y="6153150"/>
-            <a:ext cx="6096000" cy="361950"/>
-          </a:xfrm>
-          <a:prstGeom xmlns:a="http://schemas.openxmlformats.org/drawingml/2006/main" prst="rect">
-            <a:avLst/>
-          </a:prstGeom>
-          <a:noFill xmlns:a="http://schemas.openxmlformats.org/drawingml/2006/main"/>
-          <a:ln xmlns:a="http://schemas.openxmlformats.org/drawingml/2006/main" w="0">
-            <a:noFill/>
-          </a:ln>
-        </p:spPr>
-        <p:txBody>
-          <a:bodyPr xmlns:a="http://schemas.openxmlformats.org/drawingml/2006/main" lIns="0" tIns="0" rIns="0" bIns="0"/>
-          <a:lstStyle xmlns:a="http://schemas.openxmlformats.org/drawingml/2006/main">
-            <a:defPPr>
-              <a:defRPr sz="1800" b="0">
-                <a:solidFill>
-                  <a:srgbClr val="15716E"/>
-                </a:solidFill>
-                <a:latin typeface="Arial"/>
-                <a:ea typeface="Arial"/>
-                <a:cs typeface="Arial"/>
-              </a:defRPr>
-            </a:defPPr>
-          </a:lstStyle>
-          <a:p xmlns:a="http://schemas.openxmlformats.org/drawingml/2006/main">
-            <a:pPr>
-              <a:defRPr sz="1800" b="0">
-                <a:solidFill>
-                  <a:srgbClr val="15716E"/>
-                </a:solidFill>
-                <a:latin typeface="Arial"/>
-                <a:ea typeface="Arial"/>
-                <a:cs typeface="Arial"/>
-              </a:defRPr>
-            </a:pPr>
-            <a:r>
-              <a:rPr sz="1800" b="0">
-                <a:solidFill>
-                  <a:srgbClr val="15716E"/>
-                </a:solidFill>
-                <a:latin typeface="Arial"/>
-                <a:ea typeface="Arial"/>
-                <a:cs typeface="Arial"/>
-                <a:hlinkClick xmlns:r="http://schemas.openxmlformats.org/officeDocument/2006/relationships" r:id="Re6867add8c5d446a"/>
-              </a:rPr>
-              <a:t>Research objects with AI: the talk</a:t>
-            </a:r>
-          </a:p>
-        </p:txBody>
-      </p:sp>
-      <p:sp>
-        <p:nvSpPr>
-          <p:cNvPr id="6" name="">
-            <a:extLst xmlns:a="http://schemas.openxmlformats.org/drawingml/2006/main">
-              <a:ext uri="{FF2B5EF4-FFF2-40B4-BE49-F238E27FC236}">
-                <a16:creationId xmlns:a16="http://schemas.microsoft.com/office/drawing/2014/main" id="{87A62A40-21EC-4250-98EA-642F2777BFCB}"/>
-              </a:ext>
-            </a:extLst>
-          </p:cNvPr>
-          <p:cNvSpPr>
-            <a:spLocks xmlns:a="http://schemas.openxmlformats.org/drawingml/2006/main" noGrp="1"/>
-          </p:cNvSpPr>
-          <p:nvPr/>
-        </p:nvSpPr>
-        <p:spPr>
-          <a:xfrm xmlns:a="http://schemas.openxmlformats.org/drawingml/2006/main">
-            <a:off x="6953250" y="6153150"/>
-            <a:ext cx="4572000" cy="361950"/>
-          </a:xfrm>
-          <a:prstGeom xmlns:a="http://schemas.openxmlformats.org/drawingml/2006/main" prst="rect">
-            <a:avLst/>
-          </a:prstGeom>
-          <a:noFill xmlns:a="http://schemas.openxmlformats.org/drawingml/2006/main"/>
-          <a:ln xmlns:a="http://schemas.openxmlformats.org/drawingml/2006/main" w="0">
-            <a:noFill/>
-          </a:ln>
-        </p:spPr>
-        <p:txBody>
-          <a:bodyPr xmlns:a="http://schemas.openxmlformats.org/drawingml/2006/main" lIns="0" tIns="0" rIns="0" bIns="0"/>
-          <a:lstStyle xmlns:a="http://schemas.openxmlformats.org/drawingml/2006/main">
-            <a:defPPr>
-              <a:defRPr sz="1800" b="0">
-                <a:solidFill>
-                  <a:srgbClr val="15716E"/>
-                </a:solidFill>
-                <a:latin typeface="Arial"/>
-                <a:ea typeface="Arial"/>
-                <a:cs typeface="Arial"/>
-              </a:defRPr>
-            </a:defPPr>
-          </a:lstStyle>
-          <a:p xmlns:a="http://schemas.openxmlformats.org/drawingml/2006/main">
-            <a:pPr>
-              <a:defRPr sz="1800" b="0">
-                <a:solidFill>
-                  <a:srgbClr val="15716E"/>
-                </a:solidFill>
-                <a:latin typeface="Arial"/>
-                <a:ea typeface="Arial"/>
-                <a:cs typeface="Arial"/>
-              </a:defRPr>
-            </a:pPr>
-            <a:r>
-              <a:rPr sz="1800" b="0">
-                <a:solidFill>
-                  <a:srgbClr val="15716E"/>
-                </a:solidFill>
-                <a:latin typeface="Arial"/>
-                <a:ea typeface="Arial"/>
-                <a:cs typeface="Arial"/>
-                <a:hlinkClick xmlns:r="http://schemas.openxmlformats.org/officeDocument/2006/relationships" r:id="Rd541cc7dd5ae4e89"/>
-              </a:rPr>
-              <a:t>STAMPED principles</a:t>
+              <a:t>Open the presentation</a:t>
             </a:r>
           </a:p>
         </p:txBody>
@@ -5392,7 +5599,7 @@
     </p:spTree>
     <p:extLst>
       <p:ext uri="{BB962C8B-B14F-4D97-AF65-F5344CB8AC3E}">
-        <p14:creationId xmlns:p14="http://schemas.microsoft.com/office/powerpoint/2010/main" val="1600238096"/>
+        <p14:creationId xmlns:p14="http://schemas.microsoft.com/office/powerpoint/2010/main" val="1960180764"/>
       </p:ext>
     </p:extLst>
   </p:cSld>
@@ -5420,10 +5627,10 @@
       </p:grpSpPr>
       <p:sp>
         <p:nvSpPr>
-          <p:cNvPr id="9" name="">
+          <p:cNvPr id="7" name="">
             <a:extLst xmlns:a="http://schemas.openxmlformats.org/drawingml/2006/main">
               <a:ext uri="{FF2B5EF4-FFF2-40B4-BE49-F238E27FC236}">
-                <a16:creationId xmlns:a16="http://schemas.microsoft.com/office/drawing/2014/main" id="{954563A2-2981-47EB-996C-3B59AEA40F9A}"/>
+                <a16:creationId xmlns:a16="http://schemas.microsoft.com/office/drawing/2014/main" id="{B0F7F9C0-3DF9-4327-BC2F-C70488888469}"/>
               </a:ext>
             </a:extLst>
           </p:cNvPr>
@@ -5435,7 +5642,7 @@
         <p:spPr>
           <a:xfrm xmlns:a="http://schemas.openxmlformats.org/drawingml/2006/main">
             <a:off x="609600" y="523875"/>
-            <a:ext cx="10972800" cy="714375"/>
+            <a:ext cx="10972800" cy="809625"/>
           </a:xfrm>
           <a:prstGeom xmlns:a="http://schemas.openxmlformats.org/drawingml/2006/main" prst="rect">
             <a:avLst/>
@@ -5479,29 +5686,57 @@
                 <a:ea typeface="Arial"/>
                 <a:cs typeface="Arial"/>
               </a:rPr>
-              <a:t>Orinoco Lite</a:t>
-            </a:r>
-          </a:p>
-        </p:txBody>
-      </p:sp>
-      <p:sp>
-        <p:nvSpPr>
+              <a:t>What did we just make?</a:t>
+            </a:r>
+          </a:p>
+        </p:txBody>
+      </p:sp>
+      <p:pic>
+        <p:nvPicPr>
           <p:cNvPr id="2" name="">
             <a:extLst xmlns:a="http://schemas.openxmlformats.org/drawingml/2006/main">
               <a:ext uri="{FF2B5EF4-FFF2-40B4-BE49-F238E27FC236}">
-                <a16:creationId xmlns:a16="http://schemas.microsoft.com/office/drawing/2014/main" id="{372CF419-69A5-4417-9BB1-1CFFDCD4CC87}"/>
+                <a16:creationId xmlns:a16="http://schemas.microsoft.com/office/drawing/2014/main" id="{53E821E4-CFA5-4E80-A8A7-9B288A20580B}"/>
               </a:ext>
             </a:extLst>
           </p:cNvPr>
-          <p:cNvSpPr>
-            <a:spLocks xmlns:a="http://schemas.openxmlformats.org/drawingml/2006/main" noGrp="1"/>
-          </p:cNvSpPr>
+          <p:cNvPicPr>
+            <a:picLocks xmlns:a="http://schemas.openxmlformats.org/drawingml/2006/main" noChangeAspect="1"/>
+          </p:cNvPicPr>
           <p:nvPr/>
-        </p:nvSpPr>
+        </p:nvPicPr>
+        <p:blipFill>
+          <a:blip xmlns:r="http://schemas.openxmlformats.org/officeDocument/2006/relationships" xmlns:a="http://schemas.openxmlformats.org/drawingml/2006/main" r:embed="R542c20a03a8547ec"/>
+          <a:stretch xmlns:a="http://schemas.openxmlformats.org/drawingml/2006/main"/>
+        </p:blipFill>
         <p:spPr>
           <a:xfrm xmlns:a="http://schemas.openxmlformats.org/drawingml/2006/main">
-            <a:off x="609600" y="1428750"/>
-            <a:ext cx="5524500" cy="1000125"/>
+            <a:off x="609600" y="1813322"/>
+            <a:ext cx="5810250" cy="3631406"/>
+          </a:xfrm>
+          <a:prstGeom xmlns:a="http://schemas.openxmlformats.org/drawingml/2006/main" prst="rect">
+            <a:avLst/>
+          </a:prstGeom>
+        </p:spPr>
+      </p:pic>
+      <p:sp>
+        <p:nvSpPr>
+          <p:cNvPr id="3" name="">
+            <a:extLst xmlns:a="http://schemas.openxmlformats.org/drawingml/2006/main">
+              <a:ext uri="{FF2B5EF4-FFF2-40B4-BE49-F238E27FC236}">
+                <a16:creationId xmlns:a16="http://schemas.microsoft.com/office/drawing/2014/main" id="{DE033887-4D6D-4AE5-B5FB-A5C433DB5F02}"/>
+              </a:ext>
+            </a:extLst>
+          </p:cNvPr>
+          <p:cNvSpPr>
+            <a:spLocks xmlns:a="http://schemas.openxmlformats.org/drawingml/2006/main" noGrp="1"/>
+          </p:cNvSpPr>
+          <p:nvPr/>
+        </p:nvSpPr>
+        <p:spPr>
+          <a:xfrm xmlns:a="http://schemas.openxmlformats.org/drawingml/2006/main">
+            <a:off x="6953250" y="1924050"/>
+            <a:ext cx="4667250" cy="1476375"/>
           </a:xfrm>
           <a:prstGeom xmlns:a="http://schemas.openxmlformats.org/drawingml/2006/main" prst="rect">
             <a:avLst/>
@@ -5515,7 +5750,7 @@
           <a:bodyPr xmlns:a="http://schemas.openxmlformats.org/drawingml/2006/main" lIns="0" tIns="0" rIns="0" bIns="0"/>
           <a:lstStyle xmlns:a="http://schemas.openxmlformats.org/drawingml/2006/main">
             <a:defPPr>
-              <a:defRPr sz="2925" b="1">
+              <a:defRPr sz="2625" b="1">
                 <a:solidFill>
                   <a:srgbClr val="183A3C"/>
                 </a:solidFill>
@@ -5527,7 +5762,7 @@
           </a:lstStyle>
           <a:p xmlns:a="http://schemas.openxmlformats.org/drawingml/2006/main">
             <a:pPr>
-              <a:defRPr sz="2925" b="1">
+              <a:defRPr sz="2625" b="1">
                 <a:solidFill>
                   <a:srgbClr val="183A3C"/>
                 </a:solidFill>
@@ -5537,7 +5772,7 @@
               </a:defRPr>
             </a:pPr>
             <a:r>
-              <a:rPr sz="2925" b="1">
+              <a:rPr sz="2625" b="1">
                 <a:solidFill>
                   <a:srgbClr val="183A3C"/>
                 </a:solidFill>
@@ -5545,17 +5780,63 @@
                 <a:ea typeface="Arial"/>
                 <a:cs typeface="Arial"/>
               </a:rPr>
-              <a:t>Connected research information</a:t>
-            </a:r>
-          </a:p>
-        </p:txBody>
-      </p:sp>
-      <p:sp>
-        <p:nvSpPr>
-          <p:cNvPr id="3" name="">
+              <a:t>A research object includes</a:t>
+            </a:r>
+          </a:p>
+          <a:p xmlns:a="http://schemas.openxmlformats.org/drawingml/2006/main">
+            <a:pPr>
+              <a:defRPr sz="2625" b="1">
+                <a:solidFill>
+                  <a:srgbClr val="183A3C"/>
+                </a:solidFill>
+                <a:latin typeface="Arial"/>
+                <a:ea typeface="Arial"/>
+                <a:cs typeface="Arial"/>
+              </a:defRPr>
+            </a:pPr>
+            <a:r>
+              <a:rPr sz="2625" b="1">
+                <a:solidFill>
+                  <a:srgbClr val="183A3C"/>
+                </a:solidFill>
+                <a:latin typeface="Arial"/>
+                <a:ea typeface="Arial"/>
+                <a:cs typeface="Arial"/>
+              </a:rPr>
+              <a:t>the result and what it takes</a:t>
+            </a:r>
+          </a:p>
+          <a:p xmlns:a="http://schemas.openxmlformats.org/drawingml/2006/main">
+            <a:pPr>
+              <a:defRPr sz="2625" b="1">
+                <a:solidFill>
+                  <a:srgbClr val="183A3C"/>
+                </a:solidFill>
+                <a:latin typeface="Arial"/>
+                <a:ea typeface="Arial"/>
+                <a:cs typeface="Arial"/>
+              </a:defRPr>
+            </a:pPr>
+            <a:r>
+              <a:rPr sz="2625" b="1">
+                <a:solidFill>
+                  <a:srgbClr val="183A3C"/>
+                </a:solidFill>
+                <a:latin typeface="Arial"/>
+                <a:ea typeface="Arial"/>
+                <a:cs typeface="Arial"/>
+              </a:rPr>
+              <a:t>to inspect or rerun it.</a:t>
+            </a:r>
+          </a:p>
+        </p:txBody>
+      </p:sp>
+      <p:sp>
+        <p:nvSpPr>
+          <p:cNvPr id="4" name="">
             <a:extLst xmlns:a="http://schemas.openxmlformats.org/drawingml/2006/main">
               <a:ext uri="{FF2B5EF4-FFF2-40B4-BE49-F238E27FC236}">
-                <a16:creationId xmlns:a16="http://schemas.microsoft.com/office/drawing/2014/main" id="{F146A648-4FE7-4E33-A4E0-F6CAA491FBF6}"/>
+                <a16:creationId xmlns:a16="http://schemas.microsoft.com/office/drawing/2014/main" id="{D11FABB8-8479-4E07-B229-A295BC617153}"/>
               </a:ext>
             </a:extLst>
           </p:cNvPr>
@@ -5566,8 +5847,8 @@
         </p:nvSpPr>
         <p:spPr>
           <a:xfrm xmlns:a="http://schemas.openxmlformats.org/drawingml/2006/main">
-            <a:off x="609600" y="2762250"/>
-            <a:ext cx="5429250" cy="952500"/>
+            <a:off x="6953250" y="3762375"/>
+            <a:ext cx="4667250" cy="1428750"/>
           </a:xfrm>
           <a:prstGeom xmlns:a="http://schemas.openxmlformats.org/drawingml/2006/main" prst="rect">
             <a:avLst/>
@@ -5581,7 +5862,7 @@
           <a:bodyPr xmlns:a="http://schemas.openxmlformats.org/drawingml/2006/main" lIns="0" tIns="0" rIns="0" bIns="0"/>
           <a:lstStyle xmlns:a="http://schemas.openxmlformats.org/drawingml/2006/main">
             <a:defPPr>
-              <a:defRPr sz="2400" b="0">
+              <a:defRPr sz="2100" b="0">
                 <a:solidFill>
                   <a:srgbClr val="183A3C"/>
                 </a:solidFill>
@@ -5593,7 +5874,7 @@
           </a:lstStyle>
           <a:p xmlns:a="http://schemas.openxmlformats.org/drawingml/2006/main">
             <a:pPr>
-              <a:defRPr sz="2400" b="0">
+              <a:defRPr sz="2100" b="0">
                 <a:solidFill>
                   <a:srgbClr val="183A3C"/>
                 </a:solidFill>
@@ -5603,7 +5884,7 @@
               </a:defRPr>
             </a:pPr>
             <a:r>
-              <a:rPr sz="2400" b="0">
+              <a:rPr sz="2100" b="0">
                 <a:solidFill>
                   <a:srgbClr val="183A3C"/>
                 </a:solidFill>
@@ -5611,12 +5892,12 @@
                 <a:ea typeface="Arial"/>
                 <a:cs typeface="Arial"/>
               </a:rPr>
-              <a:t>People, projects and outputs</a:t>
+              <a:t>STAMPED asks about the package:</a:t>
             </a:r>
           </a:p>
           <a:p xmlns:a="http://schemas.openxmlformats.org/drawingml/2006/main">
             <a:pPr>
-              <a:defRPr sz="2400" b="0">
+              <a:defRPr sz="2100" b="0">
                 <a:solidFill>
                   <a:srgbClr val="183A3C"/>
                 </a:solidFill>
@@ -5626,7 +5907,7 @@
               </a:defRPr>
             </a:pPr>
             <a:r>
-              <a:rPr sz="2400" b="0">
+              <a:rPr sz="2100" b="0">
                 <a:solidFill>
                   <a:srgbClr val="183A3C"/>
                 </a:solidFill>
@@ -5634,17 +5915,40 @@
                 <a:ea typeface="Arial"/>
                 <a:cs typeface="Arial"/>
               </a:rPr>
-              <a:t>share explicit relationships.</a:t>
-            </a:r>
-          </a:p>
-        </p:txBody>
-      </p:sp>
-      <p:sp>
-        <p:nvSpPr>
-          <p:cNvPr id="4" name="">
+              <a:t>its history, its parts, its environment,</a:t>
+            </a:r>
+          </a:p>
+          <a:p xmlns:a="http://schemas.openxmlformats.org/drawingml/2006/main">
+            <a:pPr>
+              <a:defRPr sz="2100" b="0">
+                <a:solidFill>
+                  <a:srgbClr val="183A3C"/>
+                </a:solidFill>
+                <a:latin typeface="Arial"/>
+                <a:ea typeface="Arial"/>
+                <a:cs typeface="Arial"/>
+              </a:defRPr>
+            </a:pPr>
+            <a:r>
+              <a:rPr sz="2100" b="0">
+                <a:solidFill>
+                  <a:srgbClr val="183A3C"/>
+                </a:solidFill>
+                <a:latin typeface="Arial"/>
+                <a:ea typeface="Arial"/>
+                <a:cs typeface="Arial"/>
+              </a:rPr>
+              <a:t>and how someone else can use it.</a:t>
+            </a:r>
+          </a:p>
+        </p:txBody>
+      </p:sp>
+      <p:sp>
+        <p:nvSpPr>
+          <p:cNvPr id="5" name="">
             <a:extLst xmlns:a="http://schemas.openxmlformats.org/drawingml/2006/main">
               <a:ext uri="{FF2B5EF4-FFF2-40B4-BE49-F238E27FC236}">
-                <a16:creationId xmlns:a16="http://schemas.microsoft.com/office/drawing/2014/main" id="{0DD24F89-1C08-40FB-9C7D-E39C00471D45}"/>
+                <a16:creationId xmlns:a16="http://schemas.microsoft.com/office/drawing/2014/main" id="{C2D4D0CE-095D-4469-A80D-56ABA06B8511}"/>
               </a:ext>
             </a:extLst>
           </p:cNvPr>
@@ -5655,8 +5959,8 @@
         </p:nvSpPr>
         <p:spPr>
           <a:xfrm xmlns:a="http://schemas.openxmlformats.org/drawingml/2006/main">
-            <a:off x="609600" y="4000500"/>
-            <a:ext cx="5429250" cy="1476375"/>
+            <a:off x="609600" y="6153150"/>
+            <a:ext cx="6096000" cy="361950"/>
           </a:xfrm>
           <a:prstGeom xmlns:a="http://schemas.openxmlformats.org/drawingml/2006/main" prst="rect">
             <a:avLst/>
@@ -5670,9 +5974,9 @@
           <a:bodyPr xmlns:a="http://schemas.openxmlformats.org/drawingml/2006/main" lIns="0" tIns="0" rIns="0" bIns="0"/>
           <a:lstStyle xmlns:a="http://schemas.openxmlformats.org/drawingml/2006/main">
             <a:defPPr>
-              <a:defRPr sz="2175" b="0">
-                <a:solidFill>
-                  <a:srgbClr val="183A3C"/>
+              <a:defRPr sz="1800" b="0">
+                <a:solidFill>
+                  <a:srgbClr val="15716E"/>
                 </a:solidFill>
                 <a:latin typeface="Arial"/>
                 <a:ea typeface="Arial"/>
@@ -5682,9 +5986,9 @@
           </a:lstStyle>
           <a:p xmlns:a="http://schemas.openxmlformats.org/drawingml/2006/main">
             <a:pPr>
-              <a:defRPr sz="2175" b="0">
-                <a:solidFill>
-                  <a:srgbClr val="183A3C"/>
+              <a:defRPr sz="1800" b="0">
+                <a:solidFill>
+                  <a:srgbClr val="15716E"/>
                 </a:solidFill>
                 <a:latin typeface="Arial"/>
                 <a:ea typeface="Arial"/>
@@ -5692,111 +5996,38 @@
               </a:defRPr>
             </a:pPr>
             <a:r>
-              <a:rPr sz="2175" b="0">
-                <a:solidFill>
-                  <a:srgbClr val="183A3C"/>
-                </a:solidFill>
-                <a:latin typeface="Arial"/>
-                <a:ea typeface="Arial"/>
-                <a:cs typeface="Arial"/>
+              <a:rPr sz="1800" b="0">
+                <a:solidFill>
+                  <a:srgbClr val="15716E"/>
+                </a:solidFill>
+                <a:latin typeface="Arial"/>
+                <a:ea typeface="Arial"/>
+                <a:cs typeface="Arial"/>
+                <a:hlinkClick xmlns:r="http://schemas.openxmlformats.org/officeDocument/2006/relationships" r:id="R49af0ce4084949d7"/>
               </a:rPr>
-              <a:t>An editor proposes changes.</a:t>
-            </a:r>
-          </a:p>
-          <a:p xmlns:a="http://schemas.openxmlformats.org/drawingml/2006/main">
-            <a:pPr>
-              <a:defRPr sz="2175" b="0">
-                <a:solidFill>
-                  <a:srgbClr val="183A3C"/>
-                </a:solidFill>
-                <a:latin typeface="Arial"/>
-                <a:ea typeface="Arial"/>
-                <a:cs typeface="Arial"/>
-              </a:defRPr>
-            </a:pPr>
-            <a:r>
-              <a:rPr sz="2175" b="0">
-                <a:solidFill>
-                  <a:srgbClr val="183A3C"/>
-                </a:solidFill>
-                <a:latin typeface="Arial"/>
-                <a:ea typeface="Arial"/>
-                <a:cs typeface="Arial"/>
-              </a:rPr>
-              <a:t>GitHub review preserves the history.</a:t>
-            </a:r>
-          </a:p>
-          <a:p xmlns:a="http://schemas.openxmlformats.org/drawingml/2006/main">
-            <a:pPr>
-              <a:defRPr sz="2175" b="0">
-                <a:solidFill>
-                  <a:srgbClr val="183A3C"/>
-                </a:solidFill>
-                <a:latin typeface="Arial"/>
-                <a:ea typeface="Arial"/>
-                <a:cs typeface="Arial"/>
-              </a:defRPr>
-            </a:pPr>
-            <a:r>
-              <a:rPr sz="2175" b="0">
-                <a:solidFill>
-                  <a:srgbClr val="183A3C"/>
-                </a:solidFill>
-                <a:latin typeface="Arial"/>
-                <a:ea typeface="Arial"/>
-                <a:cs typeface="Arial"/>
-              </a:rPr>
-              <a:t>The records feed a website and graph.</a:t>
-            </a:r>
-          </a:p>
-        </p:txBody>
-      </p:sp>
-      <p:pic>
-        <p:nvPicPr>
-          <p:cNvPr id="5" name="">
+              <a:t>Research objects with AI: the talk</a:t>
+            </a:r>
+          </a:p>
+        </p:txBody>
+      </p:sp>
+      <p:sp>
+        <p:nvSpPr>
+          <p:cNvPr id="6" name="">
             <a:extLst xmlns:a="http://schemas.openxmlformats.org/drawingml/2006/main">
               <a:ext uri="{FF2B5EF4-FFF2-40B4-BE49-F238E27FC236}">
-                <a16:creationId xmlns:a16="http://schemas.microsoft.com/office/drawing/2014/main" id="{E58CAB46-C422-482B-A696-CA88A6E7E025}"/>
+                <a16:creationId xmlns:a16="http://schemas.microsoft.com/office/drawing/2014/main" id="{D6898661-B914-4744-B94B-A12B57222651}"/>
               </a:ext>
             </a:extLst>
           </p:cNvPr>
-          <p:cNvPicPr>
-            <a:picLocks xmlns:a="http://schemas.openxmlformats.org/drawingml/2006/main" noChangeAspect="1"/>
-          </p:cNvPicPr>
+          <p:cNvSpPr>
+            <a:spLocks xmlns:a="http://schemas.openxmlformats.org/drawingml/2006/main" noGrp="1"/>
+          </p:cNvSpPr>
           <p:nvPr/>
-        </p:nvPicPr>
-        <p:blipFill>
-          <a:blip xmlns:r="http://schemas.openxmlformats.org/officeDocument/2006/relationships" xmlns:a="http://schemas.openxmlformats.org/drawingml/2006/main" r:embed="Rfa97f16a7c434a0b"/>
-          <a:stretch xmlns:a="http://schemas.openxmlformats.org/drawingml/2006/main"/>
-        </p:blipFill>
+        </p:nvSpPr>
         <p:spPr>
           <a:xfrm xmlns:a="http://schemas.openxmlformats.org/drawingml/2006/main">
-            <a:off x="6766560" y="1381125"/>
-            <a:ext cx="4373880" cy="4333875"/>
-          </a:xfrm>
-          <a:prstGeom xmlns:a="http://schemas.openxmlformats.org/drawingml/2006/main" prst="rect">
-            <a:avLst/>
-          </a:prstGeom>
-        </p:spPr>
-      </p:pic>
-      <p:sp>
-        <p:nvSpPr>
-          <p:cNvPr id="6" name="">
-            <a:extLst xmlns:a="http://schemas.openxmlformats.org/drawingml/2006/main">
-              <a:ext uri="{FF2B5EF4-FFF2-40B4-BE49-F238E27FC236}">
-                <a16:creationId xmlns:a16="http://schemas.microsoft.com/office/drawing/2014/main" id="{2271D289-B5A5-47EE-905B-6EF97A631F44}"/>
-              </a:ext>
-            </a:extLst>
-          </p:cNvPr>
-          <p:cNvSpPr>
-            <a:spLocks xmlns:a="http://schemas.openxmlformats.org/drawingml/2006/main" noGrp="1"/>
-          </p:cNvSpPr>
-          <p:nvPr/>
-        </p:nvSpPr>
-        <p:spPr>
-          <a:xfrm xmlns:a="http://schemas.openxmlformats.org/drawingml/2006/main">
-            <a:off x="609600" y="6153150"/>
-            <a:ext cx="3810000" cy="361950"/>
+            <a:off x="6953250" y="6153150"/>
+            <a:ext cx="4572000" cy="361950"/>
           </a:xfrm>
           <a:prstGeom xmlns:a="http://schemas.openxmlformats.org/drawingml/2006/main" prst="rect">
             <a:avLst/>
@@ -5839,143 +6070,9 @@
                 <a:latin typeface="Arial"/>
                 <a:ea typeface="Arial"/>
                 <a:cs typeface="Arial"/>
-                <a:hlinkClick xmlns:r="http://schemas.openxmlformats.org/officeDocument/2006/relationships" r:id="R8c5a3dca3f3d45cd"/>
+                <a:hlinkClick xmlns:r="http://schemas.openxmlformats.org/officeDocument/2006/relationships" r:id="Rf33befa126eb4aa8"/>
               </a:rPr>
-              <a:t>Project + source</a:t>
-            </a:r>
-          </a:p>
-        </p:txBody>
-      </p:sp>
-      <p:sp>
-        <p:nvSpPr>
-          <p:cNvPr id="7" name="">
-            <a:extLst xmlns:a="http://schemas.openxmlformats.org/drawingml/2006/main">
-              <a:ext uri="{FF2B5EF4-FFF2-40B4-BE49-F238E27FC236}">
-                <a16:creationId xmlns:a16="http://schemas.microsoft.com/office/drawing/2014/main" id="{CFEB11F4-DB45-4733-85C9-14272698A0AA}"/>
-              </a:ext>
-            </a:extLst>
-          </p:cNvPr>
-          <p:cNvSpPr>
-            <a:spLocks xmlns:a="http://schemas.openxmlformats.org/drawingml/2006/main" noGrp="1"/>
-          </p:cNvSpPr>
-          <p:nvPr/>
-        </p:nvSpPr>
-        <p:spPr>
-          <a:xfrm xmlns:a="http://schemas.openxmlformats.org/drawingml/2006/main">
-            <a:off x="4762500" y="6153150"/>
-            <a:ext cx="3238500" cy="361950"/>
-          </a:xfrm>
-          <a:prstGeom xmlns:a="http://schemas.openxmlformats.org/drawingml/2006/main" prst="rect">
-            <a:avLst/>
-          </a:prstGeom>
-          <a:noFill xmlns:a="http://schemas.openxmlformats.org/drawingml/2006/main"/>
-          <a:ln xmlns:a="http://schemas.openxmlformats.org/drawingml/2006/main" w="0">
-            <a:noFill/>
-          </a:ln>
-        </p:spPr>
-        <p:txBody>
-          <a:bodyPr xmlns:a="http://schemas.openxmlformats.org/drawingml/2006/main" lIns="0" tIns="0" rIns="0" bIns="0"/>
-          <a:lstStyle xmlns:a="http://schemas.openxmlformats.org/drawingml/2006/main">
-            <a:defPPr>
-              <a:defRPr sz="1800" b="0">
-                <a:solidFill>
-                  <a:srgbClr val="15716E"/>
-                </a:solidFill>
-                <a:latin typeface="Arial"/>
-                <a:ea typeface="Arial"/>
-                <a:cs typeface="Arial"/>
-              </a:defRPr>
-            </a:defPPr>
-          </a:lstStyle>
-          <a:p xmlns:a="http://schemas.openxmlformats.org/drawingml/2006/main">
-            <a:pPr>
-              <a:defRPr sz="1800" b="0">
-                <a:solidFill>
-                  <a:srgbClr val="15716E"/>
-                </a:solidFill>
-                <a:latin typeface="Arial"/>
-                <a:ea typeface="Arial"/>
-                <a:cs typeface="Arial"/>
-              </a:defRPr>
-            </a:pPr>
-            <a:r>
-              <a:rPr sz="1800" b="0">
-                <a:solidFill>
-                  <a:srgbClr val="15716E"/>
-                </a:solidFill>
-                <a:latin typeface="Arial"/>
-                <a:ea typeface="Arial"/>
-                <a:cs typeface="Arial"/>
-                <a:hlinkClick xmlns:r="http://schemas.openxmlformats.org/officeDocument/2006/relationships" r:id="R48a5c4b55b394fba"/>
-              </a:rPr>
-              <a:t>Explore the graph</a:t>
-            </a:r>
-          </a:p>
-        </p:txBody>
-      </p:sp>
-      <p:sp>
-        <p:nvSpPr>
-          <p:cNvPr id="8" name="">
-            <a:extLst xmlns:a="http://schemas.openxmlformats.org/drawingml/2006/main">
-              <a:ext uri="{FF2B5EF4-FFF2-40B4-BE49-F238E27FC236}">
-                <a16:creationId xmlns:a16="http://schemas.microsoft.com/office/drawing/2014/main" id="{2CC4E924-8A8D-41F5-934F-A4924CA72DB1}"/>
-              </a:ext>
-            </a:extLst>
-          </p:cNvPr>
-          <p:cNvSpPr>
-            <a:spLocks xmlns:a="http://schemas.openxmlformats.org/drawingml/2006/main" noGrp="1"/>
-          </p:cNvSpPr>
-          <p:nvPr/>
-        </p:nvSpPr>
-        <p:spPr>
-          <a:xfrm xmlns:a="http://schemas.openxmlformats.org/drawingml/2006/main">
-            <a:off x="9525000" y="6153150"/>
-            <a:ext cx="2000250" cy="361950"/>
-          </a:xfrm>
-          <a:prstGeom xmlns:a="http://schemas.openxmlformats.org/drawingml/2006/main" prst="rect">
-            <a:avLst/>
-          </a:prstGeom>
-          <a:noFill xmlns:a="http://schemas.openxmlformats.org/drawingml/2006/main"/>
-          <a:ln xmlns:a="http://schemas.openxmlformats.org/drawingml/2006/main" w="0">
-            <a:noFill/>
-          </a:ln>
-        </p:spPr>
-        <p:txBody>
-          <a:bodyPr xmlns:a="http://schemas.openxmlformats.org/drawingml/2006/main" lIns="0" tIns="0" rIns="0" bIns="0"/>
-          <a:lstStyle xmlns:a="http://schemas.openxmlformats.org/drawingml/2006/main">
-            <a:defPPr>
-              <a:defRPr sz="1800" b="0">
-                <a:solidFill>
-                  <a:srgbClr val="15716E"/>
-                </a:solidFill>
-                <a:latin typeface="Arial"/>
-                <a:ea typeface="Arial"/>
-                <a:cs typeface="Arial"/>
-              </a:defRPr>
-            </a:defPPr>
-          </a:lstStyle>
-          <a:p xmlns:a="http://schemas.openxmlformats.org/drawingml/2006/main">
-            <a:pPr>
-              <a:defRPr sz="1800" b="0">
-                <a:solidFill>
-                  <a:srgbClr val="15716E"/>
-                </a:solidFill>
-                <a:latin typeface="Arial"/>
-                <a:ea typeface="Arial"/>
-                <a:cs typeface="Arial"/>
-              </a:defRPr>
-            </a:pPr>
-            <a:r>
-              <a:rPr sz="1800" b="0">
-                <a:solidFill>
-                  <a:srgbClr val="15716E"/>
-                </a:solidFill>
-                <a:latin typeface="Arial"/>
-                <a:ea typeface="Arial"/>
-                <a:cs typeface="Arial"/>
-                <a:hlinkClick xmlns:r="http://schemas.openxmlformats.org/officeDocument/2006/relationships" r:id="R79b782204b654974"/>
-              </a:rPr>
-              <a:t>Poster</a:t>
+              <a:t>STAMPED principles</a:t>
             </a:r>
           </a:p>
         </p:txBody>
@@ -5983,7 +6080,7 @@
     </p:spTree>
     <p:extLst>
       <p:ext uri="{BB962C8B-B14F-4D97-AF65-F5344CB8AC3E}">
-        <p14:creationId xmlns:p14="http://schemas.microsoft.com/office/powerpoint/2010/main" val="1051359668"/>
+        <p14:creationId xmlns:p14="http://schemas.microsoft.com/office/powerpoint/2010/main" val="1533001854"/>
       </p:ext>
     </p:extLst>
   </p:cSld>
@@ -6011,10 +6108,10 @@
       </p:grpSpPr>
       <p:sp>
         <p:nvSpPr>
-          <p:cNvPr id="11" name="">
+          <p:cNvPr id="9" name="">
             <a:extLst xmlns:a="http://schemas.openxmlformats.org/drawingml/2006/main">
               <a:ext uri="{FF2B5EF4-FFF2-40B4-BE49-F238E27FC236}">
-                <a16:creationId xmlns:a16="http://schemas.microsoft.com/office/drawing/2014/main" id="{C1882910-780E-4127-84D8-D2360D9478D2}"/>
+                <a16:creationId xmlns:a16="http://schemas.microsoft.com/office/drawing/2014/main" id="{46FF48FB-3AAC-4374-B2D6-CAC6490EC69B}"/>
               </a:ext>
             </a:extLst>
           </p:cNvPr>
@@ -6026,7 +6123,7 @@
         <p:spPr>
           <a:xfrm xmlns:a="http://schemas.openxmlformats.org/drawingml/2006/main">
             <a:off x="609600" y="523875"/>
-            <a:ext cx="10972800" cy="809625"/>
+            <a:ext cx="10972800" cy="714375"/>
           </a:xfrm>
           <a:prstGeom xmlns:a="http://schemas.openxmlformats.org/drawingml/2006/main" prst="rect">
             <a:avLst/>
@@ -6070,7 +6167,7 @@
                 <a:ea typeface="Arial"/>
                 <a:cs typeface="Arial"/>
               </a:rPr>
-              <a:t>STAMPED in Practice</a:t>
+              <a:t>Orinoco Lite</a:t>
             </a:r>
           </a:p>
         </p:txBody>
@@ -6080,7 +6177,7 @@
           <p:cNvPr id="2" name="">
             <a:extLst xmlns:a="http://schemas.openxmlformats.org/drawingml/2006/main">
               <a:ext uri="{FF2B5EF4-FFF2-40B4-BE49-F238E27FC236}">
-                <a16:creationId xmlns:a16="http://schemas.microsoft.com/office/drawing/2014/main" id="{387D45B4-51CC-44E8-B821-CCCDF26B5F3B}"/>
+                <a16:creationId xmlns:a16="http://schemas.microsoft.com/office/drawing/2014/main" id="{CE8A8D7C-A257-420F-9729-A5DBB511F401}"/>
               </a:ext>
             </a:extLst>
           </p:cNvPr>
@@ -6091,8 +6188,8 @@
         </p:nvSpPr>
         <p:spPr>
           <a:xfrm xmlns:a="http://schemas.openxmlformats.org/drawingml/2006/main">
-            <a:off x="609600" y="1571625"/>
-            <a:ext cx="6619875" cy="1028700"/>
+            <a:off x="609600" y="1428750"/>
+            <a:ext cx="5524500" cy="1000125"/>
           </a:xfrm>
           <a:prstGeom xmlns:a="http://schemas.openxmlformats.org/drawingml/2006/main" prst="rect">
             <a:avLst/>
@@ -6106,7 +6203,7 @@
           <a:bodyPr xmlns:a="http://schemas.openxmlformats.org/drawingml/2006/main" lIns="0" tIns="0" rIns="0" bIns="0"/>
           <a:lstStyle xmlns:a="http://schemas.openxmlformats.org/drawingml/2006/main">
             <a:defPPr>
-              <a:defRPr sz="2775" b="1">
+              <a:defRPr sz="2925" b="1">
                 <a:solidFill>
                   <a:srgbClr val="183A3C"/>
                 </a:solidFill>
@@ -6118,7 +6215,7 @@
           </a:lstStyle>
           <a:p xmlns:a="http://schemas.openxmlformats.org/drawingml/2006/main">
             <a:pPr>
-              <a:defRPr sz="2775" b="1">
+              <a:defRPr sz="2925" b="1">
                 <a:solidFill>
                   <a:srgbClr val="183A3C"/>
                 </a:solidFill>
@@ -6128,7 +6225,7 @@
               </a:defRPr>
             </a:pPr>
             <a:r>
-              <a:rPr sz="2775" b="1">
+              <a:rPr sz="2925" b="1">
                 <a:solidFill>
                   <a:srgbClr val="183A3C"/>
                 </a:solidFill>
@@ -6136,30 +6233,7 @@
                 <a:ea typeface="Arial"/>
                 <a:cs typeface="Arial"/>
               </a:rPr>
-              <a:t>Skills that improve through</a:t>
-            </a:r>
-          </a:p>
-          <a:p xmlns:a="http://schemas.openxmlformats.org/drawingml/2006/main">
-            <a:pPr>
-              <a:defRPr sz="2775" b="1">
-                <a:solidFill>
-                  <a:srgbClr val="183A3C"/>
-                </a:solidFill>
-                <a:latin typeface="Arial"/>
-                <a:ea typeface="Arial"/>
-                <a:cs typeface="Arial"/>
-              </a:defRPr>
-            </a:pPr>
-            <a:r>
-              <a:rPr sz="2775" b="1">
-                <a:solidFill>
-                  <a:srgbClr val="183A3C"/>
-                </a:solidFill>
-                <a:latin typeface="Arial"/>
-                <a:ea typeface="Arial"/>
-                <a:cs typeface="Arial"/>
-              </a:rPr>
-              <a:t>scientific work</a:t>
+              <a:t>Connected research information</a:t>
             </a:r>
           </a:p>
         </p:txBody>
@@ -6169,7 +6243,7 @@
           <p:cNvPr id="3" name="">
             <a:extLst xmlns:a="http://schemas.openxmlformats.org/drawingml/2006/main">
               <a:ext uri="{FF2B5EF4-FFF2-40B4-BE49-F238E27FC236}">
-                <a16:creationId xmlns:a16="http://schemas.microsoft.com/office/drawing/2014/main" id="{8DFD4201-8B9A-4221-B2AD-022F95D55F8E}"/>
+                <a16:creationId xmlns:a16="http://schemas.microsoft.com/office/drawing/2014/main" id="{2B08EC72-ECB1-4B12-90B5-1A73F6568E14}"/>
               </a:ext>
             </a:extLst>
           </p:cNvPr>
@@ -6180,8 +6254,8 @@
         </p:nvSpPr>
         <p:spPr>
           <a:xfrm xmlns:a="http://schemas.openxmlformats.org/drawingml/2006/main">
-            <a:off x="609600" y="2952750"/>
-            <a:ext cx="6381750" cy="542925"/>
+            <a:off x="609600" y="2762250"/>
+            <a:ext cx="5429250" cy="952500"/>
           </a:xfrm>
           <a:prstGeom xmlns:a="http://schemas.openxmlformats.org/drawingml/2006/main" prst="rect">
             <a:avLst/>
@@ -6195,9 +6269,9 @@
           <a:bodyPr xmlns:a="http://schemas.openxmlformats.org/drawingml/2006/main" lIns="0" tIns="0" rIns="0" bIns="0"/>
           <a:lstStyle xmlns:a="http://schemas.openxmlformats.org/drawingml/2006/main">
             <a:defPPr>
-              <a:defRPr sz="2400" b="1">
-                <a:solidFill>
-                  <a:srgbClr val="15716E"/>
+              <a:defRPr sz="2400" b="0">
+                <a:solidFill>
+                  <a:srgbClr val="183A3C"/>
                 </a:solidFill>
                 <a:latin typeface="Arial"/>
                 <a:ea typeface="Arial"/>
@@ -6207,9 +6281,9 @@
           </a:lstStyle>
           <a:p xmlns:a="http://schemas.openxmlformats.org/drawingml/2006/main">
             <a:pPr>
-              <a:defRPr sz="2400" b="1">
-                <a:solidFill>
-                  <a:srgbClr val="15716E"/>
+              <a:defRPr sz="2400" b="0">
+                <a:solidFill>
+                  <a:srgbClr val="183A3C"/>
                 </a:solidFill>
                 <a:latin typeface="Arial"/>
                 <a:ea typeface="Arial"/>
@@ -6217,15 +6291,38 @@
               </a:defRPr>
             </a:pPr>
             <a:r>
-              <a:rPr sz="2400" b="1">
-                <a:solidFill>
-                  <a:srgbClr val="15716E"/>
+              <a:rPr sz="2400" b="0">
+                <a:solidFill>
+                  <a:srgbClr val="183A3C"/>
                 </a:solidFill>
                 <a:latin typeface="Arial"/>
                 <a:ea typeface="Arial"/>
                 <a:cs typeface="Arial"/>
               </a:rPr>
-              <a:t>Study record on Zenodo</a:t>
+              <a:t>People, projects and outputs</a:t>
+            </a:r>
+          </a:p>
+          <a:p xmlns:a="http://schemas.openxmlformats.org/drawingml/2006/main">
+            <a:pPr>
+              <a:defRPr sz="2400" b="0">
+                <a:solidFill>
+                  <a:srgbClr val="183A3C"/>
+                </a:solidFill>
+                <a:latin typeface="Arial"/>
+                <a:ea typeface="Arial"/>
+                <a:cs typeface="Arial"/>
+              </a:defRPr>
+            </a:pPr>
+            <a:r>
+              <a:rPr sz="2400" b="0">
+                <a:solidFill>
+                  <a:srgbClr val="183A3C"/>
+                </a:solidFill>
+                <a:latin typeface="Arial"/>
+                <a:ea typeface="Arial"/>
+                <a:cs typeface="Arial"/>
+              </a:rPr>
+              <a:t>share explicit relationships.</a:t>
             </a:r>
           </a:p>
         </p:txBody>
@@ -6235,7 +6332,7 @@
           <p:cNvPr id="4" name="">
             <a:extLst xmlns:a="http://schemas.openxmlformats.org/drawingml/2006/main">
               <a:ext uri="{FF2B5EF4-FFF2-40B4-BE49-F238E27FC236}">
-                <a16:creationId xmlns:a16="http://schemas.microsoft.com/office/drawing/2014/main" id="{D5BBBD69-4238-4B15-9212-0D9FD0F88AA8}"/>
+                <a16:creationId xmlns:a16="http://schemas.microsoft.com/office/drawing/2014/main" id="{CAD6F7D7-1A10-4F2C-9653-3CF4CF97BB2D}"/>
               </a:ext>
             </a:extLst>
           </p:cNvPr>
@@ -6246,8 +6343,8 @@
         </p:nvSpPr>
         <p:spPr>
           <a:xfrm xmlns:a="http://schemas.openxmlformats.org/drawingml/2006/main">
-            <a:off x="609600" y="3714750"/>
-            <a:ext cx="6286500" cy="619125"/>
+            <a:off x="609600" y="4000500"/>
+            <a:ext cx="5429250" cy="1476375"/>
           </a:xfrm>
           <a:prstGeom xmlns:a="http://schemas.openxmlformats.org/drawingml/2006/main" prst="rect">
             <a:avLst/>
@@ -6261,7 +6358,7 @@
           <a:bodyPr xmlns:a="http://schemas.openxmlformats.org/drawingml/2006/main" lIns="0" tIns="0" rIns="0" bIns="0"/>
           <a:lstStyle xmlns:a="http://schemas.openxmlformats.org/drawingml/2006/main">
             <a:defPPr>
-              <a:defRPr sz="2250" b="0">
+              <a:defRPr sz="2175" b="0">
                 <a:solidFill>
                   <a:srgbClr val="183A3C"/>
                 </a:solidFill>
@@ -6273,7 +6370,7 @@
           </a:lstStyle>
           <a:p xmlns:a="http://schemas.openxmlformats.org/drawingml/2006/main">
             <a:pPr>
-              <a:defRPr sz="2250" b="0">
+              <a:defRPr sz="2175" b="0">
                 <a:solidFill>
                   <a:srgbClr val="183A3C"/>
                 </a:solidFill>
@@ -6283,7 +6380,7 @@
               </a:defRPr>
             </a:pPr>
             <a:r>
-              <a:rPr sz="2250" b="0">
+              <a:rPr sz="2175" b="0">
                 <a:solidFill>
                   <a:srgbClr val="183A3C"/>
                 </a:solidFill>
@@ -6291,29 +6388,103 @@
                 <a:ea typeface="Arial"/>
                 <a:cs typeface="Arial"/>
               </a:rPr>
-              <a:t>Next: run, assess, improve, repeat</a:t>
-            </a:r>
-          </a:p>
-        </p:txBody>
-      </p:sp>
-      <p:sp>
-        <p:nvSpPr>
+              <a:t>An editor proposes changes.</a:t>
+            </a:r>
+          </a:p>
+          <a:p xmlns:a="http://schemas.openxmlformats.org/drawingml/2006/main">
+            <a:pPr>
+              <a:defRPr sz="2175" b="0">
+                <a:solidFill>
+                  <a:srgbClr val="183A3C"/>
+                </a:solidFill>
+                <a:latin typeface="Arial"/>
+                <a:ea typeface="Arial"/>
+                <a:cs typeface="Arial"/>
+              </a:defRPr>
+            </a:pPr>
+            <a:r>
+              <a:rPr sz="2175" b="0">
+                <a:solidFill>
+                  <a:srgbClr val="183A3C"/>
+                </a:solidFill>
+                <a:latin typeface="Arial"/>
+                <a:ea typeface="Arial"/>
+                <a:cs typeface="Arial"/>
+              </a:rPr>
+              <a:t>GitHub review preserves the history.</a:t>
+            </a:r>
+          </a:p>
+          <a:p xmlns:a="http://schemas.openxmlformats.org/drawingml/2006/main">
+            <a:pPr>
+              <a:defRPr sz="2175" b="0">
+                <a:solidFill>
+                  <a:srgbClr val="183A3C"/>
+                </a:solidFill>
+                <a:latin typeface="Arial"/>
+                <a:ea typeface="Arial"/>
+                <a:cs typeface="Arial"/>
+              </a:defRPr>
+            </a:pPr>
+            <a:r>
+              <a:rPr sz="2175" b="0">
+                <a:solidFill>
+                  <a:srgbClr val="183A3C"/>
+                </a:solidFill>
+                <a:latin typeface="Arial"/>
+                <a:ea typeface="Arial"/>
+                <a:cs typeface="Arial"/>
+              </a:rPr>
+              <a:t>The records feed a website and graph.</a:t>
+            </a:r>
+          </a:p>
+        </p:txBody>
+      </p:sp>
+      <p:pic>
+        <p:nvPicPr>
           <p:cNvPr id="5" name="">
             <a:extLst xmlns:a="http://schemas.openxmlformats.org/drawingml/2006/main">
               <a:ext uri="{FF2B5EF4-FFF2-40B4-BE49-F238E27FC236}">
-                <a16:creationId xmlns:a16="http://schemas.microsoft.com/office/drawing/2014/main" id="{3BEE3616-0601-4378-B60B-4C4F88155024}"/>
+                <a16:creationId xmlns:a16="http://schemas.microsoft.com/office/drawing/2014/main" id="{F74576E2-73C4-4DDE-A17C-6BF690E94EF3}"/>
               </a:ext>
             </a:extLst>
           </p:cNvPr>
-          <p:cNvSpPr>
-            <a:spLocks xmlns:a="http://schemas.openxmlformats.org/drawingml/2006/main" noGrp="1"/>
-          </p:cNvSpPr>
+          <p:cNvPicPr>
+            <a:picLocks xmlns:a="http://schemas.openxmlformats.org/drawingml/2006/main" noChangeAspect="1"/>
+          </p:cNvPicPr>
           <p:nvPr/>
-        </p:nvSpPr>
+        </p:nvPicPr>
+        <p:blipFill>
+          <a:blip xmlns:r="http://schemas.openxmlformats.org/officeDocument/2006/relationships" xmlns:a="http://schemas.openxmlformats.org/drawingml/2006/main" r:embed="R41313f9ab39d41ab"/>
+          <a:stretch xmlns:a="http://schemas.openxmlformats.org/drawingml/2006/main"/>
+        </p:blipFill>
         <p:spPr>
           <a:xfrm xmlns:a="http://schemas.openxmlformats.org/drawingml/2006/main">
-            <a:off x="609600" y="4619625"/>
-            <a:ext cx="6286500" cy="914400"/>
+            <a:off x="6766560" y="1381125"/>
+            <a:ext cx="4373880" cy="4333875"/>
+          </a:xfrm>
+          <a:prstGeom xmlns:a="http://schemas.openxmlformats.org/drawingml/2006/main" prst="rect">
+            <a:avLst/>
+          </a:prstGeom>
+        </p:spPr>
+      </p:pic>
+      <p:sp>
+        <p:nvSpPr>
+          <p:cNvPr id="6" name="">
+            <a:extLst xmlns:a="http://schemas.openxmlformats.org/drawingml/2006/main">
+              <a:ext uri="{FF2B5EF4-FFF2-40B4-BE49-F238E27FC236}">
+                <a16:creationId xmlns:a16="http://schemas.microsoft.com/office/drawing/2014/main" id="{60375754-FC7F-4292-87F9-F427806B105C}"/>
+              </a:ext>
+            </a:extLst>
+          </p:cNvPr>
+          <p:cNvSpPr>
+            <a:spLocks xmlns:a="http://schemas.openxmlformats.org/drawingml/2006/main" noGrp="1"/>
+          </p:cNvSpPr>
+          <p:nvPr/>
+        </p:nvSpPr>
+        <p:spPr>
+          <a:xfrm xmlns:a="http://schemas.openxmlformats.org/drawingml/2006/main">
+            <a:off x="609600" y="6153150"/>
+            <a:ext cx="3810000" cy="361950"/>
           </a:xfrm>
           <a:prstGeom xmlns:a="http://schemas.openxmlformats.org/drawingml/2006/main" prst="rect">
             <a:avLst/>
@@ -6327,9 +6498,9 @@
           <a:bodyPr xmlns:a="http://schemas.openxmlformats.org/drawingml/2006/main" lIns="0" tIns="0" rIns="0" bIns="0"/>
           <a:lstStyle xmlns:a="http://schemas.openxmlformats.org/drawingml/2006/main">
             <a:defPPr>
-              <a:defRPr sz="2100" b="0">
-                <a:solidFill>
-                  <a:srgbClr val="183A3C"/>
+              <a:defRPr sz="1800" b="0">
+                <a:solidFill>
+                  <a:srgbClr val="15716E"/>
                 </a:solidFill>
                 <a:latin typeface="Arial"/>
                 <a:ea typeface="Arial"/>
@@ -6339,9 +6510,9 @@
           </a:lstStyle>
           <a:p xmlns:a="http://schemas.openxmlformats.org/drawingml/2006/main">
             <a:pPr>
-              <a:defRPr sz="2100" b="0">
-                <a:solidFill>
-                  <a:srgbClr val="183A3C"/>
+              <a:defRPr sz="1800" b="0">
+                <a:solidFill>
+                  <a:srgbClr val="15716E"/>
                 </a:solidFill>
                 <a:latin typeface="Arial"/>
                 <a:ea typeface="Arial"/>
@@ -6349,243 +6520,37 @@
               </a:defRPr>
             </a:pPr>
             <a:r>
-              <a:rPr sz="2100" b="0">
-                <a:solidFill>
-                  <a:srgbClr val="183A3C"/>
-                </a:solidFill>
-                <a:latin typeface="Arial"/>
-                <a:ea typeface="Arial"/>
-                <a:cs typeface="Arial"/>
+              <a:rPr sz="1800" b="0">
+                <a:solidFill>
+                  <a:srgbClr val="15716E"/>
+                </a:solidFill>
+                <a:latin typeface="Arial"/>
+                <a:ea typeface="Arial"/>
+                <a:cs typeface="Arial"/>
+                <a:hlinkClick xmlns:r="http://schemas.openxmlformats.org/officeDocument/2006/relationships" r:id="Rd097473f827d4236"/>
               </a:rPr>
-              <a:t>Compare four assistance conditions.</a:t>
-            </a:r>
-          </a:p>
-          <a:p xmlns:a="http://schemas.openxmlformats.org/drawingml/2006/main">
-            <a:pPr>
-              <a:defRPr sz="2100" b="0">
-                <a:solidFill>
-                  <a:srgbClr val="183A3C"/>
-                </a:solidFill>
-                <a:latin typeface="Arial"/>
-                <a:ea typeface="Arial"/>
-                <a:cs typeface="Arial"/>
-              </a:defRPr>
-            </a:pPr>
-            <a:r>
-              <a:rPr sz="2100" b="0">
-                <a:solidFill>
-                  <a:srgbClr val="183A3C"/>
-                </a:solidFill>
-                <a:latin typeface="Arial"/>
-                <a:ea typeface="Arial"/>
-                <a:cs typeface="Arial"/>
-              </a:rPr>
-              <a:t>Test quality, effort and consistency.</a:t>
-            </a:r>
-          </a:p>
-        </p:txBody>
-      </p:sp>
-      <p:pic>
-        <p:nvPicPr>
-          <p:cNvPr id="6" name="">
+              <a:t>Project + source</a:t>
+            </a:r>
+          </a:p>
+        </p:txBody>
+      </p:sp>
+      <p:sp>
+        <p:nvSpPr>
+          <p:cNvPr id="7" name="">
             <a:extLst xmlns:a="http://schemas.openxmlformats.org/drawingml/2006/main">
               <a:ext uri="{FF2B5EF4-FFF2-40B4-BE49-F238E27FC236}">
-                <a16:creationId xmlns:a16="http://schemas.microsoft.com/office/drawing/2014/main" id="{E50DF319-A2A3-413C-B583-A170456781F3}"/>
+                <a16:creationId xmlns:a16="http://schemas.microsoft.com/office/drawing/2014/main" id="{8C084257-B7B9-4898-9743-58C0B2F59F60}"/>
               </a:ext>
             </a:extLst>
           </p:cNvPr>
-          <p:cNvPicPr>
-            <a:picLocks xmlns:a="http://schemas.openxmlformats.org/drawingml/2006/main" noChangeAspect="1"/>
-          </p:cNvPicPr>
+          <p:cNvSpPr>
+            <a:spLocks xmlns:a="http://schemas.openxmlformats.org/drawingml/2006/main" noGrp="1"/>
+          </p:cNvSpPr>
           <p:nvPr/>
-        </p:nvPicPr>
-        <p:blipFill>
-          <a:blip xmlns:r="http://schemas.openxmlformats.org/officeDocument/2006/relationships" xmlns:a="http://schemas.openxmlformats.org/drawingml/2006/main" r:embed="R353a67b311fd4f22"/>
-          <a:stretch xmlns:a="http://schemas.openxmlformats.org/drawingml/2006/main"/>
-        </p:blipFill>
+        </p:nvSpPr>
         <p:spPr>
           <a:xfrm xmlns:a="http://schemas.openxmlformats.org/drawingml/2006/main">
-            <a:off x="7762875" y="1524000"/>
-            <a:ext cx="3810000" cy="3810000"/>
-          </a:xfrm>
-          <a:prstGeom xmlns:a="http://schemas.openxmlformats.org/drawingml/2006/main" prst="rect">
-            <a:avLst/>
-          </a:prstGeom>
-        </p:spPr>
-      </p:pic>
-      <p:sp>
-        <p:nvSpPr>
-          <p:cNvPr id="7" name="">
-            <a:extLst xmlns:a="http://schemas.openxmlformats.org/drawingml/2006/main">
-              <a:ext uri="{FF2B5EF4-FFF2-40B4-BE49-F238E27FC236}">
-                <a16:creationId xmlns:a16="http://schemas.microsoft.com/office/drawing/2014/main" id="{6503B8DC-5F78-45EA-9161-496D3AD6F3D1}"/>
-              </a:ext>
-            </a:extLst>
-          </p:cNvPr>
-          <p:cNvSpPr>
-            <a:spLocks xmlns:a="http://schemas.openxmlformats.org/drawingml/2006/main" noGrp="1"/>
-          </p:cNvSpPr>
-          <p:nvPr/>
-        </p:nvSpPr>
-        <p:spPr>
-          <a:xfrm xmlns:a="http://schemas.openxmlformats.org/drawingml/2006/main">
-            <a:off x="7762875" y="5524500"/>
-            <a:ext cx="3810000" cy="647700"/>
-          </a:xfrm>
-          <a:prstGeom xmlns:a="http://schemas.openxmlformats.org/drawingml/2006/main" prst="rect">
-            <a:avLst/>
-          </a:prstGeom>
-          <a:noFill xmlns:a="http://schemas.openxmlformats.org/drawingml/2006/main"/>
-          <a:ln xmlns:a="http://schemas.openxmlformats.org/drawingml/2006/main" w="0">
-            <a:noFill/>
-          </a:ln>
-        </p:spPr>
-        <p:txBody>
-          <a:bodyPr xmlns:a="http://schemas.openxmlformats.org/drawingml/2006/main" lIns="0" tIns="0" rIns="0" bIns="0"/>
-          <a:lstStyle xmlns:a="http://schemas.openxmlformats.org/drawingml/2006/main">
-            <a:defPPr>
-              <a:defRPr sz="1725" b="0">
-                <a:solidFill>
-                  <a:srgbClr val="183A3C"/>
-                </a:solidFill>
-                <a:latin typeface="Arial"/>
-                <a:ea typeface="Arial"/>
-                <a:cs typeface="Arial"/>
-              </a:defRPr>
-            </a:defPPr>
-          </a:lstStyle>
-          <a:p xmlns:a="http://schemas.openxmlformats.org/drawingml/2006/main">
-            <a:pPr>
-              <a:defRPr sz="1725" b="0">
-                <a:solidFill>
-                  <a:srgbClr val="183A3C"/>
-                </a:solidFill>
-                <a:latin typeface="Arial"/>
-                <a:ea typeface="Arial"/>
-                <a:cs typeface="Arial"/>
-              </a:defRPr>
-            </a:pPr>
-            <a:r>
-              <a:rPr sz="1725" b="0">
-                <a:solidFill>
-                  <a:srgbClr val="183A3C"/>
-                </a:solidFill>
-                <a:latin typeface="Arial"/>
-                <a:ea typeface="Arial"/>
-                <a:cs typeface="Arial"/>
-              </a:rPr>
-              <a:t>Research workshop in development.</a:t>
-            </a:r>
-          </a:p>
-          <a:p xmlns:a="http://schemas.openxmlformats.org/drawingml/2006/main">
-            <a:pPr>
-              <a:defRPr sz="1725" b="0">
-                <a:solidFill>
-                  <a:srgbClr val="183A3C"/>
-                </a:solidFill>
-                <a:latin typeface="Arial"/>
-                <a:ea typeface="Arial"/>
-                <a:cs typeface="Arial"/>
-              </a:defRPr>
-            </a:pPr>
-            <a:r>
-              <a:rPr sz="1725" b="0">
-                <a:solidFill>
-                  <a:srgbClr val="183A3C"/>
-                </a:solidFill>
-                <a:latin typeface="Arial"/>
-                <a:ea typeface="Arial"/>
-                <a:cs typeface="Arial"/>
-              </a:rPr>
-              <a:t>Transfer remains to be tested.</a:t>
-            </a:r>
-          </a:p>
-        </p:txBody>
-      </p:sp>
-      <p:sp>
-        <p:nvSpPr>
-          <p:cNvPr id="8" name="">
-            <a:extLst xmlns:a="http://schemas.openxmlformats.org/drawingml/2006/main">
-              <a:ext uri="{FF2B5EF4-FFF2-40B4-BE49-F238E27FC236}">
-                <a16:creationId xmlns:a16="http://schemas.microsoft.com/office/drawing/2014/main" id="{B6E74366-4108-4625-967E-9DC574E14512}"/>
-              </a:ext>
-            </a:extLst>
-          </p:cNvPr>
-          <p:cNvSpPr>
-            <a:spLocks xmlns:a="http://schemas.openxmlformats.org/drawingml/2006/main" noGrp="1"/>
-          </p:cNvSpPr>
-          <p:nvPr/>
-        </p:nvSpPr>
-        <p:spPr>
-          <a:xfrm xmlns:a="http://schemas.openxmlformats.org/drawingml/2006/main">
-            <a:off x="609600" y="6153150"/>
-            <a:ext cx="3143250" cy="361950"/>
-          </a:xfrm>
-          <a:prstGeom xmlns:a="http://schemas.openxmlformats.org/drawingml/2006/main" prst="rect">
-            <a:avLst/>
-          </a:prstGeom>
-          <a:noFill xmlns:a="http://schemas.openxmlformats.org/drawingml/2006/main"/>
-          <a:ln xmlns:a="http://schemas.openxmlformats.org/drawingml/2006/main" w="0">
-            <a:noFill/>
-          </a:ln>
-        </p:spPr>
-        <p:txBody>
-          <a:bodyPr xmlns:a="http://schemas.openxmlformats.org/drawingml/2006/main" lIns="0" tIns="0" rIns="0" bIns="0"/>
-          <a:lstStyle xmlns:a="http://schemas.openxmlformats.org/drawingml/2006/main">
-            <a:defPPr>
-              <a:defRPr sz="1800" b="0">
-                <a:solidFill>
-                  <a:srgbClr val="15716E"/>
-                </a:solidFill>
-                <a:latin typeface="Arial"/>
-                <a:ea typeface="Arial"/>
-                <a:cs typeface="Arial"/>
-              </a:defRPr>
-            </a:defPPr>
-          </a:lstStyle>
-          <a:p xmlns:a="http://schemas.openxmlformats.org/drawingml/2006/main">
-            <a:pPr>
-              <a:defRPr sz="1800" b="0">
-                <a:solidFill>
-                  <a:srgbClr val="15716E"/>
-                </a:solidFill>
-                <a:latin typeface="Arial"/>
-                <a:ea typeface="Arial"/>
-                <a:cs typeface="Arial"/>
-              </a:defRPr>
-            </a:pPr>
-            <a:r>
-              <a:rPr sz="1800" b="0">
-                <a:solidFill>
-                  <a:srgbClr val="15716E"/>
-                </a:solidFill>
-                <a:latin typeface="Arial"/>
-                <a:ea typeface="Arial"/>
-                <a:cs typeface="Arial"/>
-                <a:hlinkClick xmlns:r="http://schemas.openxmlformats.org/officeDocument/2006/relationships" r:id="R882b8cf50e3a494a"/>
-              </a:rPr>
-              <a:t>Poster PR #35</a:t>
-            </a:r>
-          </a:p>
-        </p:txBody>
-      </p:sp>
-      <p:sp>
-        <p:nvSpPr>
-          <p:cNvPr id="9" name="">
-            <a:extLst xmlns:a="http://schemas.openxmlformats.org/drawingml/2006/main">
-              <a:ext uri="{FF2B5EF4-FFF2-40B4-BE49-F238E27FC236}">
-                <a16:creationId xmlns:a16="http://schemas.microsoft.com/office/drawing/2014/main" id="{CD5C5891-9406-4DBC-BFE1-D0959819CD09}"/>
-              </a:ext>
-            </a:extLst>
-          </p:cNvPr>
-          <p:cNvSpPr>
-            <a:spLocks xmlns:a="http://schemas.openxmlformats.org/drawingml/2006/main" noGrp="1"/>
-          </p:cNvSpPr>
-          <p:nvPr/>
-        </p:nvSpPr>
-        <p:spPr>
-          <a:xfrm xmlns:a="http://schemas.openxmlformats.org/drawingml/2006/main">
-            <a:off x="4333875" y="6153150"/>
+            <a:off x="4762500" y="6153150"/>
             <a:ext cx="3238500" cy="361950"/>
           </a:xfrm>
           <a:prstGeom xmlns:a="http://schemas.openxmlformats.org/drawingml/2006/main" prst="rect">
@@ -6629,19 +6594,19 @@
                 <a:latin typeface="Arial"/>
                 <a:ea typeface="Arial"/>
                 <a:cs typeface="Arial"/>
-                <a:hlinkClick xmlns:r="http://schemas.openxmlformats.org/officeDocument/2006/relationships" r:id="Rec16e4e201994115"/>
+                <a:hlinkClick xmlns:r="http://schemas.openxmlformats.org/officeDocument/2006/relationships" r:id="R6fcdf2f811404a7e"/>
               </a:rPr>
-              <a:t>Study on Zenodo</a:t>
-            </a:r>
-          </a:p>
-        </p:txBody>
-      </p:sp>
-      <p:sp>
-        <p:nvSpPr>
-          <p:cNvPr id="10" name="">
+              <a:t>Explore the graph</a:t>
+            </a:r>
+          </a:p>
+        </p:txBody>
+      </p:sp>
+      <p:sp>
+        <p:nvSpPr>
+          <p:cNvPr id="8" name="">
             <a:extLst xmlns:a="http://schemas.openxmlformats.org/drawingml/2006/main">
               <a:ext uri="{FF2B5EF4-FFF2-40B4-BE49-F238E27FC236}">
-                <a16:creationId xmlns:a16="http://schemas.microsoft.com/office/drawing/2014/main" id="{580B5769-1EE1-4048-AA14-FEDB446B9DDA}"/>
+                <a16:creationId xmlns:a16="http://schemas.microsoft.com/office/drawing/2014/main" id="{169B7F75-3A69-444C-ADF4-48DE827F9EEA}"/>
               </a:ext>
             </a:extLst>
           </p:cNvPr>
@@ -6652,8 +6617,8 @@
         </p:nvSpPr>
         <p:spPr>
           <a:xfrm xmlns:a="http://schemas.openxmlformats.org/drawingml/2006/main">
-            <a:off x="8239125" y="6153150"/>
-            <a:ext cx="3333750" cy="361950"/>
+            <a:off x="9525000" y="6153150"/>
+            <a:ext cx="2000250" cy="361950"/>
           </a:xfrm>
           <a:prstGeom xmlns:a="http://schemas.openxmlformats.org/drawingml/2006/main" prst="rect">
             <a:avLst/>
@@ -6696,9 +6661,9 @@
                 <a:latin typeface="Arial"/>
                 <a:ea typeface="Arial"/>
                 <a:cs typeface="Arial"/>
-                <a:hlinkClick xmlns:r="http://schemas.openxmlformats.org/officeDocument/2006/relationships" r:id="Re319bd24410245e6"/>
+                <a:hlinkClick xmlns:r="http://schemas.openxmlformats.org/officeDocument/2006/relationships" r:id="Ref2c8884ab0e482e"/>
               </a:rPr>
-              <a:t>Next repository</a:t>
+              <a:t>Poster</a:t>
             </a:r>
           </a:p>
         </p:txBody>
@@ -6706,7 +6671,7 @@
     </p:spTree>
     <p:extLst>
       <p:ext uri="{BB962C8B-B14F-4D97-AF65-F5344CB8AC3E}">
-        <p14:creationId xmlns:p14="http://schemas.microsoft.com/office/powerpoint/2010/main" val="349039849"/>
+        <p14:creationId xmlns:p14="http://schemas.microsoft.com/office/powerpoint/2010/main" val="577889819"/>
       </p:ext>
     </p:extLst>
   </p:cSld>
@@ -6734,10 +6699,733 @@
       </p:grpSpPr>
       <p:sp>
         <p:nvSpPr>
+          <p:cNvPr id="11" name="">
+            <a:extLst xmlns:a="http://schemas.openxmlformats.org/drawingml/2006/main">
+              <a:ext uri="{FF2B5EF4-FFF2-40B4-BE49-F238E27FC236}">
+                <a16:creationId xmlns:a16="http://schemas.microsoft.com/office/drawing/2014/main" id="{5ADE5292-5660-4BFF-BDFB-B2AA55B76B62}"/>
+              </a:ext>
+            </a:extLst>
+          </p:cNvPr>
+          <p:cNvSpPr>
+            <a:spLocks xmlns:a="http://schemas.openxmlformats.org/drawingml/2006/main" noGrp="1"/>
+          </p:cNvSpPr>
+          <p:nvPr/>
+        </p:nvSpPr>
+        <p:spPr>
+          <a:xfrm xmlns:a="http://schemas.openxmlformats.org/drawingml/2006/main">
+            <a:off x="609600" y="523875"/>
+            <a:ext cx="10972800" cy="809625"/>
+          </a:xfrm>
+          <a:prstGeom xmlns:a="http://schemas.openxmlformats.org/drawingml/2006/main" prst="rect">
+            <a:avLst/>
+          </a:prstGeom>
+          <a:noFill xmlns:a="http://schemas.openxmlformats.org/drawingml/2006/main"/>
+          <a:ln xmlns:a="http://schemas.openxmlformats.org/drawingml/2006/main" w="0">
+            <a:noFill/>
+          </a:ln>
+        </p:spPr>
+        <p:txBody>
+          <a:bodyPr xmlns:a="http://schemas.openxmlformats.org/drawingml/2006/main" lIns="0" tIns="0" rIns="0" bIns="0"/>
+          <a:lstStyle xmlns:a="http://schemas.openxmlformats.org/drawingml/2006/main">
+            <a:defPPr>
+              <a:defRPr sz="3600" b="1">
+                <a:solidFill>
+                  <a:srgbClr val="183A3C"/>
+                </a:solidFill>
+                <a:latin typeface="Arial"/>
+                <a:ea typeface="Arial"/>
+                <a:cs typeface="Arial"/>
+              </a:defRPr>
+            </a:defPPr>
+          </a:lstStyle>
+          <a:p xmlns:a="http://schemas.openxmlformats.org/drawingml/2006/main">
+            <a:pPr>
+              <a:defRPr sz="3600" b="1">
+                <a:solidFill>
+                  <a:srgbClr val="183A3C"/>
+                </a:solidFill>
+                <a:latin typeface="Arial"/>
+                <a:ea typeface="Arial"/>
+                <a:cs typeface="Arial"/>
+              </a:defRPr>
+            </a:pPr>
+            <a:r>
+              <a:rPr sz="3600" b="1">
+                <a:solidFill>
+                  <a:srgbClr val="183A3C"/>
+                </a:solidFill>
+                <a:latin typeface="Arial"/>
+                <a:ea typeface="Arial"/>
+                <a:cs typeface="Arial"/>
+              </a:rPr>
+              <a:t>STAMPED in Practice</a:t>
+            </a:r>
+          </a:p>
+        </p:txBody>
+      </p:sp>
+      <p:sp>
+        <p:nvSpPr>
+          <p:cNvPr id="2" name="">
+            <a:extLst xmlns:a="http://schemas.openxmlformats.org/drawingml/2006/main">
+              <a:ext uri="{FF2B5EF4-FFF2-40B4-BE49-F238E27FC236}">
+                <a16:creationId xmlns:a16="http://schemas.microsoft.com/office/drawing/2014/main" id="{D1A6864D-AEB7-4A81-8B0B-6F7F13381A5E}"/>
+              </a:ext>
+            </a:extLst>
+          </p:cNvPr>
+          <p:cNvSpPr>
+            <a:spLocks xmlns:a="http://schemas.openxmlformats.org/drawingml/2006/main" noGrp="1"/>
+          </p:cNvSpPr>
+          <p:nvPr/>
+        </p:nvSpPr>
+        <p:spPr>
+          <a:xfrm xmlns:a="http://schemas.openxmlformats.org/drawingml/2006/main">
+            <a:off x="609600" y="1571625"/>
+            <a:ext cx="6619875" cy="1028700"/>
+          </a:xfrm>
+          <a:prstGeom xmlns:a="http://schemas.openxmlformats.org/drawingml/2006/main" prst="rect">
+            <a:avLst/>
+          </a:prstGeom>
+          <a:noFill xmlns:a="http://schemas.openxmlformats.org/drawingml/2006/main"/>
+          <a:ln xmlns:a="http://schemas.openxmlformats.org/drawingml/2006/main" w="0">
+            <a:noFill/>
+          </a:ln>
+        </p:spPr>
+        <p:txBody>
+          <a:bodyPr xmlns:a="http://schemas.openxmlformats.org/drawingml/2006/main" lIns="0" tIns="0" rIns="0" bIns="0"/>
+          <a:lstStyle xmlns:a="http://schemas.openxmlformats.org/drawingml/2006/main">
+            <a:defPPr>
+              <a:defRPr sz="2775" b="1">
+                <a:solidFill>
+                  <a:srgbClr val="183A3C"/>
+                </a:solidFill>
+                <a:latin typeface="Arial"/>
+                <a:ea typeface="Arial"/>
+                <a:cs typeface="Arial"/>
+              </a:defRPr>
+            </a:defPPr>
+          </a:lstStyle>
+          <a:p xmlns:a="http://schemas.openxmlformats.org/drawingml/2006/main">
+            <a:pPr>
+              <a:defRPr sz="2775" b="1">
+                <a:solidFill>
+                  <a:srgbClr val="183A3C"/>
+                </a:solidFill>
+                <a:latin typeface="Arial"/>
+                <a:ea typeface="Arial"/>
+                <a:cs typeface="Arial"/>
+              </a:defRPr>
+            </a:pPr>
+            <a:r>
+              <a:rPr sz="2775" b="1">
+                <a:solidFill>
+                  <a:srgbClr val="183A3C"/>
+                </a:solidFill>
+                <a:latin typeface="Arial"/>
+                <a:ea typeface="Arial"/>
+                <a:cs typeface="Arial"/>
+              </a:rPr>
+              <a:t>Skills that improve through</a:t>
+            </a:r>
+          </a:p>
+          <a:p xmlns:a="http://schemas.openxmlformats.org/drawingml/2006/main">
+            <a:pPr>
+              <a:defRPr sz="2775" b="1">
+                <a:solidFill>
+                  <a:srgbClr val="183A3C"/>
+                </a:solidFill>
+                <a:latin typeface="Arial"/>
+                <a:ea typeface="Arial"/>
+                <a:cs typeface="Arial"/>
+              </a:defRPr>
+            </a:pPr>
+            <a:r>
+              <a:rPr sz="2775" b="1">
+                <a:solidFill>
+                  <a:srgbClr val="183A3C"/>
+                </a:solidFill>
+                <a:latin typeface="Arial"/>
+                <a:ea typeface="Arial"/>
+                <a:cs typeface="Arial"/>
+              </a:rPr>
+              <a:t>scientific work</a:t>
+            </a:r>
+          </a:p>
+        </p:txBody>
+      </p:sp>
+      <p:sp>
+        <p:nvSpPr>
+          <p:cNvPr id="3" name="">
+            <a:extLst xmlns:a="http://schemas.openxmlformats.org/drawingml/2006/main">
+              <a:ext uri="{FF2B5EF4-FFF2-40B4-BE49-F238E27FC236}">
+                <a16:creationId xmlns:a16="http://schemas.microsoft.com/office/drawing/2014/main" id="{D118B151-E506-46F5-9BC5-ADD3AAFD50A0}"/>
+              </a:ext>
+            </a:extLst>
+          </p:cNvPr>
+          <p:cNvSpPr>
+            <a:spLocks xmlns:a="http://schemas.openxmlformats.org/drawingml/2006/main" noGrp="1"/>
+          </p:cNvSpPr>
+          <p:nvPr/>
+        </p:nvSpPr>
+        <p:spPr>
+          <a:xfrm xmlns:a="http://schemas.openxmlformats.org/drawingml/2006/main">
+            <a:off x="609600" y="2952750"/>
+            <a:ext cx="6381750" cy="542925"/>
+          </a:xfrm>
+          <a:prstGeom xmlns:a="http://schemas.openxmlformats.org/drawingml/2006/main" prst="rect">
+            <a:avLst/>
+          </a:prstGeom>
+          <a:noFill xmlns:a="http://schemas.openxmlformats.org/drawingml/2006/main"/>
+          <a:ln xmlns:a="http://schemas.openxmlformats.org/drawingml/2006/main" w="0">
+            <a:noFill/>
+          </a:ln>
+        </p:spPr>
+        <p:txBody>
+          <a:bodyPr xmlns:a="http://schemas.openxmlformats.org/drawingml/2006/main" lIns="0" tIns="0" rIns="0" bIns="0"/>
+          <a:lstStyle xmlns:a="http://schemas.openxmlformats.org/drawingml/2006/main">
+            <a:defPPr>
+              <a:defRPr sz="2400" b="1">
+                <a:solidFill>
+                  <a:srgbClr val="15716E"/>
+                </a:solidFill>
+                <a:latin typeface="Arial"/>
+                <a:ea typeface="Arial"/>
+                <a:cs typeface="Arial"/>
+              </a:defRPr>
+            </a:defPPr>
+          </a:lstStyle>
+          <a:p xmlns:a="http://schemas.openxmlformats.org/drawingml/2006/main">
+            <a:pPr>
+              <a:defRPr sz="2400" b="1">
+                <a:solidFill>
+                  <a:srgbClr val="15716E"/>
+                </a:solidFill>
+                <a:latin typeface="Arial"/>
+                <a:ea typeface="Arial"/>
+                <a:cs typeface="Arial"/>
+              </a:defRPr>
+            </a:pPr>
+            <a:r>
+              <a:rPr sz="2400" b="1">
+                <a:solidFill>
+                  <a:srgbClr val="15716E"/>
+                </a:solidFill>
+                <a:latin typeface="Arial"/>
+                <a:ea typeface="Arial"/>
+                <a:cs typeface="Arial"/>
+              </a:rPr>
+              <a:t>Study record on Zenodo</a:t>
+            </a:r>
+          </a:p>
+        </p:txBody>
+      </p:sp>
+      <p:sp>
+        <p:nvSpPr>
+          <p:cNvPr id="4" name="">
+            <a:extLst xmlns:a="http://schemas.openxmlformats.org/drawingml/2006/main">
+              <a:ext uri="{FF2B5EF4-FFF2-40B4-BE49-F238E27FC236}">
+                <a16:creationId xmlns:a16="http://schemas.microsoft.com/office/drawing/2014/main" id="{34416991-E8DB-4E73-A490-ECCC18477CFF}"/>
+              </a:ext>
+            </a:extLst>
+          </p:cNvPr>
+          <p:cNvSpPr>
+            <a:spLocks xmlns:a="http://schemas.openxmlformats.org/drawingml/2006/main" noGrp="1"/>
+          </p:cNvSpPr>
+          <p:nvPr/>
+        </p:nvSpPr>
+        <p:spPr>
+          <a:xfrm xmlns:a="http://schemas.openxmlformats.org/drawingml/2006/main">
+            <a:off x="609600" y="3714750"/>
+            <a:ext cx="6286500" cy="619125"/>
+          </a:xfrm>
+          <a:prstGeom xmlns:a="http://schemas.openxmlformats.org/drawingml/2006/main" prst="rect">
+            <a:avLst/>
+          </a:prstGeom>
+          <a:noFill xmlns:a="http://schemas.openxmlformats.org/drawingml/2006/main"/>
+          <a:ln xmlns:a="http://schemas.openxmlformats.org/drawingml/2006/main" w="0">
+            <a:noFill/>
+          </a:ln>
+        </p:spPr>
+        <p:txBody>
+          <a:bodyPr xmlns:a="http://schemas.openxmlformats.org/drawingml/2006/main" lIns="0" tIns="0" rIns="0" bIns="0"/>
+          <a:lstStyle xmlns:a="http://schemas.openxmlformats.org/drawingml/2006/main">
+            <a:defPPr>
+              <a:defRPr sz="2250" b="0">
+                <a:solidFill>
+                  <a:srgbClr val="183A3C"/>
+                </a:solidFill>
+                <a:latin typeface="Arial"/>
+                <a:ea typeface="Arial"/>
+                <a:cs typeface="Arial"/>
+              </a:defRPr>
+            </a:defPPr>
+          </a:lstStyle>
+          <a:p xmlns:a="http://schemas.openxmlformats.org/drawingml/2006/main">
+            <a:pPr>
+              <a:defRPr sz="2250" b="0">
+                <a:solidFill>
+                  <a:srgbClr val="183A3C"/>
+                </a:solidFill>
+                <a:latin typeface="Arial"/>
+                <a:ea typeface="Arial"/>
+                <a:cs typeface="Arial"/>
+              </a:defRPr>
+            </a:pPr>
+            <a:r>
+              <a:rPr sz="2250" b="0">
+                <a:solidFill>
+                  <a:srgbClr val="183A3C"/>
+                </a:solidFill>
+                <a:latin typeface="Arial"/>
+                <a:ea typeface="Arial"/>
+                <a:cs typeface="Arial"/>
+              </a:rPr>
+              <a:t>Next: run, assess, improve, repeat</a:t>
+            </a:r>
+          </a:p>
+        </p:txBody>
+      </p:sp>
+      <p:sp>
+        <p:nvSpPr>
+          <p:cNvPr id="5" name="">
+            <a:extLst xmlns:a="http://schemas.openxmlformats.org/drawingml/2006/main">
+              <a:ext uri="{FF2B5EF4-FFF2-40B4-BE49-F238E27FC236}">
+                <a16:creationId xmlns:a16="http://schemas.microsoft.com/office/drawing/2014/main" id="{27C102CB-8DC5-4F2D-88EF-B4BE04DC38E9}"/>
+              </a:ext>
+            </a:extLst>
+          </p:cNvPr>
+          <p:cNvSpPr>
+            <a:spLocks xmlns:a="http://schemas.openxmlformats.org/drawingml/2006/main" noGrp="1"/>
+          </p:cNvSpPr>
+          <p:nvPr/>
+        </p:nvSpPr>
+        <p:spPr>
+          <a:xfrm xmlns:a="http://schemas.openxmlformats.org/drawingml/2006/main">
+            <a:off x="609600" y="4619625"/>
+            <a:ext cx="6286500" cy="914400"/>
+          </a:xfrm>
+          <a:prstGeom xmlns:a="http://schemas.openxmlformats.org/drawingml/2006/main" prst="rect">
+            <a:avLst/>
+          </a:prstGeom>
+          <a:noFill xmlns:a="http://schemas.openxmlformats.org/drawingml/2006/main"/>
+          <a:ln xmlns:a="http://schemas.openxmlformats.org/drawingml/2006/main" w="0">
+            <a:noFill/>
+          </a:ln>
+        </p:spPr>
+        <p:txBody>
+          <a:bodyPr xmlns:a="http://schemas.openxmlformats.org/drawingml/2006/main" lIns="0" tIns="0" rIns="0" bIns="0"/>
+          <a:lstStyle xmlns:a="http://schemas.openxmlformats.org/drawingml/2006/main">
+            <a:defPPr>
+              <a:defRPr sz="2100" b="0">
+                <a:solidFill>
+                  <a:srgbClr val="183A3C"/>
+                </a:solidFill>
+                <a:latin typeface="Arial"/>
+                <a:ea typeface="Arial"/>
+                <a:cs typeface="Arial"/>
+              </a:defRPr>
+            </a:defPPr>
+          </a:lstStyle>
+          <a:p xmlns:a="http://schemas.openxmlformats.org/drawingml/2006/main">
+            <a:pPr>
+              <a:defRPr sz="2100" b="0">
+                <a:solidFill>
+                  <a:srgbClr val="183A3C"/>
+                </a:solidFill>
+                <a:latin typeface="Arial"/>
+                <a:ea typeface="Arial"/>
+                <a:cs typeface="Arial"/>
+              </a:defRPr>
+            </a:pPr>
+            <a:r>
+              <a:rPr sz="2100" b="0">
+                <a:solidFill>
+                  <a:srgbClr val="183A3C"/>
+                </a:solidFill>
+                <a:latin typeface="Arial"/>
+                <a:ea typeface="Arial"/>
+                <a:cs typeface="Arial"/>
+              </a:rPr>
+              <a:t>Compare four assistance conditions.</a:t>
+            </a:r>
+          </a:p>
+          <a:p xmlns:a="http://schemas.openxmlformats.org/drawingml/2006/main">
+            <a:pPr>
+              <a:defRPr sz="2100" b="0">
+                <a:solidFill>
+                  <a:srgbClr val="183A3C"/>
+                </a:solidFill>
+                <a:latin typeface="Arial"/>
+                <a:ea typeface="Arial"/>
+                <a:cs typeface="Arial"/>
+              </a:defRPr>
+            </a:pPr>
+            <a:r>
+              <a:rPr sz="2100" b="0">
+                <a:solidFill>
+                  <a:srgbClr val="183A3C"/>
+                </a:solidFill>
+                <a:latin typeface="Arial"/>
+                <a:ea typeface="Arial"/>
+                <a:cs typeface="Arial"/>
+              </a:rPr>
+              <a:t>Test quality, effort and consistency.</a:t>
+            </a:r>
+          </a:p>
+        </p:txBody>
+      </p:sp>
+      <p:pic>
+        <p:nvPicPr>
           <p:cNvPr id="6" name="">
             <a:extLst xmlns:a="http://schemas.openxmlformats.org/drawingml/2006/main">
               <a:ext uri="{FF2B5EF4-FFF2-40B4-BE49-F238E27FC236}">
-                <a16:creationId xmlns:a16="http://schemas.microsoft.com/office/drawing/2014/main" id="{8F7E996F-F3D6-497E-B045-EC1D22B0AE48}"/>
+                <a16:creationId xmlns:a16="http://schemas.microsoft.com/office/drawing/2014/main" id="{8B3219CA-136D-4A74-9A73-06F50E9ED5C1}"/>
+              </a:ext>
+            </a:extLst>
+          </p:cNvPr>
+          <p:cNvPicPr>
+            <a:picLocks xmlns:a="http://schemas.openxmlformats.org/drawingml/2006/main" noChangeAspect="1"/>
+          </p:cNvPicPr>
+          <p:nvPr/>
+        </p:nvPicPr>
+        <p:blipFill>
+          <a:blip xmlns:r="http://schemas.openxmlformats.org/officeDocument/2006/relationships" xmlns:a="http://schemas.openxmlformats.org/drawingml/2006/main" r:embed="R60a6fff882714008"/>
+          <a:stretch xmlns:a="http://schemas.openxmlformats.org/drawingml/2006/main"/>
+        </p:blipFill>
+        <p:spPr>
+          <a:xfrm xmlns:a="http://schemas.openxmlformats.org/drawingml/2006/main">
+            <a:off x="7762875" y="1524000"/>
+            <a:ext cx="3810000" cy="3810000"/>
+          </a:xfrm>
+          <a:prstGeom xmlns:a="http://schemas.openxmlformats.org/drawingml/2006/main" prst="rect">
+            <a:avLst/>
+          </a:prstGeom>
+        </p:spPr>
+      </p:pic>
+      <p:sp>
+        <p:nvSpPr>
+          <p:cNvPr id="7" name="">
+            <a:extLst xmlns:a="http://schemas.openxmlformats.org/drawingml/2006/main">
+              <a:ext uri="{FF2B5EF4-FFF2-40B4-BE49-F238E27FC236}">
+                <a16:creationId xmlns:a16="http://schemas.microsoft.com/office/drawing/2014/main" id="{B55D9AAF-038A-4196-AED7-619BF99CAB92}"/>
+              </a:ext>
+            </a:extLst>
+          </p:cNvPr>
+          <p:cNvSpPr>
+            <a:spLocks xmlns:a="http://schemas.openxmlformats.org/drawingml/2006/main" noGrp="1"/>
+          </p:cNvSpPr>
+          <p:nvPr/>
+        </p:nvSpPr>
+        <p:spPr>
+          <a:xfrm xmlns:a="http://schemas.openxmlformats.org/drawingml/2006/main">
+            <a:off x="7762875" y="5524500"/>
+            <a:ext cx="3810000" cy="647700"/>
+          </a:xfrm>
+          <a:prstGeom xmlns:a="http://schemas.openxmlformats.org/drawingml/2006/main" prst="rect">
+            <a:avLst/>
+          </a:prstGeom>
+          <a:noFill xmlns:a="http://schemas.openxmlformats.org/drawingml/2006/main"/>
+          <a:ln xmlns:a="http://schemas.openxmlformats.org/drawingml/2006/main" w="0">
+            <a:noFill/>
+          </a:ln>
+        </p:spPr>
+        <p:txBody>
+          <a:bodyPr xmlns:a="http://schemas.openxmlformats.org/drawingml/2006/main" lIns="0" tIns="0" rIns="0" bIns="0"/>
+          <a:lstStyle xmlns:a="http://schemas.openxmlformats.org/drawingml/2006/main">
+            <a:defPPr>
+              <a:defRPr sz="1725" b="0">
+                <a:solidFill>
+                  <a:srgbClr val="183A3C"/>
+                </a:solidFill>
+                <a:latin typeface="Arial"/>
+                <a:ea typeface="Arial"/>
+                <a:cs typeface="Arial"/>
+              </a:defRPr>
+            </a:defPPr>
+          </a:lstStyle>
+          <a:p xmlns:a="http://schemas.openxmlformats.org/drawingml/2006/main">
+            <a:pPr>
+              <a:defRPr sz="1725" b="0">
+                <a:solidFill>
+                  <a:srgbClr val="183A3C"/>
+                </a:solidFill>
+                <a:latin typeface="Arial"/>
+                <a:ea typeface="Arial"/>
+                <a:cs typeface="Arial"/>
+              </a:defRPr>
+            </a:pPr>
+            <a:r>
+              <a:rPr sz="1725" b="0">
+                <a:solidFill>
+                  <a:srgbClr val="183A3C"/>
+                </a:solidFill>
+                <a:latin typeface="Arial"/>
+                <a:ea typeface="Arial"/>
+                <a:cs typeface="Arial"/>
+              </a:rPr>
+              <a:t>Research workshop in development.</a:t>
+            </a:r>
+          </a:p>
+          <a:p xmlns:a="http://schemas.openxmlformats.org/drawingml/2006/main">
+            <a:pPr>
+              <a:defRPr sz="1725" b="0">
+                <a:solidFill>
+                  <a:srgbClr val="183A3C"/>
+                </a:solidFill>
+                <a:latin typeface="Arial"/>
+                <a:ea typeface="Arial"/>
+                <a:cs typeface="Arial"/>
+              </a:defRPr>
+            </a:pPr>
+            <a:r>
+              <a:rPr sz="1725" b="0">
+                <a:solidFill>
+                  <a:srgbClr val="183A3C"/>
+                </a:solidFill>
+                <a:latin typeface="Arial"/>
+                <a:ea typeface="Arial"/>
+                <a:cs typeface="Arial"/>
+              </a:rPr>
+              <a:t>Transfer remains to be tested.</a:t>
+            </a:r>
+          </a:p>
+        </p:txBody>
+      </p:sp>
+      <p:sp>
+        <p:nvSpPr>
+          <p:cNvPr id="8" name="">
+            <a:extLst xmlns:a="http://schemas.openxmlformats.org/drawingml/2006/main">
+              <a:ext uri="{FF2B5EF4-FFF2-40B4-BE49-F238E27FC236}">
+                <a16:creationId xmlns:a16="http://schemas.microsoft.com/office/drawing/2014/main" id="{59B96A0D-CCEF-4C01-AB46-62D9F8B23B64}"/>
+              </a:ext>
+            </a:extLst>
+          </p:cNvPr>
+          <p:cNvSpPr>
+            <a:spLocks xmlns:a="http://schemas.openxmlformats.org/drawingml/2006/main" noGrp="1"/>
+          </p:cNvSpPr>
+          <p:nvPr/>
+        </p:nvSpPr>
+        <p:spPr>
+          <a:xfrm xmlns:a="http://schemas.openxmlformats.org/drawingml/2006/main">
+            <a:off x="609600" y="6153150"/>
+            <a:ext cx="3143250" cy="361950"/>
+          </a:xfrm>
+          <a:prstGeom xmlns:a="http://schemas.openxmlformats.org/drawingml/2006/main" prst="rect">
+            <a:avLst/>
+          </a:prstGeom>
+          <a:noFill xmlns:a="http://schemas.openxmlformats.org/drawingml/2006/main"/>
+          <a:ln xmlns:a="http://schemas.openxmlformats.org/drawingml/2006/main" w="0">
+            <a:noFill/>
+          </a:ln>
+        </p:spPr>
+        <p:txBody>
+          <a:bodyPr xmlns:a="http://schemas.openxmlformats.org/drawingml/2006/main" lIns="0" tIns="0" rIns="0" bIns="0"/>
+          <a:lstStyle xmlns:a="http://schemas.openxmlformats.org/drawingml/2006/main">
+            <a:defPPr>
+              <a:defRPr sz="1800" b="0">
+                <a:solidFill>
+                  <a:srgbClr val="15716E"/>
+                </a:solidFill>
+                <a:latin typeface="Arial"/>
+                <a:ea typeface="Arial"/>
+                <a:cs typeface="Arial"/>
+              </a:defRPr>
+            </a:defPPr>
+          </a:lstStyle>
+          <a:p xmlns:a="http://schemas.openxmlformats.org/drawingml/2006/main">
+            <a:pPr>
+              <a:defRPr sz="1800" b="0">
+                <a:solidFill>
+                  <a:srgbClr val="15716E"/>
+                </a:solidFill>
+                <a:latin typeface="Arial"/>
+                <a:ea typeface="Arial"/>
+                <a:cs typeface="Arial"/>
+              </a:defRPr>
+            </a:pPr>
+            <a:r>
+              <a:rPr sz="1800" b="0">
+                <a:solidFill>
+                  <a:srgbClr val="15716E"/>
+                </a:solidFill>
+                <a:latin typeface="Arial"/>
+                <a:ea typeface="Arial"/>
+                <a:cs typeface="Arial"/>
+                <a:hlinkClick xmlns:r="http://schemas.openxmlformats.org/officeDocument/2006/relationships" r:id="R9a82bb5a2ba2418e"/>
+              </a:rPr>
+              <a:t>Poster PR #35</a:t>
+            </a:r>
+          </a:p>
+        </p:txBody>
+      </p:sp>
+      <p:sp>
+        <p:nvSpPr>
+          <p:cNvPr id="9" name="">
+            <a:extLst xmlns:a="http://schemas.openxmlformats.org/drawingml/2006/main">
+              <a:ext uri="{FF2B5EF4-FFF2-40B4-BE49-F238E27FC236}">
+                <a16:creationId xmlns:a16="http://schemas.microsoft.com/office/drawing/2014/main" id="{E9899F58-74AB-43F5-A135-79F86F1B3C01}"/>
+              </a:ext>
+            </a:extLst>
+          </p:cNvPr>
+          <p:cNvSpPr>
+            <a:spLocks xmlns:a="http://schemas.openxmlformats.org/drawingml/2006/main" noGrp="1"/>
+          </p:cNvSpPr>
+          <p:nvPr/>
+        </p:nvSpPr>
+        <p:spPr>
+          <a:xfrm xmlns:a="http://schemas.openxmlformats.org/drawingml/2006/main">
+            <a:off x="4333875" y="6153150"/>
+            <a:ext cx="3238500" cy="361950"/>
+          </a:xfrm>
+          <a:prstGeom xmlns:a="http://schemas.openxmlformats.org/drawingml/2006/main" prst="rect">
+            <a:avLst/>
+          </a:prstGeom>
+          <a:noFill xmlns:a="http://schemas.openxmlformats.org/drawingml/2006/main"/>
+          <a:ln xmlns:a="http://schemas.openxmlformats.org/drawingml/2006/main" w="0">
+            <a:noFill/>
+          </a:ln>
+        </p:spPr>
+        <p:txBody>
+          <a:bodyPr xmlns:a="http://schemas.openxmlformats.org/drawingml/2006/main" lIns="0" tIns="0" rIns="0" bIns="0"/>
+          <a:lstStyle xmlns:a="http://schemas.openxmlformats.org/drawingml/2006/main">
+            <a:defPPr>
+              <a:defRPr sz="1800" b="0">
+                <a:solidFill>
+                  <a:srgbClr val="15716E"/>
+                </a:solidFill>
+                <a:latin typeface="Arial"/>
+                <a:ea typeface="Arial"/>
+                <a:cs typeface="Arial"/>
+              </a:defRPr>
+            </a:defPPr>
+          </a:lstStyle>
+          <a:p xmlns:a="http://schemas.openxmlformats.org/drawingml/2006/main">
+            <a:pPr>
+              <a:defRPr sz="1800" b="0">
+                <a:solidFill>
+                  <a:srgbClr val="15716E"/>
+                </a:solidFill>
+                <a:latin typeface="Arial"/>
+                <a:ea typeface="Arial"/>
+                <a:cs typeface="Arial"/>
+              </a:defRPr>
+            </a:pPr>
+            <a:r>
+              <a:rPr sz="1800" b="0">
+                <a:solidFill>
+                  <a:srgbClr val="15716E"/>
+                </a:solidFill>
+                <a:latin typeface="Arial"/>
+                <a:ea typeface="Arial"/>
+                <a:cs typeface="Arial"/>
+                <a:hlinkClick xmlns:r="http://schemas.openxmlformats.org/officeDocument/2006/relationships" r:id="R8864af59af4a456c"/>
+              </a:rPr>
+              <a:t>Study on Zenodo</a:t>
+            </a:r>
+          </a:p>
+        </p:txBody>
+      </p:sp>
+      <p:sp>
+        <p:nvSpPr>
+          <p:cNvPr id="10" name="">
+            <a:extLst xmlns:a="http://schemas.openxmlformats.org/drawingml/2006/main">
+              <a:ext uri="{FF2B5EF4-FFF2-40B4-BE49-F238E27FC236}">
+                <a16:creationId xmlns:a16="http://schemas.microsoft.com/office/drawing/2014/main" id="{4665971C-A222-4E25-89C9-64D9434EAC66}"/>
+              </a:ext>
+            </a:extLst>
+          </p:cNvPr>
+          <p:cNvSpPr>
+            <a:spLocks xmlns:a="http://schemas.openxmlformats.org/drawingml/2006/main" noGrp="1"/>
+          </p:cNvSpPr>
+          <p:nvPr/>
+        </p:nvSpPr>
+        <p:spPr>
+          <a:xfrm xmlns:a="http://schemas.openxmlformats.org/drawingml/2006/main">
+            <a:off x="8239125" y="6153150"/>
+            <a:ext cx="3333750" cy="361950"/>
+          </a:xfrm>
+          <a:prstGeom xmlns:a="http://schemas.openxmlformats.org/drawingml/2006/main" prst="rect">
+            <a:avLst/>
+          </a:prstGeom>
+          <a:noFill xmlns:a="http://schemas.openxmlformats.org/drawingml/2006/main"/>
+          <a:ln xmlns:a="http://schemas.openxmlformats.org/drawingml/2006/main" w="0">
+            <a:noFill/>
+          </a:ln>
+        </p:spPr>
+        <p:txBody>
+          <a:bodyPr xmlns:a="http://schemas.openxmlformats.org/drawingml/2006/main" lIns="0" tIns="0" rIns="0" bIns="0"/>
+          <a:lstStyle xmlns:a="http://schemas.openxmlformats.org/drawingml/2006/main">
+            <a:defPPr>
+              <a:defRPr sz="1800" b="0">
+                <a:solidFill>
+                  <a:srgbClr val="15716E"/>
+                </a:solidFill>
+                <a:latin typeface="Arial"/>
+                <a:ea typeface="Arial"/>
+                <a:cs typeface="Arial"/>
+              </a:defRPr>
+            </a:defPPr>
+          </a:lstStyle>
+          <a:p xmlns:a="http://schemas.openxmlformats.org/drawingml/2006/main">
+            <a:pPr>
+              <a:defRPr sz="1800" b="0">
+                <a:solidFill>
+                  <a:srgbClr val="15716E"/>
+                </a:solidFill>
+                <a:latin typeface="Arial"/>
+                <a:ea typeface="Arial"/>
+                <a:cs typeface="Arial"/>
+              </a:defRPr>
+            </a:pPr>
+            <a:r>
+              <a:rPr sz="1800" b="0">
+                <a:solidFill>
+                  <a:srgbClr val="15716E"/>
+                </a:solidFill>
+                <a:latin typeface="Arial"/>
+                <a:ea typeface="Arial"/>
+                <a:cs typeface="Arial"/>
+                <a:hlinkClick xmlns:r="http://schemas.openxmlformats.org/officeDocument/2006/relationships" r:id="R4eea099f69ed4920"/>
+              </a:rPr>
+              <a:t>Next repository</a:t>
+            </a:r>
+          </a:p>
+        </p:txBody>
+      </p:sp>
+    </p:spTree>
+    <p:extLst>
+      <p:ext uri="{BB962C8B-B14F-4D97-AF65-F5344CB8AC3E}">
+        <p14:creationId xmlns:p14="http://schemas.microsoft.com/office/powerpoint/2010/main" val="330917845"/>
+      </p:ext>
+    </p:extLst>
+  </p:cSld>
+</p:sld>
+</file>
+
+<file path=ppt/slides/slide8.xml><?xml version="1.0" encoding="utf-8"?>
+<p:sld xmlns:p="http://schemas.openxmlformats.org/presentationml/2006/main">
+  <p:cSld>
+    <p:bg>
+      <p:bgPr>
+        <a:solidFill xmlns:a="http://schemas.openxmlformats.org/drawingml/2006/main">
+          <a:srgbClr val="F5F0E6"/>
+        </a:solidFill>
+      </p:bgPr>
+    </p:bg>
+    <p:spTree>
+      <p:nvGrpSpPr>
+        <p:cNvPr id="1" name=""/>
+        <p:cNvGrpSpPr/>
+        <p:nvPr/>
+      </p:nvGrpSpPr>
+      <p:grpSpPr>
+        <a:xfrm xmlns:a="http://schemas.openxmlformats.org/drawingml/2006/main"/>
+      </p:grpSpPr>
+      <p:sp>
+        <p:nvSpPr>
+          <p:cNvPr id="6" name="">
+            <a:extLst xmlns:a="http://schemas.openxmlformats.org/drawingml/2006/main">
+              <a:ext uri="{FF2B5EF4-FFF2-40B4-BE49-F238E27FC236}">
+                <a16:creationId xmlns:a16="http://schemas.microsoft.com/office/drawing/2014/main" id="{2594AFAD-CBE8-4A40-AB7A-BD2807E73C05}"/>
               </a:ext>
             </a:extLst>
           </p:cNvPr>
@@ -6826,7 +7514,7 @@
           <p:cNvPr id="2" name="">
             <a:extLst xmlns:a="http://schemas.openxmlformats.org/drawingml/2006/main">
               <a:ext uri="{FF2B5EF4-FFF2-40B4-BE49-F238E27FC236}">
-                <a16:creationId xmlns:a16="http://schemas.microsoft.com/office/drawing/2014/main" id="{94C8A294-5801-4C2E-9398-D3F368720787}"/>
+                <a16:creationId xmlns:a16="http://schemas.microsoft.com/office/drawing/2014/main" id="{C5AE3397-D16E-4218-AB94-0B1446F8800E}"/>
               </a:ext>
             </a:extLst>
           </p:cNvPr>
@@ -6915,7 +7603,7 @@
           <p:cNvPr id="3" name="">
             <a:extLst xmlns:a="http://schemas.openxmlformats.org/drawingml/2006/main">
               <a:ext uri="{FF2B5EF4-FFF2-40B4-BE49-F238E27FC236}">
-                <a16:creationId xmlns:a16="http://schemas.microsoft.com/office/drawing/2014/main" id="{5F10C5A6-72A2-4500-8C2D-A6635302CEEA}"/>
+                <a16:creationId xmlns:a16="http://schemas.microsoft.com/office/drawing/2014/main" id="{B95F8904-7A02-4408-93FB-01A6B3832F60}"/>
               </a:ext>
             </a:extLst>
           </p:cNvPr>
@@ -6981,7 +7669,7 @@
           <p:cNvPr id="4" name="">
             <a:extLst xmlns:a="http://schemas.openxmlformats.org/drawingml/2006/main">
               <a:ext uri="{FF2B5EF4-FFF2-40B4-BE49-F238E27FC236}">
-                <a16:creationId xmlns:a16="http://schemas.microsoft.com/office/drawing/2014/main" id="{6D23265D-A199-4432-A4F7-0BDB9A11B688}"/>
+                <a16:creationId xmlns:a16="http://schemas.microsoft.com/office/drawing/2014/main" id="{3537508C-34E0-46AA-9040-64D226651299}"/>
               </a:ext>
             </a:extLst>
           </p:cNvPr>
@@ -7036,7 +7724,7 @@
                 <a:latin typeface="Arial"/>
                 <a:ea typeface="Arial"/>
                 <a:cs typeface="Arial"/>
-                <a:hlinkClick xmlns:r="http://schemas.openxmlformats.org/officeDocument/2006/relationships" r:id="R992e7ebfccf143e0"/>
+                <a:hlinkClick xmlns:r="http://schemas.openxmlformats.org/officeDocument/2006/relationships" r:id="Re0846637a6374911"/>
               </a:rPr>
               <a:t>leej3.github.io/ai-and-ales-2026</a:t>
             </a:r>
@@ -7048,7 +7736,7 @@
           <p:cNvPr id="5" name="">
             <a:extLst xmlns:a="http://schemas.openxmlformats.org/drawingml/2006/main">
               <a:ext uri="{FF2B5EF4-FFF2-40B4-BE49-F238E27FC236}">
-                <a16:creationId xmlns:a16="http://schemas.microsoft.com/office/drawing/2014/main" id="{C59C02E6-9D54-4491-B81F-D4521E9D57A1}"/>
+                <a16:creationId xmlns:a16="http://schemas.microsoft.com/office/drawing/2014/main" id="{4AF4398C-6376-47F1-9119-3CB7D5ED9F78}"/>
               </a:ext>
             </a:extLst>
           </p:cNvPr>
@@ -7103,7 +7791,7 @@
                 <a:latin typeface="Arial"/>
                 <a:ea typeface="Arial"/>
                 <a:cs typeface="Arial"/>
-                <a:hlinkClick xmlns:r="http://schemas.openxmlformats.org/officeDocument/2006/relationships" r:id="R7912f2f727df4fa9"/>
+                <a:hlinkClick xmlns:r="http://schemas.openxmlformats.org/officeDocument/2006/relationships" r:id="R3c04847001094888"/>
               </a:rPr>
               <a:t>All links, downloads and editable source</a:t>
             </a:r>
@@ -7113,7 +7801,7 @@
     </p:spTree>
     <p:extLst>
       <p:ext uri="{BB962C8B-B14F-4D97-AF65-F5344CB8AC3E}">
-        <p14:creationId xmlns:p14="http://schemas.microsoft.com/office/powerpoint/2010/main" val="1819292043"/>
+        <p14:creationId xmlns:p14="http://schemas.microsoft.com/office/powerpoint/2010/main" val="1454460622"/>
       </p:ext>
     </p:extLst>
   </p:cSld>

</xml_diff>